<commit_message>
Re-rendered to correct the side bar
</commit_message>
<xml_diff>
--- a/figs/DIYfigures_pp.pptx
+++ b/figs/DIYfigures_pp.pptx
@@ -3282,7 +3282,7 @@
         </p:nvGrpSpPr>
         <p:grpSpPr>
           <a:xfrm>
-            <a:off x="228459" y="329892"/>
+            <a:off x="228459" y="657563"/>
             <a:ext cx="12344682" cy="8286074"/>
             <a:chOff x="228459" y="329892"/>
             <a:chExt cx="12344682" cy="8286074"/>
@@ -4571,7 +4571,7 @@
                 </a:rPr>
                 <a:t>と</a:t>
               </a:r>
-              <a:endParaRPr kumimoji="1" lang="en-US" altLang="ja-JP" sz="1400">
+              <a:endParaRPr kumimoji="1" lang="en-US" altLang="ja-JP" sz="1400" dirty="0">
                 <a:solidFill>
                   <a:schemeClr val="tx1"/>
                 </a:solidFill>

</xml_diff>

<commit_message>
Added 10/Party Competition and Cooperation
</commit_message>
<xml_diff>
--- a/figs/DIYfigures_pp.pptx
+++ b/figs/DIYfigures_pp.pptx
@@ -15,6 +15,10 @@
     <p:sldId id="265" r:id="rId9"/>
     <p:sldId id="262" r:id="rId10"/>
     <p:sldId id="263" r:id="rId11"/>
+    <p:sldId id="266" r:id="rId12"/>
+    <p:sldId id="267" r:id="rId13"/>
+    <p:sldId id="268" r:id="rId14"/>
+    <p:sldId id="269" r:id="rId15"/>
   </p:sldIdLst>
   <p:sldSz cx="12801600" cy="9601200" type="A3"/>
   <p:notesSz cx="6858000" cy="9144000"/>
@@ -252,7 +256,7 @@
           <a:p>
             <a:fld id="{DBD89380-344E-284F-BE0F-D796858BF56F}" type="datetimeFigureOut">
               <a:rPr kumimoji="1" lang="ja-JP" altLang="en-US" smtClean="0"/>
-              <a:t>2026/5/23</a:t>
+              <a:t>2026/5/29</a:t>
             </a:fld>
             <a:endParaRPr kumimoji="1" lang="ja-JP" altLang="en-US"/>
           </a:p>
@@ -454,7 +458,7 @@
           <a:p>
             <a:fld id="{DBD89380-344E-284F-BE0F-D796858BF56F}" type="datetimeFigureOut">
               <a:rPr kumimoji="1" lang="ja-JP" altLang="en-US" smtClean="0"/>
-              <a:t>2026/5/23</a:t>
+              <a:t>2026/5/29</a:t>
             </a:fld>
             <a:endParaRPr kumimoji="1" lang="ja-JP" altLang="en-US"/>
           </a:p>
@@ -666,7 +670,7 @@
           <a:p>
             <a:fld id="{DBD89380-344E-284F-BE0F-D796858BF56F}" type="datetimeFigureOut">
               <a:rPr kumimoji="1" lang="ja-JP" altLang="en-US" smtClean="0"/>
-              <a:t>2026/5/23</a:t>
+              <a:t>2026/5/29</a:t>
             </a:fld>
             <a:endParaRPr kumimoji="1" lang="ja-JP" altLang="en-US"/>
           </a:p>
@@ -868,7 +872,7 @@
           <a:p>
             <a:fld id="{DBD89380-344E-284F-BE0F-D796858BF56F}" type="datetimeFigureOut">
               <a:rPr kumimoji="1" lang="ja-JP" altLang="en-US" smtClean="0"/>
-              <a:t>2026/5/23</a:t>
+              <a:t>2026/5/29</a:t>
             </a:fld>
             <a:endParaRPr kumimoji="1" lang="ja-JP" altLang="en-US"/>
           </a:p>
@@ -1112,7 +1116,7 @@
           <a:p>
             <a:fld id="{DBD89380-344E-284F-BE0F-D796858BF56F}" type="datetimeFigureOut">
               <a:rPr kumimoji="1" lang="ja-JP" altLang="en-US" smtClean="0"/>
-              <a:t>2026/5/23</a:t>
+              <a:t>2026/5/29</a:t>
             </a:fld>
             <a:endParaRPr kumimoji="1" lang="ja-JP" altLang="en-US"/>
           </a:p>
@@ -1408,7 +1412,7 @@
           <a:p>
             <a:fld id="{DBD89380-344E-284F-BE0F-D796858BF56F}" type="datetimeFigureOut">
               <a:rPr kumimoji="1" lang="ja-JP" altLang="en-US" smtClean="0"/>
-              <a:t>2026/5/23</a:t>
+              <a:t>2026/5/29</a:t>
             </a:fld>
             <a:endParaRPr kumimoji="1" lang="ja-JP" altLang="en-US"/>
           </a:p>
@@ -1839,7 +1843,7 @@
           <a:p>
             <a:fld id="{DBD89380-344E-284F-BE0F-D796858BF56F}" type="datetimeFigureOut">
               <a:rPr kumimoji="1" lang="ja-JP" altLang="en-US" smtClean="0"/>
-              <a:t>2026/5/23</a:t>
+              <a:t>2026/5/29</a:t>
             </a:fld>
             <a:endParaRPr kumimoji="1" lang="ja-JP" altLang="en-US"/>
           </a:p>
@@ -1957,7 +1961,7 @@
           <a:p>
             <a:fld id="{DBD89380-344E-284F-BE0F-D796858BF56F}" type="datetimeFigureOut">
               <a:rPr kumimoji="1" lang="ja-JP" altLang="en-US" smtClean="0"/>
-              <a:t>2026/5/23</a:t>
+              <a:t>2026/5/29</a:t>
             </a:fld>
             <a:endParaRPr kumimoji="1" lang="ja-JP" altLang="en-US"/>
           </a:p>
@@ -2052,7 +2056,7 @@
           <a:p>
             <a:fld id="{DBD89380-344E-284F-BE0F-D796858BF56F}" type="datetimeFigureOut">
               <a:rPr kumimoji="1" lang="ja-JP" altLang="en-US" smtClean="0"/>
-              <a:t>2026/5/23</a:t>
+              <a:t>2026/5/29</a:t>
             </a:fld>
             <a:endParaRPr kumimoji="1" lang="ja-JP" altLang="en-US"/>
           </a:p>
@@ -2361,7 +2365,7 @@
           <a:p>
             <a:fld id="{DBD89380-344E-284F-BE0F-D796858BF56F}" type="datetimeFigureOut">
               <a:rPr kumimoji="1" lang="ja-JP" altLang="en-US" smtClean="0"/>
-              <a:t>2026/5/23</a:t>
+              <a:t>2026/5/29</a:t>
             </a:fld>
             <a:endParaRPr kumimoji="1" lang="ja-JP" altLang="en-US"/>
           </a:p>
@@ -2618,7 +2622,7 @@
           <a:p>
             <a:fld id="{DBD89380-344E-284F-BE0F-D796858BF56F}" type="datetimeFigureOut">
               <a:rPr kumimoji="1" lang="ja-JP" altLang="en-US" smtClean="0"/>
-              <a:t>2026/5/23</a:t>
+              <a:t>2026/5/29</a:t>
             </a:fld>
             <a:endParaRPr kumimoji="1" lang="ja-JP" altLang="en-US"/>
           </a:p>
@@ -2863,7 +2867,7 @@
           <a:p>
             <a:fld id="{DBD89380-344E-284F-BE0F-D796858BF56F}" type="datetimeFigureOut">
               <a:rPr kumimoji="1" lang="ja-JP" altLang="en-US" smtClean="0"/>
-              <a:t>2026/5/23</a:t>
+              <a:t>2026/5/29</a:t>
             </a:fld>
             <a:endParaRPr kumimoji="1" lang="ja-JP" altLang="en-US"/>
           </a:p>
@@ -8685,6 +8689,2514 @@
 </p:sld>
 </file>
 
+<file path=ppt/slides/slide11.xml><?xml version="1.0" encoding="utf-8"?>
+<p:sld xmlns:a="http://schemas.openxmlformats.org/drawingml/2006/main" xmlns:r="http://schemas.openxmlformats.org/officeDocument/2006/relationships" xmlns:p="http://schemas.openxmlformats.org/presentationml/2006/main">
+  <p:cSld>
+    <p:spTree>
+      <p:nvGrpSpPr>
+        <p:cNvPr id="1" name=""/>
+        <p:cNvGrpSpPr/>
+        <p:nvPr/>
+      </p:nvGrpSpPr>
+      <p:grpSpPr>
+        <a:xfrm>
+          <a:off x="0" y="0"/>
+          <a:ext cx="0" cy="0"/>
+          <a:chOff x="0" y="0"/>
+          <a:chExt cx="0" cy="0"/>
+        </a:xfrm>
+      </p:grpSpPr>
+      <p:grpSp>
+        <p:nvGrpSpPr>
+          <p:cNvPr id="26" name="グループ化 25">
+            <a:extLst>
+              <a:ext uri="{FF2B5EF4-FFF2-40B4-BE49-F238E27FC236}">
+                <a16:creationId xmlns:a16="http://schemas.microsoft.com/office/drawing/2014/main" id="{6C19007C-4305-2626-CEF5-58E409ED8840}"/>
+              </a:ext>
+            </a:extLst>
+          </p:cNvPr>
+          <p:cNvGrpSpPr/>
+          <p:nvPr/>
+        </p:nvGrpSpPr>
+        <p:grpSpPr>
+          <a:xfrm>
+            <a:off x="157083" y="2370162"/>
+            <a:ext cx="12508199" cy="4200379"/>
+            <a:chOff x="157083" y="2370162"/>
+            <a:chExt cx="12508199" cy="4200379"/>
+          </a:xfrm>
+        </p:grpSpPr>
+        <p:sp>
+          <p:nvSpPr>
+            <p:cNvPr id="2" name="テキスト ボックス 1">
+              <a:extLst>
+                <a:ext uri="{FF2B5EF4-FFF2-40B4-BE49-F238E27FC236}">
+                  <a16:creationId xmlns:a16="http://schemas.microsoft.com/office/drawing/2014/main" id="{39068A81-4B16-F159-93AE-1A6270F08C76}"/>
+                </a:ext>
+              </a:extLst>
+            </p:cNvPr>
+            <p:cNvSpPr txBox="1"/>
+            <p:nvPr/>
+          </p:nvSpPr>
+          <p:spPr>
+            <a:xfrm>
+              <a:off x="6876581" y="2370162"/>
+              <a:ext cx="3762531" cy="892552"/>
+            </a:xfrm>
+            <a:prstGeom prst="rect">
+              <a:avLst/>
+            </a:prstGeom>
+            <a:solidFill>
+              <a:schemeClr val="bg1"/>
+            </a:solidFill>
+            <a:ln w="25400">
+              <a:solidFill>
+                <a:schemeClr val="tx1"/>
+              </a:solidFill>
+            </a:ln>
+          </p:spPr>
+          <p:txBody>
+            <a:bodyPr wrap="square">
+              <a:spAutoFit/>
+            </a:bodyPr>
+            <a:lstStyle/>
+            <a:p>
+              <a:pPr algn="ctr"/>
+              <a:r>
+                <a:rPr kumimoji="1" lang="ja-JP" altLang="en-US" sz="3200">
+                  <a:latin typeface="Hiragino Kaku Gothic StdN W8" panose="020B0800000000000000" pitchFamily="34" charset="-128"/>
+                  <a:ea typeface="Hiragino Kaku Gothic StdN W8" panose="020B0800000000000000" pitchFamily="34" charset="-128"/>
+                </a:rPr>
+                <a:t>閣内協力</a:t>
+              </a:r>
+              <a:br>
+                <a:rPr kumimoji="1" lang="en-US" altLang="ja-JP" sz="3200" dirty="0">
+                  <a:latin typeface="Hiragino Kaku Gothic StdN W8" panose="020B0800000000000000" pitchFamily="34" charset="-128"/>
+                  <a:ea typeface="Hiragino Kaku Gothic StdN W8" panose="020B0800000000000000" pitchFamily="34" charset="-128"/>
+                </a:rPr>
+              </a:br>
+              <a:r>
+                <a:rPr kumimoji="1" lang="ja-JP" altLang="en-US" sz="2000">
+                  <a:latin typeface="Hiragino Kaku Gothic StdN W8" panose="020B0800000000000000" pitchFamily="34" charset="-128"/>
+                  <a:ea typeface="Hiragino Kaku Gothic StdN W8" panose="020B0800000000000000" pitchFamily="34" charset="-128"/>
+                </a:rPr>
+                <a:t>（連立）</a:t>
+              </a:r>
+              <a:endParaRPr lang="ja-JP" altLang="en-US" sz="3200"/>
+            </a:p>
+          </p:txBody>
+        </p:sp>
+        <p:sp>
+          <p:nvSpPr>
+            <p:cNvPr id="3" name="テキスト ボックス 2">
+              <a:extLst>
+                <a:ext uri="{FF2B5EF4-FFF2-40B4-BE49-F238E27FC236}">
+                  <a16:creationId xmlns:a16="http://schemas.microsoft.com/office/drawing/2014/main" id="{4D61D920-1766-123A-1C04-CDCD26FA48FD}"/>
+                </a:ext>
+              </a:extLst>
+            </p:cNvPr>
+            <p:cNvSpPr txBox="1"/>
+            <p:nvPr/>
+          </p:nvSpPr>
+          <p:spPr>
+            <a:xfrm>
+              <a:off x="3114050" y="2370162"/>
+              <a:ext cx="3762531" cy="892552"/>
+            </a:xfrm>
+            <a:prstGeom prst="rect">
+              <a:avLst/>
+            </a:prstGeom>
+            <a:solidFill>
+              <a:schemeClr val="bg1"/>
+            </a:solidFill>
+            <a:ln w="25400">
+              <a:solidFill>
+                <a:schemeClr val="tx1"/>
+              </a:solidFill>
+            </a:ln>
+          </p:spPr>
+          <p:txBody>
+            <a:bodyPr wrap="square">
+              <a:spAutoFit/>
+            </a:bodyPr>
+            <a:lstStyle/>
+            <a:p>
+              <a:pPr algn="ctr"/>
+              <a:r>
+                <a:rPr kumimoji="1" lang="ja-JP" altLang="en-US" sz="3200">
+                  <a:latin typeface="Hiragino Kaku Gothic StdN W8" panose="020B0800000000000000" pitchFamily="34" charset="-128"/>
+                  <a:ea typeface="Hiragino Kaku Gothic StdN W8" panose="020B0800000000000000" pitchFamily="34" charset="-128"/>
+                </a:rPr>
+                <a:t>閣外協力</a:t>
+              </a:r>
+              <a:endParaRPr kumimoji="1" lang="en-US" altLang="ja-JP" sz="3200" dirty="0">
+                <a:latin typeface="Hiragino Kaku Gothic StdN W8" panose="020B0800000000000000" pitchFamily="34" charset="-128"/>
+                <a:ea typeface="Hiragino Kaku Gothic StdN W8" panose="020B0800000000000000" pitchFamily="34" charset="-128"/>
+              </a:endParaRPr>
+            </a:p>
+            <a:p>
+              <a:pPr algn="ctr"/>
+              <a:r>
+                <a:rPr kumimoji="1" lang="en-US" altLang="ja-JP" sz="2000" dirty="0">
+                  <a:latin typeface="Hiragino Kaku Gothic StdN W8" panose="020B0800000000000000" pitchFamily="34" charset="-128"/>
+                  <a:ea typeface="Hiragino Kaku Gothic StdN W8" panose="020B0800000000000000" pitchFamily="34" charset="-128"/>
+                </a:rPr>
+                <a:t>(confidence &amp; supply)</a:t>
+              </a:r>
+              <a:endParaRPr lang="ja-JP" altLang="en-US" sz="2000"/>
+            </a:p>
+          </p:txBody>
+        </p:sp>
+        <p:sp>
+          <p:nvSpPr>
+            <p:cNvPr id="4" name="テキスト ボックス 3">
+              <a:extLst>
+                <a:ext uri="{FF2B5EF4-FFF2-40B4-BE49-F238E27FC236}">
+                  <a16:creationId xmlns:a16="http://schemas.microsoft.com/office/drawing/2014/main" id="{4C81767A-A0FF-429B-DACC-085FCFE830E2}"/>
+                </a:ext>
+              </a:extLst>
+            </p:cNvPr>
+            <p:cNvSpPr txBox="1"/>
+            <p:nvPr/>
+          </p:nvSpPr>
+          <p:spPr>
+            <a:xfrm>
+              <a:off x="157083" y="2370162"/>
+              <a:ext cx="2956967" cy="892552"/>
+            </a:xfrm>
+            <a:prstGeom prst="rect">
+              <a:avLst/>
+            </a:prstGeom>
+            <a:solidFill>
+              <a:schemeClr val="bg1"/>
+            </a:solidFill>
+            <a:ln w="25400">
+              <a:solidFill>
+                <a:schemeClr val="tx1"/>
+              </a:solidFill>
+            </a:ln>
+          </p:spPr>
+          <p:txBody>
+            <a:bodyPr wrap="square">
+              <a:spAutoFit/>
+            </a:bodyPr>
+            <a:lstStyle/>
+            <a:p>
+              <a:pPr algn="ctr"/>
+              <a:r>
+                <a:rPr kumimoji="1" lang="ja-JP" altLang="en-US" sz="3200">
+                  <a:latin typeface="Hiragino Kaku Gothic StdN W8" panose="020B0800000000000000" pitchFamily="34" charset="-128"/>
+                  <a:ea typeface="Hiragino Kaku Gothic StdN W8" panose="020B0800000000000000" pitchFamily="34" charset="-128"/>
+                </a:rPr>
+                <a:t>部分連合</a:t>
+              </a:r>
+              <a:br>
+                <a:rPr kumimoji="1" lang="en-US" altLang="ja-JP" sz="3200" dirty="0">
+                  <a:latin typeface="Hiragino Kaku Gothic StdN W8" panose="020B0800000000000000" pitchFamily="34" charset="-128"/>
+                  <a:ea typeface="Hiragino Kaku Gothic StdN W8" panose="020B0800000000000000" pitchFamily="34" charset="-128"/>
+                </a:rPr>
+              </a:br>
+              <a:r>
+                <a:rPr kumimoji="1" lang="en-US" altLang="ja-JP" sz="2000" dirty="0">
+                  <a:latin typeface="Hiragino Kaku Gothic StdN W8" panose="020B0800000000000000" pitchFamily="34" charset="-128"/>
+                  <a:ea typeface="Hiragino Kaku Gothic StdN W8" panose="020B0800000000000000" pitchFamily="34" charset="-128"/>
+                </a:rPr>
+                <a:t>(</a:t>
+              </a:r>
+              <a:r>
+                <a:rPr kumimoji="1" lang="ja-JP" altLang="en-US" sz="2000">
+                  <a:latin typeface="Hiragino Kaku Gothic StdN W8" panose="020B0800000000000000" pitchFamily="34" charset="-128"/>
+                  <a:ea typeface="Hiragino Kaku Gothic StdN W8" panose="020B0800000000000000" pitchFamily="34" charset="-128"/>
+                </a:rPr>
+                <a:t>パーシャル連合</a:t>
+              </a:r>
+              <a:r>
+                <a:rPr kumimoji="1" lang="en-US" altLang="ja-JP" sz="2000" dirty="0">
+                  <a:latin typeface="Hiragino Kaku Gothic StdN W8" panose="020B0800000000000000" pitchFamily="34" charset="-128"/>
+                  <a:ea typeface="Hiragino Kaku Gothic StdN W8" panose="020B0800000000000000" pitchFamily="34" charset="-128"/>
+                </a:rPr>
+                <a:t>)</a:t>
+              </a:r>
+              <a:endParaRPr lang="ja-JP" altLang="en-US" sz="3200"/>
+            </a:p>
+          </p:txBody>
+        </p:sp>
+        <p:sp>
+          <p:nvSpPr>
+            <p:cNvPr id="5" name="テキスト ボックス 4">
+              <a:extLst>
+                <a:ext uri="{FF2B5EF4-FFF2-40B4-BE49-F238E27FC236}">
+                  <a16:creationId xmlns:a16="http://schemas.microsoft.com/office/drawing/2014/main" id="{B858506E-44DC-E300-5FB1-C096E880AB21}"/>
+                </a:ext>
+              </a:extLst>
+            </p:cNvPr>
+            <p:cNvSpPr txBox="1"/>
+            <p:nvPr/>
+          </p:nvSpPr>
+          <p:spPr>
+            <a:xfrm>
+              <a:off x="6876581" y="4231441"/>
+              <a:ext cx="3762531" cy="584775"/>
+            </a:xfrm>
+            <a:prstGeom prst="rect">
+              <a:avLst/>
+            </a:prstGeom>
+            <a:solidFill>
+              <a:schemeClr val="bg1"/>
+            </a:solidFill>
+            <a:ln w="25400">
+              <a:solidFill>
+                <a:schemeClr val="tx1"/>
+              </a:solidFill>
+            </a:ln>
+          </p:spPr>
+          <p:txBody>
+            <a:bodyPr wrap="square">
+              <a:spAutoFit/>
+            </a:bodyPr>
+            <a:lstStyle/>
+            <a:p>
+              <a:pPr algn="ctr"/>
+              <a:r>
+                <a:rPr kumimoji="1" lang="ja-JP" altLang="en-US" sz="3200">
+                  <a:latin typeface="Hiragino Sans W4" panose="020B0400000000000000" pitchFamily="34" charset="-128"/>
+                  <a:ea typeface="Hiragino Sans W4" panose="020B0400000000000000" pitchFamily="34" charset="-128"/>
+                </a:rPr>
+                <a:t>閣僚ポストの共有</a:t>
+              </a:r>
+              <a:endParaRPr lang="ja-JP" altLang="en-US" sz="3200">
+                <a:latin typeface="Hiragino Sans W4" panose="020B0400000000000000" pitchFamily="34" charset="-128"/>
+                <a:ea typeface="Hiragino Sans W4" panose="020B0400000000000000" pitchFamily="34" charset="-128"/>
+              </a:endParaRPr>
+            </a:p>
+          </p:txBody>
+        </p:sp>
+        <p:sp>
+          <p:nvSpPr>
+            <p:cNvPr id="6" name="テキスト ボックス 5">
+              <a:extLst>
+                <a:ext uri="{FF2B5EF4-FFF2-40B4-BE49-F238E27FC236}">
+                  <a16:creationId xmlns:a16="http://schemas.microsoft.com/office/drawing/2014/main" id="{F2080C2A-8884-AE3E-7310-7F94276B45E6}"/>
+                </a:ext>
+              </a:extLst>
+            </p:cNvPr>
+            <p:cNvSpPr txBox="1"/>
+            <p:nvPr/>
+          </p:nvSpPr>
+          <p:spPr>
+            <a:xfrm>
+              <a:off x="3822492" y="4816216"/>
+              <a:ext cx="6816619" cy="584775"/>
+            </a:xfrm>
+            <a:prstGeom prst="rect">
+              <a:avLst/>
+            </a:prstGeom>
+            <a:solidFill>
+              <a:schemeClr val="bg1"/>
+            </a:solidFill>
+            <a:ln w="25400">
+              <a:solidFill>
+                <a:schemeClr val="tx1"/>
+              </a:solidFill>
+            </a:ln>
+          </p:spPr>
+          <p:txBody>
+            <a:bodyPr wrap="square">
+              <a:spAutoFit/>
+            </a:bodyPr>
+            <a:lstStyle/>
+            <a:p>
+              <a:pPr algn="ctr"/>
+              <a:r>
+                <a:rPr kumimoji="1" lang="ja-JP" altLang="en-US" sz="3200">
+                  <a:latin typeface="Hiragino Sans W4" panose="020B0400000000000000" pitchFamily="34" charset="-128"/>
+                  <a:ea typeface="Hiragino Sans W4" panose="020B0400000000000000" pitchFamily="34" charset="-128"/>
+                </a:rPr>
+                <a:t>法案採決での恒常的協力</a:t>
+              </a:r>
+              <a:r>
+                <a:rPr kumimoji="1" lang="en-US" altLang="ja-JP" sz="3200" dirty="0">
+                  <a:latin typeface="Hiragino Sans W4" panose="020B0400000000000000" pitchFamily="34" charset="-128"/>
+                  <a:ea typeface="Hiragino Sans W4" panose="020B0400000000000000" pitchFamily="34" charset="-128"/>
+                </a:rPr>
+                <a:t> (</a:t>
+              </a:r>
+              <a:r>
+                <a:rPr kumimoji="1" lang="ja-JP" altLang="en-US" sz="3200">
+                  <a:latin typeface="Hiragino Sans W4" panose="020B0400000000000000" pitchFamily="34" charset="-128"/>
+                  <a:ea typeface="Hiragino Sans W4" panose="020B0400000000000000" pitchFamily="34" charset="-128"/>
+                </a:rPr>
+                <a:t>事前審査</a:t>
+              </a:r>
+              <a:r>
+                <a:rPr kumimoji="1" lang="en-US" altLang="ja-JP" sz="3200" dirty="0">
+                  <a:latin typeface="Hiragino Sans W4" panose="020B0400000000000000" pitchFamily="34" charset="-128"/>
+                  <a:ea typeface="Hiragino Sans W4" panose="020B0400000000000000" pitchFamily="34" charset="-128"/>
+                </a:rPr>
+                <a:t>)</a:t>
+              </a:r>
+              <a:endParaRPr lang="ja-JP" altLang="en-US" sz="3200">
+                <a:latin typeface="Hiragino Sans W4" panose="020B0400000000000000" pitchFamily="34" charset="-128"/>
+                <a:ea typeface="Hiragino Sans W4" panose="020B0400000000000000" pitchFamily="34" charset="-128"/>
+              </a:endParaRPr>
+            </a:p>
+          </p:txBody>
+        </p:sp>
+        <p:sp>
+          <p:nvSpPr>
+            <p:cNvPr id="7" name="テキスト ボックス 6">
+              <a:extLst>
+                <a:ext uri="{FF2B5EF4-FFF2-40B4-BE49-F238E27FC236}">
+                  <a16:creationId xmlns:a16="http://schemas.microsoft.com/office/drawing/2014/main" id="{F8F4E68D-1E61-BDCA-3629-F7723E656244}"/>
+                </a:ext>
+              </a:extLst>
+            </p:cNvPr>
+            <p:cNvSpPr txBox="1"/>
+            <p:nvPr/>
+          </p:nvSpPr>
+          <p:spPr>
+            <a:xfrm>
+              <a:off x="3114049" y="5400991"/>
+              <a:ext cx="7525061" cy="584775"/>
+            </a:xfrm>
+            <a:prstGeom prst="rect">
+              <a:avLst/>
+            </a:prstGeom>
+            <a:solidFill>
+              <a:schemeClr val="bg1"/>
+            </a:solidFill>
+            <a:ln w="25400">
+              <a:solidFill>
+                <a:schemeClr val="tx1"/>
+              </a:solidFill>
+            </a:ln>
+          </p:spPr>
+          <p:txBody>
+            <a:bodyPr wrap="square">
+              <a:spAutoFit/>
+            </a:bodyPr>
+            <a:lstStyle/>
+            <a:p>
+              <a:pPr algn="ctr"/>
+              <a:r>
+                <a:rPr kumimoji="1" lang="ja-JP" altLang="en-US" sz="3200">
+                  <a:latin typeface="Hiragino Sans W4" panose="020B0400000000000000" pitchFamily="34" charset="-128"/>
+                  <a:ea typeface="Hiragino Sans W4" panose="020B0400000000000000" pitchFamily="34" charset="-128"/>
+                </a:rPr>
+                <a:t>首相指名選挙での協力</a:t>
+              </a:r>
+              <a:endParaRPr lang="ja-JP" altLang="en-US" sz="3200">
+                <a:latin typeface="Hiragino Sans W4" panose="020B0400000000000000" pitchFamily="34" charset="-128"/>
+                <a:ea typeface="Hiragino Sans W4" panose="020B0400000000000000" pitchFamily="34" charset="-128"/>
+              </a:endParaRPr>
+            </a:p>
+          </p:txBody>
+        </p:sp>
+        <p:sp>
+          <p:nvSpPr>
+            <p:cNvPr id="8" name="テキスト ボックス 7">
+              <a:extLst>
+                <a:ext uri="{FF2B5EF4-FFF2-40B4-BE49-F238E27FC236}">
+                  <a16:creationId xmlns:a16="http://schemas.microsoft.com/office/drawing/2014/main" id="{8D4618CF-75F1-CC1E-92CF-87DD263695FC}"/>
+                </a:ext>
+              </a:extLst>
+            </p:cNvPr>
+            <p:cNvSpPr txBox="1"/>
+            <p:nvPr/>
+          </p:nvSpPr>
+          <p:spPr>
+            <a:xfrm>
+              <a:off x="157084" y="5985766"/>
+              <a:ext cx="10482026" cy="584775"/>
+            </a:xfrm>
+            <a:prstGeom prst="rect">
+              <a:avLst/>
+            </a:prstGeom>
+            <a:solidFill>
+              <a:schemeClr val="bg1"/>
+            </a:solidFill>
+            <a:ln w="25400">
+              <a:solidFill>
+                <a:schemeClr val="tx1"/>
+              </a:solidFill>
+            </a:ln>
+          </p:spPr>
+          <p:txBody>
+            <a:bodyPr wrap="square">
+              <a:spAutoFit/>
+            </a:bodyPr>
+            <a:lstStyle/>
+            <a:p>
+              <a:pPr algn="ctr"/>
+              <a:r>
+                <a:rPr kumimoji="1" lang="ja-JP" altLang="en-US" sz="3200">
+                  <a:latin typeface="Hiragino Sans W4" panose="020B0400000000000000" pitchFamily="34" charset="-128"/>
+                  <a:ea typeface="Hiragino Sans W4" panose="020B0400000000000000" pitchFamily="34" charset="-128"/>
+                </a:rPr>
+                <a:t>法案採決でのその都度の協力</a:t>
+              </a:r>
+              <a:endParaRPr lang="ja-JP" altLang="en-US" sz="3200">
+                <a:latin typeface="Hiragino Sans W4" panose="020B0400000000000000" pitchFamily="34" charset="-128"/>
+                <a:ea typeface="Hiragino Sans W4" panose="020B0400000000000000" pitchFamily="34" charset="-128"/>
+              </a:endParaRPr>
+            </a:p>
+          </p:txBody>
+        </p:sp>
+        <p:sp>
+          <p:nvSpPr>
+            <p:cNvPr id="9" name="テキスト ボックス 8">
+              <a:extLst>
+                <a:ext uri="{FF2B5EF4-FFF2-40B4-BE49-F238E27FC236}">
+                  <a16:creationId xmlns:a16="http://schemas.microsoft.com/office/drawing/2014/main" id="{B3003924-7F1D-25DA-D484-732855D6FF3B}"/>
+                </a:ext>
+              </a:extLst>
+            </p:cNvPr>
+            <p:cNvSpPr txBox="1"/>
+            <p:nvPr/>
+          </p:nvSpPr>
+          <p:spPr>
+            <a:xfrm>
+              <a:off x="11347554" y="4231441"/>
+              <a:ext cx="1317728" cy="584775"/>
+            </a:xfrm>
+            <a:prstGeom prst="rect">
+              <a:avLst/>
+            </a:prstGeom>
+            <a:solidFill>
+              <a:schemeClr val="bg1"/>
+            </a:solidFill>
+            <a:ln w="25400">
+              <a:solidFill>
+                <a:schemeClr val="tx1"/>
+              </a:solidFill>
+            </a:ln>
+          </p:spPr>
+          <p:txBody>
+            <a:bodyPr wrap="square">
+              <a:spAutoFit/>
+            </a:bodyPr>
+            <a:lstStyle/>
+            <a:p>
+              <a:pPr algn="ctr"/>
+              <a:r>
+                <a:rPr kumimoji="1" lang="ja-JP" altLang="en-US" sz="3200">
+                  <a:latin typeface="Hiragino Kaku Gothic StdN W8" panose="020B0800000000000000" pitchFamily="34" charset="-128"/>
+                  <a:ea typeface="Hiragino Kaku Gothic StdN W8" panose="020B0800000000000000" pitchFamily="34" charset="-128"/>
+                </a:rPr>
+                <a:t>政権</a:t>
+              </a:r>
+              <a:endParaRPr lang="ja-JP" altLang="en-US" sz="3200"/>
+            </a:p>
+          </p:txBody>
+        </p:sp>
+        <p:sp>
+          <p:nvSpPr>
+            <p:cNvPr id="10" name="テキスト ボックス 9">
+              <a:extLst>
+                <a:ext uri="{FF2B5EF4-FFF2-40B4-BE49-F238E27FC236}">
+                  <a16:creationId xmlns:a16="http://schemas.microsoft.com/office/drawing/2014/main" id="{6929AEA4-B99A-1F12-55ED-9F047D5FEE2E}"/>
+                </a:ext>
+              </a:extLst>
+            </p:cNvPr>
+            <p:cNvSpPr txBox="1"/>
+            <p:nvPr/>
+          </p:nvSpPr>
+          <p:spPr>
+            <a:xfrm>
+              <a:off x="11347553" y="5400991"/>
+              <a:ext cx="1317728" cy="584775"/>
+            </a:xfrm>
+            <a:prstGeom prst="rect">
+              <a:avLst/>
+            </a:prstGeom>
+            <a:solidFill>
+              <a:schemeClr val="bg1"/>
+            </a:solidFill>
+            <a:ln w="25400">
+              <a:solidFill>
+                <a:schemeClr val="tx1"/>
+              </a:solidFill>
+            </a:ln>
+          </p:spPr>
+          <p:txBody>
+            <a:bodyPr wrap="square">
+              <a:spAutoFit/>
+            </a:bodyPr>
+            <a:lstStyle/>
+            <a:p>
+              <a:pPr algn="ctr"/>
+              <a:r>
+                <a:rPr kumimoji="1" lang="ja-JP" altLang="en-US" sz="3200">
+                  <a:latin typeface="Hiragino Kaku Gothic StdN W8" panose="020B0800000000000000" pitchFamily="34" charset="-128"/>
+                  <a:ea typeface="Hiragino Kaku Gothic StdN W8" panose="020B0800000000000000" pitchFamily="34" charset="-128"/>
+                </a:rPr>
+                <a:t>国会</a:t>
+              </a:r>
+              <a:endParaRPr lang="ja-JP" altLang="en-US" sz="3200"/>
+            </a:p>
+          </p:txBody>
+        </p:sp>
+        <p:cxnSp>
+          <p:nvCxnSpPr>
+            <p:cNvPr id="12" name="直線コネクタ 11">
+              <a:extLst>
+                <a:ext uri="{FF2B5EF4-FFF2-40B4-BE49-F238E27FC236}">
+                  <a16:creationId xmlns:a16="http://schemas.microsoft.com/office/drawing/2014/main" id="{5BFBE178-C7C8-F64F-3028-BD44D4CA1FB8}"/>
+                </a:ext>
+              </a:extLst>
+            </p:cNvPr>
+            <p:cNvCxnSpPr>
+              <a:stCxn id="9" idx="1"/>
+              <a:endCxn id="5" idx="3"/>
+            </p:cNvCxnSpPr>
+            <p:nvPr/>
+          </p:nvCxnSpPr>
+          <p:spPr>
+            <a:xfrm flipH="1">
+              <a:off x="10639112" y="4523829"/>
+              <a:ext cx="708442" cy="0"/>
+            </a:xfrm>
+            <a:prstGeom prst="line">
+              <a:avLst/>
+            </a:prstGeom>
+            <a:ln w="19050">
+              <a:solidFill>
+                <a:schemeClr val="tx1"/>
+              </a:solidFill>
+            </a:ln>
+          </p:spPr>
+          <p:style>
+            <a:lnRef idx="1">
+              <a:schemeClr val="accent1"/>
+            </a:lnRef>
+            <a:fillRef idx="0">
+              <a:schemeClr val="accent1"/>
+            </a:fillRef>
+            <a:effectRef idx="0">
+              <a:schemeClr val="accent1"/>
+            </a:effectRef>
+            <a:fontRef idx="minor">
+              <a:schemeClr val="tx1"/>
+            </a:fontRef>
+          </p:style>
+        </p:cxnSp>
+        <p:cxnSp>
+          <p:nvCxnSpPr>
+            <p:cNvPr id="13" name="直線コネクタ 12">
+              <a:extLst>
+                <a:ext uri="{FF2B5EF4-FFF2-40B4-BE49-F238E27FC236}">
+                  <a16:creationId xmlns:a16="http://schemas.microsoft.com/office/drawing/2014/main" id="{13E34BF8-78D1-2D79-DD40-89C30F8085F2}"/>
+                </a:ext>
+              </a:extLst>
+            </p:cNvPr>
+            <p:cNvCxnSpPr>
+              <a:cxnSpLocks/>
+              <a:stCxn id="9" idx="1"/>
+              <a:endCxn id="7" idx="3"/>
+            </p:cNvCxnSpPr>
+            <p:nvPr/>
+          </p:nvCxnSpPr>
+          <p:spPr>
+            <a:xfrm flipH="1">
+              <a:off x="10639110" y="4523829"/>
+              <a:ext cx="708444" cy="1169550"/>
+            </a:xfrm>
+            <a:prstGeom prst="line">
+              <a:avLst/>
+            </a:prstGeom>
+            <a:ln w="19050">
+              <a:solidFill>
+                <a:schemeClr val="tx1"/>
+              </a:solidFill>
+            </a:ln>
+          </p:spPr>
+          <p:style>
+            <a:lnRef idx="1">
+              <a:schemeClr val="accent1"/>
+            </a:lnRef>
+            <a:fillRef idx="0">
+              <a:schemeClr val="accent1"/>
+            </a:fillRef>
+            <a:effectRef idx="0">
+              <a:schemeClr val="accent1"/>
+            </a:effectRef>
+            <a:fontRef idx="minor">
+              <a:schemeClr val="tx1"/>
+            </a:fontRef>
+          </p:style>
+        </p:cxnSp>
+        <p:cxnSp>
+          <p:nvCxnSpPr>
+            <p:cNvPr id="16" name="直線コネクタ 15">
+              <a:extLst>
+                <a:ext uri="{FF2B5EF4-FFF2-40B4-BE49-F238E27FC236}">
+                  <a16:creationId xmlns:a16="http://schemas.microsoft.com/office/drawing/2014/main" id="{BC45DE0E-BC62-63E8-FA86-21B5DE4731F9}"/>
+                </a:ext>
+              </a:extLst>
+            </p:cNvPr>
+            <p:cNvCxnSpPr>
+              <a:cxnSpLocks/>
+              <a:stCxn id="10" idx="1"/>
+              <a:endCxn id="6" idx="3"/>
+            </p:cNvCxnSpPr>
+            <p:nvPr/>
+          </p:nvCxnSpPr>
+          <p:spPr>
+            <a:xfrm flipH="1" flipV="1">
+              <a:off x="10639111" y="5108604"/>
+              <a:ext cx="708442" cy="584775"/>
+            </a:xfrm>
+            <a:prstGeom prst="line">
+              <a:avLst/>
+            </a:prstGeom>
+            <a:ln w="19050">
+              <a:solidFill>
+                <a:schemeClr val="tx1"/>
+              </a:solidFill>
+            </a:ln>
+          </p:spPr>
+          <p:style>
+            <a:lnRef idx="1">
+              <a:schemeClr val="accent1"/>
+            </a:lnRef>
+            <a:fillRef idx="0">
+              <a:schemeClr val="accent1"/>
+            </a:fillRef>
+            <a:effectRef idx="0">
+              <a:schemeClr val="accent1"/>
+            </a:effectRef>
+            <a:fontRef idx="minor">
+              <a:schemeClr val="tx1"/>
+            </a:fontRef>
+          </p:style>
+        </p:cxnSp>
+        <p:cxnSp>
+          <p:nvCxnSpPr>
+            <p:cNvPr id="19" name="直線コネクタ 18">
+              <a:extLst>
+                <a:ext uri="{FF2B5EF4-FFF2-40B4-BE49-F238E27FC236}">
+                  <a16:creationId xmlns:a16="http://schemas.microsoft.com/office/drawing/2014/main" id="{D61E57DA-AE9D-766C-B214-10E9B2451208}"/>
+                </a:ext>
+              </a:extLst>
+            </p:cNvPr>
+            <p:cNvCxnSpPr>
+              <a:cxnSpLocks/>
+              <a:stCxn id="10" idx="1"/>
+              <a:endCxn id="7" idx="3"/>
+            </p:cNvCxnSpPr>
+            <p:nvPr/>
+          </p:nvCxnSpPr>
+          <p:spPr>
+            <a:xfrm flipH="1">
+              <a:off x="10639110" y="5693379"/>
+              <a:ext cx="708443" cy="0"/>
+            </a:xfrm>
+            <a:prstGeom prst="line">
+              <a:avLst/>
+            </a:prstGeom>
+            <a:ln w="19050">
+              <a:solidFill>
+                <a:schemeClr val="tx1"/>
+              </a:solidFill>
+            </a:ln>
+          </p:spPr>
+          <p:style>
+            <a:lnRef idx="1">
+              <a:schemeClr val="accent1"/>
+            </a:lnRef>
+            <a:fillRef idx="0">
+              <a:schemeClr val="accent1"/>
+            </a:fillRef>
+            <a:effectRef idx="0">
+              <a:schemeClr val="accent1"/>
+            </a:effectRef>
+            <a:fontRef idx="minor">
+              <a:schemeClr val="tx1"/>
+            </a:fontRef>
+          </p:style>
+        </p:cxnSp>
+        <p:cxnSp>
+          <p:nvCxnSpPr>
+            <p:cNvPr id="23" name="直線コネクタ 22">
+              <a:extLst>
+                <a:ext uri="{FF2B5EF4-FFF2-40B4-BE49-F238E27FC236}">
+                  <a16:creationId xmlns:a16="http://schemas.microsoft.com/office/drawing/2014/main" id="{DE54C75F-C8C2-C45C-195E-8A44E8DDDEC8}"/>
+                </a:ext>
+              </a:extLst>
+            </p:cNvPr>
+            <p:cNvCxnSpPr>
+              <a:cxnSpLocks/>
+              <a:stCxn id="10" idx="1"/>
+              <a:endCxn id="8" idx="3"/>
+            </p:cNvCxnSpPr>
+            <p:nvPr/>
+          </p:nvCxnSpPr>
+          <p:spPr>
+            <a:xfrm flipH="1">
+              <a:off x="10639110" y="5693379"/>
+              <a:ext cx="708443" cy="584775"/>
+            </a:xfrm>
+            <a:prstGeom prst="line">
+              <a:avLst/>
+            </a:prstGeom>
+            <a:ln w="19050">
+              <a:solidFill>
+                <a:schemeClr val="tx1"/>
+              </a:solidFill>
+            </a:ln>
+          </p:spPr>
+          <p:style>
+            <a:lnRef idx="1">
+              <a:schemeClr val="accent1"/>
+            </a:lnRef>
+            <a:fillRef idx="0">
+              <a:schemeClr val="accent1"/>
+            </a:fillRef>
+            <a:effectRef idx="0">
+              <a:schemeClr val="accent1"/>
+            </a:effectRef>
+            <a:fontRef idx="minor">
+              <a:schemeClr val="tx1"/>
+            </a:fontRef>
+          </p:style>
+        </p:cxnSp>
+      </p:grpSp>
+    </p:spTree>
+    <p:extLst>
+      <p:ext uri="{BB962C8B-B14F-4D97-AF65-F5344CB8AC3E}">
+        <p14:creationId xmlns:p14="http://schemas.microsoft.com/office/powerpoint/2010/main" val="811957124"/>
+      </p:ext>
+    </p:extLst>
+  </p:cSld>
+  <p:clrMapOvr>
+    <a:masterClrMapping/>
+  </p:clrMapOvr>
+</p:sld>
+</file>
+
+<file path=ppt/slides/slide12.xml><?xml version="1.0" encoding="utf-8"?>
+<p:sld xmlns:a="http://schemas.openxmlformats.org/drawingml/2006/main" xmlns:r="http://schemas.openxmlformats.org/officeDocument/2006/relationships" xmlns:p="http://schemas.openxmlformats.org/presentationml/2006/main">
+  <p:cSld>
+    <p:spTree>
+      <p:nvGrpSpPr>
+        <p:cNvPr id="1" name=""/>
+        <p:cNvGrpSpPr/>
+        <p:nvPr/>
+      </p:nvGrpSpPr>
+      <p:grpSpPr>
+        <a:xfrm>
+          <a:off x="0" y="0"/>
+          <a:ext cx="0" cy="0"/>
+          <a:chOff x="0" y="0"/>
+          <a:chExt cx="0" cy="0"/>
+        </a:xfrm>
+      </p:grpSpPr>
+      <p:grpSp>
+        <p:nvGrpSpPr>
+          <p:cNvPr id="41" name="グループ化 40">
+            <a:extLst>
+              <a:ext uri="{FF2B5EF4-FFF2-40B4-BE49-F238E27FC236}">
+                <a16:creationId xmlns:a16="http://schemas.microsoft.com/office/drawing/2014/main" id="{0AC263B6-3684-6200-85D3-AED9CD034748}"/>
+              </a:ext>
+            </a:extLst>
+          </p:cNvPr>
+          <p:cNvGrpSpPr/>
+          <p:nvPr/>
+        </p:nvGrpSpPr>
+        <p:grpSpPr>
+          <a:xfrm>
+            <a:off x="479208" y="657973"/>
+            <a:ext cx="12147158" cy="7191134"/>
+            <a:chOff x="479208" y="657973"/>
+            <a:chExt cx="12147158" cy="7191134"/>
+          </a:xfrm>
+        </p:grpSpPr>
+        <p:pic>
+          <p:nvPicPr>
+            <p:cNvPr id="2050" name="Picture 2">
+              <a:extLst>
+                <a:ext uri="{FF2B5EF4-FFF2-40B4-BE49-F238E27FC236}">
+                  <a16:creationId xmlns:a16="http://schemas.microsoft.com/office/drawing/2014/main" id="{228C3C54-CC6D-F0D0-0AA1-9E4F571D1878}"/>
+                </a:ext>
+              </a:extLst>
+            </p:cNvPr>
+            <p:cNvPicPr>
+              <a:picLocks noChangeAspect="1" noChangeArrowheads="1"/>
+            </p:cNvPicPr>
+            <p:nvPr/>
+          </p:nvPicPr>
+          <p:blipFill>
+            <a:blip r:embed="rId2">
+              <a:extLst>
+                <a:ext uri="{28A0092B-C50C-407E-A947-70E740481C1C}">
+                  <a14:useLocalDpi xmlns:a14="http://schemas.microsoft.com/office/drawing/2010/main" val="0"/>
+                </a:ext>
+              </a:extLst>
+            </a:blip>
+            <a:srcRect/>
+            <a:stretch>
+              <a:fillRect/>
+            </a:stretch>
+          </p:blipFill>
+          <p:spPr bwMode="auto">
+            <a:xfrm>
+              <a:off x="3048598" y="1319135"/>
+              <a:ext cx="2208080" cy="2713219"/>
+            </a:xfrm>
+            <a:prstGeom prst="rect">
+              <a:avLst/>
+            </a:prstGeom>
+            <a:noFill/>
+            <a:extLst>
+              <a:ext uri="{909E8E84-426E-40DD-AFC4-6F175D3DCCD1}">
+                <a14:hiddenFill xmlns:a14="http://schemas.microsoft.com/office/drawing/2010/main">
+                  <a:solidFill>
+                    <a:srgbClr val="FFFFFF"/>
+                  </a:solidFill>
+                </a14:hiddenFill>
+              </a:ext>
+            </a:extLst>
+          </p:spPr>
+        </p:pic>
+        <p:pic>
+          <p:nvPicPr>
+            <p:cNvPr id="2" name="Picture 2">
+              <a:extLst>
+                <a:ext uri="{FF2B5EF4-FFF2-40B4-BE49-F238E27FC236}">
+                  <a16:creationId xmlns:a16="http://schemas.microsoft.com/office/drawing/2014/main" id="{CEB100D0-8D99-8C49-4BD9-848E6CCB751A}"/>
+                </a:ext>
+              </a:extLst>
+            </p:cNvPr>
+            <p:cNvPicPr>
+              <a:picLocks noChangeAspect="1" noChangeArrowheads="1"/>
+            </p:cNvPicPr>
+            <p:nvPr/>
+          </p:nvPicPr>
+          <p:blipFill>
+            <a:blip r:embed="rId2">
+              <a:extLst>
+                <a:ext uri="{28A0092B-C50C-407E-A947-70E740481C1C}">
+                  <a14:useLocalDpi xmlns:a14="http://schemas.microsoft.com/office/drawing/2010/main" val="0"/>
+                </a:ext>
+              </a:extLst>
+            </a:blip>
+            <a:srcRect/>
+            <a:stretch>
+              <a:fillRect/>
+            </a:stretch>
+          </p:blipFill>
+          <p:spPr bwMode="auto">
+            <a:xfrm>
+              <a:off x="7545287" y="1319135"/>
+              <a:ext cx="2208080" cy="2713219"/>
+            </a:xfrm>
+            <a:prstGeom prst="rect">
+              <a:avLst/>
+            </a:prstGeom>
+            <a:noFill/>
+            <a:extLst>
+              <a:ext uri="{909E8E84-426E-40DD-AFC4-6F175D3DCCD1}">
+                <a14:hiddenFill xmlns:a14="http://schemas.microsoft.com/office/drawing/2010/main">
+                  <a:solidFill>
+                    <a:srgbClr val="FFFFFF"/>
+                  </a:solidFill>
+                </a14:hiddenFill>
+              </a:ext>
+            </a:extLst>
+          </p:spPr>
+        </p:pic>
+        <p:pic>
+          <p:nvPicPr>
+            <p:cNvPr id="2054" name="Picture 6">
+              <a:extLst>
+                <a:ext uri="{FF2B5EF4-FFF2-40B4-BE49-F238E27FC236}">
+                  <a16:creationId xmlns:a16="http://schemas.microsoft.com/office/drawing/2014/main" id="{E1849215-7B0B-C2AA-4519-DD1B1A946E54}"/>
+                </a:ext>
+              </a:extLst>
+            </p:cNvPr>
+            <p:cNvPicPr>
+              <a:picLocks noChangeAspect="1" noChangeArrowheads="1"/>
+            </p:cNvPicPr>
+            <p:nvPr/>
+          </p:nvPicPr>
+          <p:blipFill>
+            <a:blip r:embed="rId3">
+              <a:extLst>
+                <a:ext uri="{28A0092B-C50C-407E-A947-70E740481C1C}">
+                  <a14:useLocalDpi xmlns:a14="http://schemas.microsoft.com/office/drawing/2010/main" val="0"/>
+                </a:ext>
+              </a:extLst>
+            </a:blip>
+            <a:srcRect/>
+            <a:stretch>
+              <a:fillRect/>
+            </a:stretch>
+          </p:blipFill>
+          <p:spPr bwMode="auto">
+            <a:xfrm>
+              <a:off x="479208" y="5568847"/>
+              <a:ext cx="1003887" cy="1341621"/>
+            </a:xfrm>
+            <a:prstGeom prst="rect">
+              <a:avLst/>
+            </a:prstGeom>
+            <a:noFill/>
+            <a:extLst>
+              <a:ext uri="{909E8E84-426E-40DD-AFC4-6F175D3DCCD1}">
+                <a14:hiddenFill xmlns:a14="http://schemas.microsoft.com/office/drawing/2010/main">
+                  <a:solidFill>
+                    <a:srgbClr val="FFFFFF"/>
+                  </a:solidFill>
+                </a14:hiddenFill>
+              </a:ext>
+            </a:extLst>
+          </p:spPr>
+        </p:pic>
+        <p:pic>
+          <p:nvPicPr>
+            <p:cNvPr id="3" name="Picture 6">
+              <a:extLst>
+                <a:ext uri="{FF2B5EF4-FFF2-40B4-BE49-F238E27FC236}">
+                  <a16:creationId xmlns:a16="http://schemas.microsoft.com/office/drawing/2014/main" id="{52AFC797-3A97-063C-E9A8-080C3351174B}"/>
+                </a:ext>
+              </a:extLst>
+            </p:cNvPr>
+            <p:cNvPicPr>
+              <a:picLocks noChangeAspect="1" noChangeArrowheads="1"/>
+            </p:cNvPicPr>
+            <p:nvPr/>
+          </p:nvPicPr>
+          <p:blipFill>
+            <a:blip r:embed="rId3">
+              <a:extLst>
+                <a:ext uri="{28A0092B-C50C-407E-A947-70E740481C1C}">
+                  <a14:useLocalDpi xmlns:a14="http://schemas.microsoft.com/office/drawing/2010/main" val="0"/>
+                </a:ext>
+              </a:extLst>
+            </a:blip>
+            <a:srcRect/>
+            <a:stretch>
+              <a:fillRect/>
+            </a:stretch>
+          </p:blipFill>
+          <p:spPr bwMode="auto">
+            <a:xfrm>
+              <a:off x="1718302" y="5568847"/>
+              <a:ext cx="1003887" cy="1341621"/>
+            </a:xfrm>
+            <a:prstGeom prst="rect">
+              <a:avLst/>
+            </a:prstGeom>
+            <a:noFill/>
+            <a:extLst>
+              <a:ext uri="{909E8E84-426E-40DD-AFC4-6F175D3DCCD1}">
+                <a14:hiddenFill xmlns:a14="http://schemas.microsoft.com/office/drawing/2010/main">
+                  <a:solidFill>
+                    <a:srgbClr val="FFFFFF"/>
+                  </a:solidFill>
+                </a14:hiddenFill>
+              </a:ext>
+            </a:extLst>
+          </p:spPr>
+        </p:pic>
+        <p:pic>
+          <p:nvPicPr>
+            <p:cNvPr id="4" name="Picture 6">
+              <a:extLst>
+                <a:ext uri="{FF2B5EF4-FFF2-40B4-BE49-F238E27FC236}">
+                  <a16:creationId xmlns:a16="http://schemas.microsoft.com/office/drawing/2014/main" id="{B61D0E87-851F-5D4D-E9AE-95AA97D3DAFC}"/>
+                </a:ext>
+              </a:extLst>
+            </p:cNvPr>
+            <p:cNvPicPr>
+              <a:picLocks noChangeAspect="1" noChangeArrowheads="1"/>
+            </p:cNvPicPr>
+            <p:nvPr/>
+          </p:nvPicPr>
+          <p:blipFill>
+            <a:blip r:embed="rId3">
+              <a:extLst>
+                <a:ext uri="{28A0092B-C50C-407E-A947-70E740481C1C}">
+                  <a14:useLocalDpi xmlns:a14="http://schemas.microsoft.com/office/drawing/2010/main" val="0"/>
+                </a:ext>
+              </a:extLst>
+            </a:blip>
+            <a:srcRect/>
+            <a:stretch>
+              <a:fillRect/>
+            </a:stretch>
+          </p:blipFill>
+          <p:spPr bwMode="auto">
+            <a:xfrm>
+              <a:off x="2957396" y="5568847"/>
+              <a:ext cx="1003887" cy="1341621"/>
+            </a:xfrm>
+            <a:prstGeom prst="rect">
+              <a:avLst/>
+            </a:prstGeom>
+            <a:noFill/>
+            <a:extLst>
+              <a:ext uri="{909E8E84-426E-40DD-AFC4-6F175D3DCCD1}">
+                <a14:hiddenFill xmlns:a14="http://schemas.microsoft.com/office/drawing/2010/main">
+                  <a:solidFill>
+                    <a:srgbClr val="FFFFFF"/>
+                  </a:solidFill>
+                </a14:hiddenFill>
+              </a:ext>
+            </a:extLst>
+          </p:spPr>
+        </p:pic>
+        <p:pic>
+          <p:nvPicPr>
+            <p:cNvPr id="5" name="Picture 6">
+              <a:extLst>
+                <a:ext uri="{FF2B5EF4-FFF2-40B4-BE49-F238E27FC236}">
+                  <a16:creationId xmlns:a16="http://schemas.microsoft.com/office/drawing/2014/main" id="{27C16DED-A29D-3BDC-C8DC-5048C36F84D0}"/>
+                </a:ext>
+              </a:extLst>
+            </p:cNvPr>
+            <p:cNvPicPr>
+              <a:picLocks noChangeAspect="1" noChangeArrowheads="1"/>
+            </p:cNvPicPr>
+            <p:nvPr/>
+          </p:nvPicPr>
+          <p:blipFill>
+            <a:blip r:embed="rId3">
+              <a:extLst>
+                <a:ext uri="{28A0092B-C50C-407E-A947-70E740481C1C}">
+                  <a14:useLocalDpi xmlns:a14="http://schemas.microsoft.com/office/drawing/2010/main" val="0"/>
+                </a:ext>
+              </a:extLst>
+            </a:blip>
+            <a:srcRect/>
+            <a:stretch>
+              <a:fillRect/>
+            </a:stretch>
+          </p:blipFill>
+          <p:spPr bwMode="auto">
+            <a:xfrm>
+              <a:off x="5432154" y="5568847"/>
+              <a:ext cx="1003887" cy="1341621"/>
+            </a:xfrm>
+            <a:prstGeom prst="rect">
+              <a:avLst/>
+            </a:prstGeom>
+            <a:noFill/>
+            <a:extLst>
+              <a:ext uri="{909E8E84-426E-40DD-AFC4-6F175D3DCCD1}">
+                <a14:hiddenFill xmlns:a14="http://schemas.microsoft.com/office/drawing/2010/main">
+                  <a:solidFill>
+                    <a:srgbClr val="FFFFFF"/>
+                  </a:solidFill>
+                </a14:hiddenFill>
+              </a:ext>
+            </a:extLst>
+          </p:spPr>
+        </p:pic>
+        <p:pic>
+          <p:nvPicPr>
+            <p:cNvPr id="10" name="Picture 6">
+              <a:extLst>
+                <a:ext uri="{FF2B5EF4-FFF2-40B4-BE49-F238E27FC236}">
+                  <a16:creationId xmlns:a16="http://schemas.microsoft.com/office/drawing/2014/main" id="{3E34EE4E-49F5-9AC0-A42A-00015AB709B5}"/>
+                </a:ext>
+              </a:extLst>
+            </p:cNvPr>
+            <p:cNvPicPr>
+              <a:picLocks noChangeAspect="1" noChangeArrowheads="1"/>
+            </p:cNvPicPr>
+            <p:nvPr/>
+          </p:nvPicPr>
+          <p:blipFill>
+            <a:blip r:embed="rId3">
+              <a:extLst>
+                <a:ext uri="{28A0092B-C50C-407E-A947-70E740481C1C}">
+                  <a14:useLocalDpi xmlns:a14="http://schemas.microsoft.com/office/drawing/2010/main" val="0"/>
+                </a:ext>
+              </a:extLst>
+            </a:blip>
+            <a:srcRect/>
+            <a:stretch>
+              <a:fillRect/>
+            </a:stretch>
+          </p:blipFill>
+          <p:spPr bwMode="auto">
+            <a:xfrm>
+              <a:off x="4194775" y="5568847"/>
+              <a:ext cx="1003887" cy="1341621"/>
+            </a:xfrm>
+            <a:prstGeom prst="rect">
+              <a:avLst/>
+            </a:prstGeom>
+            <a:noFill/>
+            <a:extLst>
+              <a:ext uri="{909E8E84-426E-40DD-AFC4-6F175D3DCCD1}">
+                <a14:hiddenFill xmlns:a14="http://schemas.microsoft.com/office/drawing/2010/main">
+                  <a:solidFill>
+                    <a:srgbClr val="FFFFFF"/>
+                  </a:solidFill>
+                </a14:hiddenFill>
+              </a:ext>
+            </a:extLst>
+          </p:spPr>
+        </p:pic>
+        <p:pic>
+          <p:nvPicPr>
+            <p:cNvPr id="12" name="Picture 6">
+              <a:extLst>
+                <a:ext uri="{FF2B5EF4-FFF2-40B4-BE49-F238E27FC236}">
+                  <a16:creationId xmlns:a16="http://schemas.microsoft.com/office/drawing/2014/main" id="{E5BBBF1B-F3E3-0A33-F2A7-6EA12AF08951}"/>
+                </a:ext>
+              </a:extLst>
+            </p:cNvPr>
+            <p:cNvPicPr>
+              <a:picLocks noChangeAspect="1" noChangeArrowheads="1"/>
+            </p:cNvPicPr>
+            <p:nvPr/>
+          </p:nvPicPr>
+          <p:blipFill>
+            <a:blip r:embed="rId3">
+              <a:extLst>
+                <a:ext uri="{28A0092B-C50C-407E-A947-70E740481C1C}">
+                  <a14:useLocalDpi xmlns:a14="http://schemas.microsoft.com/office/drawing/2010/main" val="0"/>
+                </a:ext>
+              </a:extLst>
+            </a:blip>
+            <a:srcRect/>
+            <a:stretch>
+              <a:fillRect/>
+            </a:stretch>
+          </p:blipFill>
+          <p:spPr bwMode="auto">
+            <a:xfrm>
+              <a:off x="6669533" y="5568847"/>
+              <a:ext cx="1003887" cy="1341621"/>
+            </a:xfrm>
+            <a:prstGeom prst="rect">
+              <a:avLst/>
+            </a:prstGeom>
+            <a:noFill/>
+            <a:extLst>
+              <a:ext uri="{909E8E84-426E-40DD-AFC4-6F175D3DCCD1}">
+                <a14:hiddenFill xmlns:a14="http://schemas.microsoft.com/office/drawing/2010/main">
+                  <a:solidFill>
+                    <a:srgbClr val="FFFFFF"/>
+                  </a:solidFill>
+                </a14:hiddenFill>
+              </a:ext>
+            </a:extLst>
+          </p:spPr>
+        </p:pic>
+        <p:pic>
+          <p:nvPicPr>
+            <p:cNvPr id="13" name="Picture 6">
+              <a:extLst>
+                <a:ext uri="{FF2B5EF4-FFF2-40B4-BE49-F238E27FC236}">
+                  <a16:creationId xmlns:a16="http://schemas.microsoft.com/office/drawing/2014/main" id="{267914E7-9638-A9DB-1D9E-8BC286EEBC6C}"/>
+                </a:ext>
+              </a:extLst>
+            </p:cNvPr>
+            <p:cNvPicPr>
+              <a:picLocks noChangeAspect="1" noChangeArrowheads="1"/>
+            </p:cNvPicPr>
+            <p:nvPr/>
+          </p:nvPicPr>
+          <p:blipFill>
+            <a:blip r:embed="rId3">
+              <a:extLst>
+                <a:ext uri="{28A0092B-C50C-407E-A947-70E740481C1C}">
+                  <a14:useLocalDpi xmlns:a14="http://schemas.microsoft.com/office/drawing/2010/main" val="0"/>
+                </a:ext>
+              </a:extLst>
+            </a:blip>
+            <a:srcRect/>
+            <a:stretch>
+              <a:fillRect/>
+            </a:stretch>
+          </p:blipFill>
+          <p:spPr bwMode="auto">
+            <a:xfrm>
+              <a:off x="7908627" y="5568847"/>
+              <a:ext cx="1003887" cy="1341621"/>
+            </a:xfrm>
+            <a:prstGeom prst="rect">
+              <a:avLst/>
+            </a:prstGeom>
+            <a:noFill/>
+            <a:extLst>
+              <a:ext uri="{909E8E84-426E-40DD-AFC4-6F175D3DCCD1}">
+                <a14:hiddenFill xmlns:a14="http://schemas.microsoft.com/office/drawing/2010/main">
+                  <a:solidFill>
+                    <a:srgbClr val="FFFFFF"/>
+                  </a:solidFill>
+                </a14:hiddenFill>
+              </a:ext>
+            </a:extLst>
+          </p:spPr>
+        </p:pic>
+        <p:pic>
+          <p:nvPicPr>
+            <p:cNvPr id="14" name="Picture 6">
+              <a:extLst>
+                <a:ext uri="{FF2B5EF4-FFF2-40B4-BE49-F238E27FC236}">
+                  <a16:creationId xmlns:a16="http://schemas.microsoft.com/office/drawing/2014/main" id="{8D879106-8945-17D0-ABC5-E0F642478CFF}"/>
+                </a:ext>
+              </a:extLst>
+            </p:cNvPr>
+            <p:cNvPicPr>
+              <a:picLocks noChangeAspect="1" noChangeArrowheads="1"/>
+            </p:cNvPicPr>
+            <p:nvPr/>
+          </p:nvPicPr>
+          <p:blipFill>
+            <a:blip r:embed="rId3">
+              <a:extLst>
+                <a:ext uri="{28A0092B-C50C-407E-A947-70E740481C1C}">
+                  <a14:useLocalDpi xmlns:a14="http://schemas.microsoft.com/office/drawing/2010/main" val="0"/>
+                </a:ext>
+              </a:extLst>
+            </a:blip>
+            <a:srcRect/>
+            <a:stretch>
+              <a:fillRect/>
+            </a:stretch>
+          </p:blipFill>
+          <p:spPr bwMode="auto">
+            <a:xfrm>
+              <a:off x="9147721" y="5568847"/>
+              <a:ext cx="1003887" cy="1341621"/>
+            </a:xfrm>
+            <a:prstGeom prst="rect">
+              <a:avLst/>
+            </a:prstGeom>
+            <a:noFill/>
+            <a:extLst>
+              <a:ext uri="{909E8E84-426E-40DD-AFC4-6F175D3DCCD1}">
+                <a14:hiddenFill xmlns:a14="http://schemas.microsoft.com/office/drawing/2010/main">
+                  <a:solidFill>
+                    <a:srgbClr val="FFFFFF"/>
+                  </a:solidFill>
+                </a14:hiddenFill>
+              </a:ext>
+            </a:extLst>
+          </p:spPr>
+        </p:pic>
+        <p:pic>
+          <p:nvPicPr>
+            <p:cNvPr id="15" name="Picture 6">
+              <a:extLst>
+                <a:ext uri="{FF2B5EF4-FFF2-40B4-BE49-F238E27FC236}">
+                  <a16:creationId xmlns:a16="http://schemas.microsoft.com/office/drawing/2014/main" id="{35808691-AA5C-0620-2867-5EDFFC0C1431}"/>
+                </a:ext>
+              </a:extLst>
+            </p:cNvPr>
+            <p:cNvPicPr>
+              <a:picLocks noChangeAspect="1" noChangeArrowheads="1"/>
+            </p:cNvPicPr>
+            <p:nvPr/>
+          </p:nvPicPr>
+          <p:blipFill>
+            <a:blip r:embed="rId3">
+              <a:extLst>
+                <a:ext uri="{28A0092B-C50C-407E-A947-70E740481C1C}">
+                  <a14:useLocalDpi xmlns:a14="http://schemas.microsoft.com/office/drawing/2010/main" val="0"/>
+                </a:ext>
+              </a:extLst>
+            </a:blip>
+            <a:srcRect/>
+            <a:stretch>
+              <a:fillRect/>
+            </a:stretch>
+          </p:blipFill>
+          <p:spPr bwMode="auto">
+            <a:xfrm>
+              <a:off x="11622479" y="5568847"/>
+              <a:ext cx="1003887" cy="1341621"/>
+            </a:xfrm>
+            <a:prstGeom prst="rect">
+              <a:avLst/>
+            </a:prstGeom>
+            <a:noFill/>
+            <a:extLst>
+              <a:ext uri="{909E8E84-426E-40DD-AFC4-6F175D3DCCD1}">
+                <a14:hiddenFill xmlns:a14="http://schemas.microsoft.com/office/drawing/2010/main">
+                  <a:solidFill>
+                    <a:srgbClr val="FFFFFF"/>
+                  </a:solidFill>
+                </a14:hiddenFill>
+              </a:ext>
+            </a:extLst>
+          </p:spPr>
+        </p:pic>
+        <p:pic>
+          <p:nvPicPr>
+            <p:cNvPr id="16" name="Picture 6">
+              <a:extLst>
+                <a:ext uri="{FF2B5EF4-FFF2-40B4-BE49-F238E27FC236}">
+                  <a16:creationId xmlns:a16="http://schemas.microsoft.com/office/drawing/2014/main" id="{508E804F-D151-03D0-6A9B-2DAEB08B6278}"/>
+                </a:ext>
+              </a:extLst>
+            </p:cNvPr>
+            <p:cNvPicPr>
+              <a:picLocks noChangeAspect="1" noChangeArrowheads="1"/>
+            </p:cNvPicPr>
+            <p:nvPr/>
+          </p:nvPicPr>
+          <p:blipFill>
+            <a:blip r:embed="rId3">
+              <a:extLst>
+                <a:ext uri="{28A0092B-C50C-407E-A947-70E740481C1C}">
+                  <a14:useLocalDpi xmlns:a14="http://schemas.microsoft.com/office/drawing/2010/main" val="0"/>
+                </a:ext>
+              </a:extLst>
+            </a:blip>
+            <a:srcRect/>
+            <a:stretch>
+              <a:fillRect/>
+            </a:stretch>
+          </p:blipFill>
+          <p:spPr bwMode="auto">
+            <a:xfrm>
+              <a:off x="10385100" y="5568847"/>
+              <a:ext cx="1003887" cy="1341621"/>
+            </a:xfrm>
+            <a:prstGeom prst="rect">
+              <a:avLst/>
+            </a:prstGeom>
+            <a:noFill/>
+            <a:extLst>
+              <a:ext uri="{909E8E84-426E-40DD-AFC4-6F175D3DCCD1}">
+                <a14:hiddenFill xmlns:a14="http://schemas.microsoft.com/office/drawing/2010/main">
+                  <a:solidFill>
+                    <a:srgbClr val="FFFFFF"/>
+                  </a:solidFill>
+                </a14:hiddenFill>
+              </a:ext>
+            </a:extLst>
+          </p:spPr>
+        </p:pic>
+        <p:sp>
+          <p:nvSpPr>
+            <p:cNvPr id="17" name="テキスト ボックス 16">
+              <a:extLst>
+                <a:ext uri="{FF2B5EF4-FFF2-40B4-BE49-F238E27FC236}">
+                  <a16:creationId xmlns:a16="http://schemas.microsoft.com/office/drawing/2014/main" id="{7CACA07B-45E4-AE05-30CD-5CD80E9EB62C}"/>
+                </a:ext>
+              </a:extLst>
+            </p:cNvPr>
+            <p:cNvSpPr txBox="1"/>
+            <p:nvPr/>
+          </p:nvSpPr>
+          <p:spPr>
+            <a:xfrm>
+              <a:off x="2488367" y="4293963"/>
+              <a:ext cx="683527" cy="646331"/>
+            </a:xfrm>
+            <a:prstGeom prst="rect">
+              <a:avLst/>
+            </a:prstGeom>
+            <a:noFill/>
+          </p:spPr>
+          <p:txBody>
+            <a:bodyPr wrap="square" rtlCol="0">
+              <a:spAutoFit/>
+            </a:bodyPr>
+            <a:lstStyle/>
+            <a:p>
+              <a:pPr algn="ctr"/>
+              <a:r>
+                <a:rPr kumimoji="1" lang="en-US" altLang="ja-JP" sz="3600" dirty="0">
+                  <a:latin typeface="Hiragino Kaku Gothic StdN W8" panose="020B0800000000000000" pitchFamily="34" charset="-128"/>
+                  <a:ea typeface="Hiragino Kaku Gothic StdN W8" panose="020B0800000000000000" pitchFamily="34" charset="-128"/>
+                </a:rPr>
+                <a:t>A</a:t>
+              </a:r>
+              <a:endParaRPr kumimoji="1" lang="ja-JP" altLang="en-US">
+                <a:latin typeface="Hiragino Kaku Gothic StdN W8" panose="020B0800000000000000" pitchFamily="34" charset="-128"/>
+                <a:ea typeface="Hiragino Kaku Gothic StdN W8" panose="020B0800000000000000" pitchFamily="34" charset="-128"/>
+              </a:endParaRPr>
+            </a:p>
+          </p:txBody>
+        </p:sp>
+        <p:sp>
+          <p:nvSpPr>
+            <p:cNvPr id="20" name="テキスト ボックス 19">
+              <a:extLst>
+                <a:ext uri="{FF2B5EF4-FFF2-40B4-BE49-F238E27FC236}">
+                  <a16:creationId xmlns:a16="http://schemas.microsoft.com/office/drawing/2014/main" id="{152C9801-B997-CABD-EE3B-647217C29EFD}"/>
+                </a:ext>
+              </a:extLst>
+            </p:cNvPr>
+            <p:cNvSpPr txBox="1"/>
+            <p:nvPr/>
+          </p:nvSpPr>
+          <p:spPr>
+            <a:xfrm>
+              <a:off x="6327769" y="4293962"/>
+              <a:ext cx="683527" cy="646331"/>
+            </a:xfrm>
+            <a:prstGeom prst="rect">
+              <a:avLst/>
+            </a:prstGeom>
+            <a:noFill/>
+          </p:spPr>
+          <p:txBody>
+            <a:bodyPr wrap="square" rtlCol="0">
+              <a:spAutoFit/>
+            </a:bodyPr>
+            <a:lstStyle/>
+            <a:p>
+              <a:pPr algn="ctr"/>
+              <a:r>
+                <a:rPr kumimoji="1" lang="en-US" altLang="ja-JP" sz="3600" dirty="0">
+                  <a:latin typeface="Hiragino Kaku Gothic StdN W8" panose="020B0800000000000000" pitchFamily="34" charset="-128"/>
+                  <a:ea typeface="Hiragino Kaku Gothic StdN W8" panose="020B0800000000000000" pitchFamily="34" charset="-128"/>
+                </a:rPr>
+                <a:t>B</a:t>
+              </a:r>
+              <a:endParaRPr kumimoji="1" lang="ja-JP" altLang="en-US">
+                <a:latin typeface="Hiragino Kaku Gothic StdN W8" panose="020B0800000000000000" pitchFamily="34" charset="-128"/>
+                <a:ea typeface="Hiragino Kaku Gothic StdN W8" panose="020B0800000000000000" pitchFamily="34" charset="-128"/>
+              </a:endParaRPr>
+            </a:p>
+          </p:txBody>
+        </p:sp>
+        <p:sp>
+          <p:nvSpPr>
+            <p:cNvPr id="21" name="テキスト ボックス 20">
+              <a:extLst>
+                <a:ext uri="{FF2B5EF4-FFF2-40B4-BE49-F238E27FC236}">
+                  <a16:creationId xmlns:a16="http://schemas.microsoft.com/office/drawing/2014/main" id="{975D02A5-9A74-C674-15CC-BE70535F865D}"/>
+                </a:ext>
+              </a:extLst>
+            </p:cNvPr>
+            <p:cNvSpPr txBox="1"/>
+            <p:nvPr/>
+          </p:nvSpPr>
+          <p:spPr>
+            <a:xfrm>
+              <a:off x="9971469" y="4293962"/>
+              <a:ext cx="683527" cy="646331"/>
+            </a:xfrm>
+            <a:prstGeom prst="rect">
+              <a:avLst/>
+            </a:prstGeom>
+            <a:noFill/>
+          </p:spPr>
+          <p:txBody>
+            <a:bodyPr wrap="square" rtlCol="0">
+              <a:spAutoFit/>
+            </a:bodyPr>
+            <a:lstStyle/>
+            <a:p>
+              <a:pPr algn="ctr"/>
+              <a:r>
+                <a:rPr kumimoji="1" lang="en-US" altLang="ja-JP" sz="3600" dirty="0">
+                  <a:latin typeface="Hiragino Kaku Gothic StdN W8" panose="020B0800000000000000" pitchFamily="34" charset="-128"/>
+                  <a:ea typeface="Hiragino Kaku Gothic StdN W8" panose="020B0800000000000000" pitchFamily="34" charset="-128"/>
+                </a:rPr>
+                <a:t>C</a:t>
+              </a:r>
+              <a:endParaRPr kumimoji="1" lang="ja-JP" altLang="en-US">
+                <a:latin typeface="Hiragino Kaku Gothic StdN W8" panose="020B0800000000000000" pitchFamily="34" charset="-128"/>
+                <a:ea typeface="Hiragino Kaku Gothic StdN W8" panose="020B0800000000000000" pitchFamily="34" charset="-128"/>
+              </a:endParaRPr>
+            </a:p>
+          </p:txBody>
+        </p:sp>
+        <p:cxnSp>
+          <p:nvCxnSpPr>
+            <p:cNvPr id="22" name="直線矢印コネクタ 21">
+              <a:extLst>
+                <a:ext uri="{FF2B5EF4-FFF2-40B4-BE49-F238E27FC236}">
+                  <a16:creationId xmlns:a16="http://schemas.microsoft.com/office/drawing/2014/main" id="{5CC6DCD8-4F15-E9EC-094D-102AEFBC1A6D}"/>
+                </a:ext>
+              </a:extLst>
+            </p:cNvPr>
+            <p:cNvCxnSpPr>
+              <a:cxnSpLocks/>
+            </p:cNvCxnSpPr>
+            <p:nvPr/>
+          </p:nvCxnSpPr>
+          <p:spPr>
+            <a:xfrm>
+              <a:off x="479208" y="5276538"/>
+              <a:ext cx="12147158" cy="0"/>
+            </a:xfrm>
+            <a:prstGeom prst="straightConnector1">
+              <a:avLst/>
+            </a:prstGeom>
+            <a:ln w="57150">
+              <a:solidFill>
+                <a:schemeClr val="tx1"/>
+              </a:solidFill>
+              <a:headEnd type="triangle"/>
+              <a:tailEnd type="triangle"/>
+            </a:ln>
+          </p:spPr>
+          <p:style>
+            <a:lnRef idx="1">
+              <a:schemeClr val="accent1"/>
+            </a:lnRef>
+            <a:fillRef idx="0">
+              <a:schemeClr val="accent1"/>
+            </a:fillRef>
+            <a:effectRef idx="0">
+              <a:schemeClr val="accent1"/>
+            </a:effectRef>
+            <a:fontRef idx="minor">
+              <a:schemeClr val="tx1"/>
+            </a:fontRef>
+          </p:style>
+        </p:cxnSp>
+        <p:sp>
+          <p:nvSpPr>
+            <p:cNvPr id="25" name="テキスト ボックス 24">
+              <a:extLst>
+                <a:ext uri="{FF2B5EF4-FFF2-40B4-BE49-F238E27FC236}">
+                  <a16:creationId xmlns:a16="http://schemas.microsoft.com/office/drawing/2014/main" id="{95B060F9-3091-39B5-BF4F-40FC7E4C49B5}"/>
+                </a:ext>
+              </a:extLst>
+            </p:cNvPr>
+            <p:cNvSpPr txBox="1"/>
+            <p:nvPr/>
+          </p:nvSpPr>
+          <p:spPr>
+            <a:xfrm>
+              <a:off x="3300194" y="734360"/>
+              <a:ext cx="1704888" cy="584775"/>
+            </a:xfrm>
+            <a:prstGeom prst="rect">
+              <a:avLst/>
+            </a:prstGeom>
+            <a:solidFill>
+              <a:schemeClr val="bg1"/>
+            </a:solidFill>
+            <a:ln w="25400">
+              <a:solidFill>
+                <a:schemeClr val="tx1"/>
+              </a:solidFill>
+            </a:ln>
+          </p:spPr>
+          <p:txBody>
+            <a:bodyPr wrap="square">
+              <a:spAutoFit/>
+            </a:bodyPr>
+            <a:lstStyle/>
+            <a:p>
+              <a:pPr algn="ctr"/>
+              <a:r>
+                <a:rPr kumimoji="1" lang="ja-JP" altLang="en-US" sz="3200">
+                  <a:latin typeface="Hiragino Kaku Gothic StdN W8" panose="020B0800000000000000" pitchFamily="34" charset="-128"/>
+                  <a:ea typeface="Hiragino Kaku Gothic StdN W8" panose="020B0800000000000000" pitchFamily="34" charset="-128"/>
+                </a:rPr>
+                <a:t>あなた</a:t>
+              </a:r>
+              <a:endParaRPr lang="ja-JP" altLang="en-US" sz="3200"/>
+            </a:p>
+          </p:txBody>
+        </p:sp>
+        <p:sp>
+          <p:nvSpPr>
+            <p:cNvPr id="26" name="テキスト ボックス 25">
+              <a:extLst>
+                <a:ext uri="{FF2B5EF4-FFF2-40B4-BE49-F238E27FC236}">
+                  <a16:creationId xmlns:a16="http://schemas.microsoft.com/office/drawing/2014/main" id="{19FD7C65-09B7-03F7-9808-B6D5E11B0A9F}"/>
+                </a:ext>
+              </a:extLst>
+            </p:cNvPr>
+            <p:cNvSpPr txBox="1"/>
+            <p:nvPr/>
+          </p:nvSpPr>
+          <p:spPr>
+            <a:xfrm>
+              <a:off x="8147745" y="657973"/>
+              <a:ext cx="1316424" cy="584775"/>
+            </a:xfrm>
+            <a:prstGeom prst="rect">
+              <a:avLst/>
+            </a:prstGeom>
+            <a:solidFill>
+              <a:schemeClr val="bg1"/>
+            </a:solidFill>
+            <a:ln w="25400">
+              <a:solidFill>
+                <a:schemeClr val="tx1"/>
+              </a:solidFill>
+            </a:ln>
+          </p:spPr>
+          <p:txBody>
+            <a:bodyPr wrap="square">
+              <a:spAutoFit/>
+            </a:bodyPr>
+            <a:lstStyle/>
+            <a:p>
+              <a:pPr algn="ctr"/>
+              <a:r>
+                <a:rPr kumimoji="1" lang="ja-JP" altLang="en-US" sz="3200">
+                  <a:latin typeface="Hiragino Kaku Gothic StdN W8" panose="020B0800000000000000" pitchFamily="34" charset="-128"/>
+                  <a:ea typeface="Hiragino Kaku Gothic StdN W8" panose="020B0800000000000000" pitchFamily="34" charset="-128"/>
+                </a:rPr>
+                <a:t>競合</a:t>
+              </a:r>
+              <a:endParaRPr lang="ja-JP" altLang="en-US" sz="3200"/>
+            </a:p>
+          </p:txBody>
+        </p:sp>
+        <p:cxnSp>
+          <p:nvCxnSpPr>
+            <p:cNvPr id="27" name="直線矢印コネクタ 26">
+              <a:extLst>
+                <a:ext uri="{FF2B5EF4-FFF2-40B4-BE49-F238E27FC236}">
+                  <a16:creationId xmlns:a16="http://schemas.microsoft.com/office/drawing/2014/main" id="{0AF6482E-F215-3675-989B-8BC3DF940C3B}"/>
+                </a:ext>
+              </a:extLst>
+            </p:cNvPr>
+            <p:cNvCxnSpPr>
+              <a:cxnSpLocks/>
+              <a:stCxn id="17" idx="2"/>
+            </p:cNvCxnSpPr>
+            <p:nvPr/>
+          </p:nvCxnSpPr>
+          <p:spPr>
+            <a:xfrm>
+              <a:off x="2830131" y="4940294"/>
+              <a:ext cx="0" cy="336244"/>
+            </a:xfrm>
+            <a:prstGeom prst="straightConnector1">
+              <a:avLst/>
+            </a:prstGeom>
+            <a:ln w="38100">
+              <a:solidFill>
+                <a:schemeClr val="tx1"/>
+              </a:solidFill>
+              <a:tailEnd type="triangle"/>
+            </a:ln>
+          </p:spPr>
+          <p:style>
+            <a:lnRef idx="1">
+              <a:schemeClr val="accent1"/>
+            </a:lnRef>
+            <a:fillRef idx="0">
+              <a:schemeClr val="accent1"/>
+            </a:fillRef>
+            <a:effectRef idx="0">
+              <a:schemeClr val="accent1"/>
+            </a:effectRef>
+            <a:fontRef idx="minor">
+              <a:schemeClr val="tx1"/>
+            </a:fontRef>
+          </p:style>
+        </p:cxnSp>
+        <p:cxnSp>
+          <p:nvCxnSpPr>
+            <p:cNvPr id="30" name="直線矢印コネクタ 29">
+              <a:extLst>
+                <a:ext uri="{FF2B5EF4-FFF2-40B4-BE49-F238E27FC236}">
+                  <a16:creationId xmlns:a16="http://schemas.microsoft.com/office/drawing/2014/main" id="{90942DFC-2376-6EF0-465A-70019976832F}"/>
+                </a:ext>
+              </a:extLst>
+            </p:cNvPr>
+            <p:cNvCxnSpPr>
+              <a:cxnSpLocks/>
+              <a:stCxn id="20" idx="2"/>
+            </p:cNvCxnSpPr>
+            <p:nvPr/>
+          </p:nvCxnSpPr>
+          <p:spPr>
+            <a:xfrm>
+              <a:off x="6669533" y="4940293"/>
+              <a:ext cx="0" cy="336245"/>
+            </a:xfrm>
+            <a:prstGeom prst="straightConnector1">
+              <a:avLst/>
+            </a:prstGeom>
+            <a:ln w="38100">
+              <a:solidFill>
+                <a:schemeClr val="tx1"/>
+              </a:solidFill>
+              <a:tailEnd type="triangle"/>
+            </a:ln>
+          </p:spPr>
+          <p:style>
+            <a:lnRef idx="1">
+              <a:schemeClr val="accent1"/>
+            </a:lnRef>
+            <a:fillRef idx="0">
+              <a:schemeClr val="accent1"/>
+            </a:fillRef>
+            <a:effectRef idx="0">
+              <a:schemeClr val="accent1"/>
+            </a:effectRef>
+            <a:fontRef idx="minor">
+              <a:schemeClr val="tx1"/>
+            </a:fontRef>
+          </p:style>
+        </p:cxnSp>
+        <p:cxnSp>
+          <p:nvCxnSpPr>
+            <p:cNvPr id="33" name="直線矢印コネクタ 32">
+              <a:extLst>
+                <a:ext uri="{FF2B5EF4-FFF2-40B4-BE49-F238E27FC236}">
+                  <a16:creationId xmlns:a16="http://schemas.microsoft.com/office/drawing/2014/main" id="{DBE3840E-DD40-2FA0-6CA1-A04A6D0A4A11}"/>
+                </a:ext>
+              </a:extLst>
+            </p:cNvPr>
+            <p:cNvCxnSpPr>
+              <a:cxnSpLocks/>
+              <a:stCxn id="21" idx="2"/>
+            </p:cNvCxnSpPr>
+            <p:nvPr/>
+          </p:nvCxnSpPr>
+          <p:spPr>
+            <a:xfrm>
+              <a:off x="10313233" y="4940293"/>
+              <a:ext cx="0" cy="336245"/>
+            </a:xfrm>
+            <a:prstGeom prst="straightConnector1">
+              <a:avLst/>
+            </a:prstGeom>
+            <a:ln w="38100">
+              <a:solidFill>
+                <a:schemeClr val="tx1"/>
+              </a:solidFill>
+              <a:tailEnd type="triangle"/>
+            </a:ln>
+          </p:spPr>
+          <p:style>
+            <a:lnRef idx="1">
+              <a:schemeClr val="accent1"/>
+            </a:lnRef>
+            <a:fillRef idx="0">
+              <a:schemeClr val="accent1"/>
+            </a:fillRef>
+            <a:effectRef idx="0">
+              <a:schemeClr val="accent1"/>
+            </a:effectRef>
+            <a:fontRef idx="minor">
+              <a:schemeClr val="tx1"/>
+            </a:fontRef>
+          </p:style>
+        </p:cxnSp>
+        <p:sp>
+          <p:nvSpPr>
+            <p:cNvPr id="40" name="テキスト ボックス 39">
+              <a:extLst>
+                <a:ext uri="{FF2B5EF4-FFF2-40B4-BE49-F238E27FC236}">
+                  <a16:creationId xmlns:a16="http://schemas.microsoft.com/office/drawing/2014/main" id="{04A42AFC-7720-6BF2-E759-8EBC99C55DD7}"/>
+                </a:ext>
+              </a:extLst>
+            </p:cNvPr>
+            <p:cNvSpPr txBox="1"/>
+            <p:nvPr/>
+          </p:nvSpPr>
+          <p:spPr>
+            <a:xfrm>
+              <a:off x="3563175" y="7202776"/>
+              <a:ext cx="6408294" cy="646331"/>
+            </a:xfrm>
+            <a:prstGeom prst="rect">
+              <a:avLst/>
+            </a:prstGeom>
+            <a:noFill/>
+          </p:spPr>
+          <p:txBody>
+            <a:bodyPr wrap="square">
+              <a:spAutoFit/>
+            </a:bodyPr>
+            <a:lstStyle/>
+            <a:p>
+              <a:pPr algn="ctr"/>
+              <a:r>
+                <a:rPr kumimoji="1" lang="en-US" altLang="ja-JP" sz="3600" dirty="0">
+                  <a:latin typeface="Hiragino Kaku Gothic StdN W8" panose="020B0800000000000000" pitchFamily="34" charset="-128"/>
+                  <a:ea typeface="Hiragino Kaku Gothic StdN W8" panose="020B0800000000000000" pitchFamily="34" charset="-128"/>
+                </a:rPr>
+                <a:t>A</a:t>
+              </a:r>
+              <a:r>
+                <a:rPr kumimoji="1" lang="ja-JP" altLang="en-US" sz="3600">
+                  <a:latin typeface="Hiragino Kaku Gothic StdN W8" panose="020B0800000000000000" pitchFamily="34" charset="-128"/>
+                  <a:ea typeface="Hiragino Kaku Gothic StdN W8" panose="020B0800000000000000" pitchFamily="34" charset="-128"/>
+                </a:rPr>
+                <a:t>・</a:t>
+              </a:r>
+              <a:r>
+                <a:rPr kumimoji="1" lang="en-US" altLang="ja-JP" sz="3600" dirty="0">
+                  <a:latin typeface="Hiragino Kaku Gothic StdN W8" panose="020B0800000000000000" pitchFamily="34" charset="-128"/>
+                  <a:ea typeface="Hiragino Kaku Gothic StdN W8" panose="020B0800000000000000" pitchFamily="34" charset="-128"/>
+                </a:rPr>
+                <a:t>B</a:t>
+              </a:r>
+              <a:r>
+                <a:rPr kumimoji="1" lang="ja-JP" altLang="en-US" sz="3600">
+                  <a:latin typeface="Hiragino Kaku Gothic StdN W8" panose="020B0800000000000000" pitchFamily="34" charset="-128"/>
+                  <a:ea typeface="Hiragino Kaku Gothic StdN W8" panose="020B0800000000000000" pitchFamily="34" charset="-128"/>
+                </a:rPr>
+                <a:t>・</a:t>
+              </a:r>
+              <a:r>
+                <a:rPr kumimoji="1" lang="en-US" altLang="ja-JP" sz="3600" dirty="0">
+                  <a:latin typeface="Hiragino Kaku Gothic StdN W8" panose="020B0800000000000000" pitchFamily="34" charset="-128"/>
+                  <a:ea typeface="Hiragino Kaku Gothic StdN W8" panose="020B0800000000000000" pitchFamily="34" charset="-128"/>
+                </a:rPr>
+                <a:t>C</a:t>
+              </a:r>
+              <a:r>
+                <a:rPr kumimoji="1" lang="ja-JP" altLang="en-US" sz="3600">
+                  <a:latin typeface="Hiragino Kaku Gothic StdN W8" panose="020B0800000000000000" pitchFamily="34" charset="-128"/>
+                  <a:ea typeface="Hiragino Kaku Gothic StdN W8" panose="020B0800000000000000" pitchFamily="34" charset="-128"/>
+                </a:rPr>
+                <a:t>どこに陣取る？</a:t>
+              </a:r>
+              <a:endParaRPr lang="ja-JP" altLang="en-US" sz="3600"/>
+            </a:p>
+          </p:txBody>
+        </p:sp>
+      </p:grpSp>
+    </p:spTree>
+    <p:extLst>
+      <p:ext uri="{BB962C8B-B14F-4D97-AF65-F5344CB8AC3E}">
+        <p14:creationId xmlns:p14="http://schemas.microsoft.com/office/powerpoint/2010/main" val="1702893411"/>
+      </p:ext>
+    </p:extLst>
+  </p:cSld>
+  <p:clrMapOvr>
+    <a:masterClrMapping/>
+  </p:clrMapOvr>
+</p:sld>
+</file>
+
+<file path=ppt/slides/slide13.xml><?xml version="1.0" encoding="utf-8"?>
+<p:sld xmlns:a="http://schemas.openxmlformats.org/drawingml/2006/main" xmlns:r="http://schemas.openxmlformats.org/officeDocument/2006/relationships" xmlns:p="http://schemas.openxmlformats.org/presentationml/2006/main">
+  <p:cSld>
+    <p:spTree>
+      <p:nvGrpSpPr>
+        <p:cNvPr id="1" name=""/>
+        <p:cNvGrpSpPr/>
+        <p:nvPr/>
+      </p:nvGrpSpPr>
+      <p:grpSpPr>
+        <a:xfrm>
+          <a:off x="0" y="0"/>
+          <a:ext cx="0" cy="0"/>
+          <a:chOff x="0" y="0"/>
+          <a:chExt cx="0" cy="0"/>
+        </a:xfrm>
+      </p:grpSpPr>
+      <p:grpSp>
+        <p:nvGrpSpPr>
+          <p:cNvPr id="20" name="グループ化 19">
+            <a:extLst>
+              <a:ext uri="{FF2B5EF4-FFF2-40B4-BE49-F238E27FC236}">
+                <a16:creationId xmlns:a16="http://schemas.microsoft.com/office/drawing/2014/main" id="{4922311C-3DFD-369F-8747-6CD998C506BE}"/>
+              </a:ext>
+            </a:extLst>
+          </p:cNvPr>
+          <p:cNvGrpSpPr/>
+          <p:nvPr/>
+        </p:nvGrpSpPr>
+        <p:grpSpPr>
+          <a:xfrm>
+            <a:off x="434237" y="1921795"/>
+            <a:ext cx="12147158" cy="6233459"/>
+            <a:chOff x="434237" y="1921795"/>
+            <a:chExt cx="12147158" cy="6233459"/>
+          </a:xfrm>
+        </p:grpSpPr>
+        <p:grpSp>
+          <p:nvGrpSpPr>
+            <p:cNvPr id="13" name="グループ化 12">
+              <a:extLst>
+                <a:ext uri="{FF2B5EF4-FFF2-40B4-BE49-F238E27FC236}">
+                  <a16:creationId xmlns:a16="http://schemas.microsoft.com/office/drawing/2014/main" id="{0134C64E-BFC1-D312-7CA3-FDC422F36642}"/>
+                </a:ext>
+              </a:extLst>
+            </p:cNvPr>
+            <p:cNvGrpSpPr/>
+            <p:nvPr/>
+          </p:nvGrpSpPr>
+          <p:grpSpPr>
+            <a:xfrm>
+              <a:off x="434237" y="1921795"/>
+              <a:ext cx="12147158" cy="5423386"/>
+              <a:chOff x="434237" y="1921795"/>
+              <a:chExt cx="12147158" cy="5423386"/>
+            </a:xfrm>
+          </p:grpSpPr>
+          <p:cxnSp>
+            <p:nvCxnSpPr>
+              <p:cNvPr id="2" name="直線矢印コネクタ 1">
+                <a:extLst>
+                  <a:ext uri="{FF2B5EF4-FFF2-40B4-BE49-F238E27FC236}">
+                    <a16:creationId xmlns:a16="http://schemas.microsoft.com/office/drawing/2014/main" id="{51800617-EADE-910C-1096-F2FEAFD62A41}"/>
+                  </a:ext>
+                </a:extLst>
+              </p:cNvPr>
+              <p:cNvCxnSpPr>
+                <a:cxnSpLocks/>
+              </p:cNvCxnSpPr>
+              <p:nvPr/>
+            </p:nvCxnSpPr>
+            <p:spPr>
+              <a:xfrm>
+                <a:off x="434237" y="7345180"/>
+                <a:ext cx="12147158" cy="0"/>
+              </a:xfrm>
+              <a:prstGeom prst="straightConnector1">
+                <a:avLst/>
+              </a:prstGeom>
+              <a:ln w="57150">
+                <a:solidFill>
+                  <a:schemeClr val="tx1"/>
+                </a:solidFill>
+                <a:headEnd type="triangle"/>
+                <a:tailEnd type="triangle"/>
+              </a:ln>
+            </p:spPr>
+            <p:style>
+              <a:lnRef idx="1">
+                <a:schemeClr val="accent1"/>
+              </a:lnRef>
+              <a:fillRef idx="0">
+                <a:schemeClr val="accent1"/>
+              </a:fillRef>
+              <a:effectRef idx="0">
+                <a:schemeClr val="accent1"/>
+              </a:effectRef>
+              <a:fontRef idx="minor">
+                <a:schemeClr val="tx1"/>
+              </a:fontRef>
+            </p:style>
+          </p:cxnSp>
+          <p:sp>
+            <p:nvSpPr>
+              <p:cNvPr id="8" name="フリーフォーム 7">
+                <a:extLst>
+                  <a:ext uri="{FF2B5EF4-FFF2-40B4-BE49-F238E27FC236}">
+                    <a16:creationId xmlns:a16="http://schemas.microsoft.com/office/drawing/2014/main" id="{A72F8354-49A4-9807-F87E-7A9461269ABA}"/>
+                  </a:ext>
+                </a:extLst>
+              </p:cNvPr>
+              <p:cNvSpPr/>
+              <p:nvPr/>
+            </p:nvSpPr>
+            <p:spPr>
+              <a:xfrm>
+                <a:off x="681925" y="1921795"/>
+                <a:ext cx="11437749" cy="5423386"/>
+              </a:xfrm>
+              <a:custGeom>
+                <a:avLst/>
+                <a:gdLst>
+                  <a:gd name="csX0" fmla="*/ 0 w 11437749"/>
+                  <a:gd name="csY0" fmla="*/ 4293030 h 4340395"/>
+                  <a:gd name="csX1" fmla="*/ 2836190 w 11437749"/>
+                  <a:gd name="csY1" fmla="*/ 3626603 h 4340395"/>
+                  <a:gd name="csX2" fmla="*/ 5718875 w 11437749"/>
+                  <a:gd name="csY2" fmla="*/ 0 h 4340395"/>
+                  <a:gd name="csX3" fmla="*/ 8632556 w 11437749"/>
+                  <a:gd name="csY3" fmla="*/ 3626603 h 4340395"/>
+                  <a:gd name="csX4" fmla="*/ 11437749 w 11437749"/>
+                  <a:gd name="csY4" fmla="*/ 4339525 h 4340395"/>
+                </a:gdLst>
+                <a:ahLst/>
+                <a:cxnLst>
+                  <a:cxn ang="0">
+                    <a:pos x="csX0" y="csY0"/>
+                  </a:cxn>
+                  <a:cxn ang="0">
+                    <a:pos x="csX1" y="csY1"/>
+                  </a:cxn>
+                  <a:cxn ang="0">
+                    <a:pos x="csX2" y="csY2"/>
+                  </a:cxn>
+                  <a:cxn ang="0">
+                    <a:pos x="csX3" y="csY3"/>
+                  </a:cxn>
+                  <a:cxn ang="0">
+                    <a:pos x="csX4" y="csY4"/>
+                  </a:cxn>
+                </a:cxnLst>
+                <a:rect l="l" t="t" r="r" b="b"/>
+                <a:pathLst>
+                  <a:path w="11437749" h="4340395">
+                    <a:moveTo>
+                      <a:pt x="0" y="4293030"/>
+                    </a:moveTo>
+                    <a:cubicBezTo>
+                      <a:pt x="941522" y="4317569"/>
+                      <a:pt x="1883044" y="4342108"/>
+                      <a:pt x="2836190" y="3626603"/>
+                    </a:cubicBezTo>
+                    <a:cubicBezTo>
+                      <a:pt x="3789336" y="2911098"/>
+                      <a:pt x="4752814" y="0"/>
+                      <a:pt x="5718875" y="0"/>
+                    </a:cubicBezTo>
+                    <a:cubicBezTo>
+                      <a:pt x="6684936" y="0"/>
+                      <a:pt x="7679410" y="2903349"/>
+                      <a:pt x="8632556" y="3626603"/>
+                    </a:cubicBezTo>
+                    <a:cubicBezTo>
+                      <a:pt x="9585702" y="4349857"/>
+                      <a:pt x="10511725" y="4344691"/>
+                      <a:pt x="11437749" y="4339525"/>
+                    </a:cubicBezTo>
+                  </a:path>
+                </a:pathLst>
+              </a:custGeom>
+              <a:noFill/>
+              <a:ln w="57150"/>
+            </p:spPr>
+            <p:style>
+              <a:lnRef idx="2">
+                <a:schemeClr val="accent1">
+                  <a:shade val="15000"/>
+                </a:schemeClr>
+              </a:lnRef>
+              <a:fillRef idx="1">
+                <a:schemeClr val="accent1"/>
+              </a:fillRef>
+              <a:effectRef idx="0">
+                <a:schemeClr val="accent1"/>
+              </a:effectRef>
+              <a:fontRef idx="minor">
+                <a:schemeClr val="lt1"/>
+              </a:fontRef>
+            </p:style>
+            <p:txBody>
+              <a:bodyPr rtlCol="0" anchor="ctr"/>
+              <a:lstStyle/>
+              <a:p>
+                <a:pPr algn="ctr"/>
+                <a:endParaRPr kumimoji="1" lang="ja-JP" altLang="en-US"/>
+              </a:p>
+            </p:txBody>
+          </p:sp>
+        </p:grpSp>
+        <p:cxnSp>
+          <p:nvCxnSpPr>
+            <p:cNvPr id="10" name="直線コネクタ 9">
+              <a:extLst>
+                <a:ext uri="{FF2B5EF4-FFF2-40B4-BE49-F238E27FC236}">
+                  <a16:creationId xmlns:a16="http://schemas.microsoft.com/office/drawing/2014/main" id="{AA185AAE-CA97-83FA-0F50-D9C4E1D194AF}"/>
+                </a:ext>
+              </a:extLst>
+            </p:cNvPr>
+            <p:cNvCxnSpPr>
+              <a:stCxn id="8" idx="2"/>
+            </p:cNvCxnSpPr>
+            <p:nvPr/>
+          </p:nvCxnSpPr>
+          <p:spPr>
+            <a:xfrm>
+              <a:off x="6400800" y="1921795"/>
+              <a:ext cx="0" cy="5423385"/>
+            </a:xfrm>
+            <a:prstGeom prst="line">
+              <a:avLst/>
+            </a:prstGeom>
+            <a:ln w="12700">
+              <a:solidFill>
+                <a:schemeClr val="tx1"/>
+              </a:solidFill>
+            </a:ln>
+          </p:spPr>
+          <p:style>
+            <a:lnRef idx="1">
+              <a:schemeClr val="accent1"/>
+            </a:lnRef>
+            <a:fillRef idx="0">
+              <a:schemeClr val="accent1"/>
+            </a:fillRef>
+            <a:effectRef idx="0">
+              <a:schemeClr val="accent1"/>
+            </a:effectRef>
+            <a:fontRef idx="minor">
+              <a:schemeClr val="tx1"/>
+            </a:fontRef>
+          </p:style>
+        </p:cxnSp>
+        <p:sp>
+          <p:nvSpPr>
+            <p:cNvPr id="11" name="テキスト ボックス 10">
+              <a:extLst>
+                <a:ext uri="{FF2B5EF4-FFF2-40B4-BE49-F238E27FC236}">
+                  <a16:creationId xmlns:a16="http://schemas.microsoft.com/office/drawing/2014/main" id="{482EC1CE-7F4A-7376-37B1-0C2ABDF60562}"/>
+                </a:ext>
+              </a:extLst>
+            </p:cNvPr>
+            <p:cNvSpPr txBox="1"/>
+            <p:nvPr/>
+          </p:nvSpPr>
+          <p:spPr>
+            <a:xfrm>
+              <a:off x="6059035" y="7508923"/>
+              <a:ext cx="683527" cy="646331"/>
+            </a:xfrm>
+            <a:prstGeom prst="rect">
+              <a:avLst/>
+            </a:prstGeom>
+            <a:noFill/>
+          </p:spPr>
+          <p:txBody>
+            <a:bodyPr wrap="square" rtlCol="0">
+              <a:spAutoFit/>
+            </a:bodyPr>
+            <a:lstStyle/>
+            <a:p>
+              <a:pPr algn="ctr"/>
+              <a:r>
+                <a:rPr kumimoji="1" lang="en-US" altLang="ja-JP" sz="3600" dirty="0">
+                  <a:latin typeface="Hiragino Kaku Gothic StdN W8" panose="020B0800000000000000" pitchFamily="34" charset="-128"/>
+                  <a:ea typeface="Hiragino Kaku Gothic StdN W8" panose="020B0800000000000000" pitchFamily="34" charset="-128"/>
+                </a:rPr>
+                <a:t>M</a:t>
+              </a:r>
+              <a:endParaRPr kumimoji="1" lang="ja-JP" altLang="en-US">
+                <a:latin typeface="Hiragino Kaku Gothic StdN W8" panose="020B0800000000000000" pitchFamily="34" charset="-128"/>
+                <a:ea typeface="Hiragino Kaku Gothic StdN W8" panose="020B0800000000000000" pitchFamily="34" charset="-128"/>
+              </a:endParaRPr>
+            </a:p>
+          </p:txBody>
+        </p:sp>
+        <p:cxnSp>
+          <p:nvCxnSpPr>
+            <p:cNvPr id="14" name="直線コネクタ 13">
+              <a:extLst>
+                <a:ext uri="{FF2B5EF4-FFF2-40B4-BE49-F238E27FC236}">
+                  <a16:creationId xmlns:a16="http://schemas.microsoft.com/office/drawing/2014/main" id="{2CCB070C-C6F0-FFD9-761D-D46D1888CB5F}"/>
+                </a:ext>
+              </a:extLst>
+            </p:cNvPr>
+            <p:cNvCxnSpPr>
+              <a:cxnSpLocks/>
+            </p:cNvCxnSpPr>
+            <p:nvPr/>
+          </p:nvCxnSpPr>
+          <p:spPr>
+            <a:xfrm>
+              <a:off x="4445430" y="5005953"/>
+              <a:ext cx="0" cy="2339227"/>
+            </a:xfrm>
+            <a:prstGeom prst="line">
+              <a:avLst/>
+            </a:prstGeom>
+            <a:ln w="12700">
+              <a:solidFill>
+                <a:schemeClr val="tx1"/>
+              </a:solidFill>
+            </a:ln>
+          </p:spPr>
+          <p:style>
+            <a:lnRef idx="1">
+              <a:schemeClr val="accent1"/>
+            </a:lnRef>
+            <a:fillRef idx="0">
+              <a:schemeClr val="accent1"/>
+            </a:fillRef>
+            <a:effectRef idx="0">
+              <a:schemeClr val="accent1"/>
+            </a:effectRef>
+            <a:fontRef idx="minor">
+              <a:schemeClr val="tx1"/>
+            </a:fontRef>
+          </p:style>
+        </p:cxnSp>
+        <p:sp>
+          <p:nvSpPr>
+            <p:cNvPr id="15" name="テキスト ボックス 14">
+              <a:extLst>
+                <a:ext uri="{FF2B5EF4-FFF2-40B4-BE49-F238E27FC236}">
+                  <a16:creationId xmlns:a16="http://schemas.microsoft.com/office/drawing/2014/main" id="{5E666F30-1982-3205-48D3-4B004F0F9660}"/>
+                </a:ext>
+              </a:extLst>
+            </p:cNvPr>
+            <p:cNvSpPr txBox="1"/>
+            <p:nvPr/>
+          </p:nvSpPr>
+          <p:spPr>
+            <a:xfrm>
+              <a:off x="4103665" y="7508923"/>
+              <a:ext cx="683527" cy="646331"/>
+            </a:xfrm>
+            <a:prstGeom prst="rect">
+              <a:avLst/>
+            </a:prstGeom>
+            <a:noFill/>
+          </p:spPr>
+          <p:txBody>
+            <a:bodyPr wrap="square" rtlCol="0">
+              <a:spAutoFit/>
+            </a:bodyPr>
+            <a:lstStyle/>
+            <a:p>
+              <a:pPr algn="ctr"/>
+              <a:r>
+                <a:rPr kumimoji="1" lang="en-US" altLang="ja-JP" sz="3600" dirty="0">
+                  <a:latin typeface="Hiragino Kaku Gothic StdN W8" panose="020B0800000000000000" pitchFamily="34" charset="-128"/>
+                  <a:ea typeface="Hiragino Kaku Gothic StdN W8" panose="020B0800000000000000" pitchFamily="34" charset="-128"/>
+                </a:rPr>
+                <a:t>A</a:t>
+              </a:r>
+              <a:endParaRPr kumimoji="1" lang="ja-JP" altLang="en-US">
+                <a:latin typeface="Hiragino Kaku Gothic StdN W8" panose="020B0800000000000000" pitchFamily="34" charset="-128"/>
+                <a:ea typeface="Hiragino Kaku Gothic StdN W8" panose="020B0800000000000000" pitchFamily="34" charset="-128"/>
+              </a:endParaRPr>
+            </a:p>
+          </p:txBody>
+        </p:sp>
+        <p:cxnSp>
+          <p:nvCxnSpPr>
+            <p:cNvPr id="17" name="直線コネクタ 16">
+              <a:extLst>
+                <a:ext uri="{FF2B5EF4-FFF2-40B4-BE49-F238E27FC236}">
+                  <a16:creationId xmlns:a16="http://schemas.microsoft.com/office/drawing/2014/main" id="{D053B2A0-86FA-AD31-DC9B-689D65A1317D}"/>
+                </a:ext>
+              </a:extLst>
+            </p:cNvPr>
+            <p:cNvCxnSpPr>
+              <a:cxnSpLocks/>
+            </p:cNvCxnSpPr>
+            <p:nvPr/>
+          </p:nvCxnSpPr>
+          <p:spPr>
+            <a:xfrm>
+              <a:off x="7672643" y="3456122"/>
+              <a:ext cx="0" cy="3889058"/>
+            </a:xfrm>
+            <a:prstGeom prst="line">
+              <a:avLst/>
+            </a:prstGeom>
+            <a:ln w="12700">
+              <a:solidFill>
+                <a:schemeClr val="tx1"/>
+              </a:solidFill>
+            </a:ln>
+          </p:spPr>
+          <p:style>
+            <a:lnRef idx="1">
+              <a:schemeClr val="accent1"/>
+            </a:lnRef>
+            <a:fillRef idx="0">
+              <a:schemeClr val="accent1"/>
+            </a:fillRef>
+            <a:effectRef idx="0">
+              <a:schemeClr val="accent1"/>
+            </a:effectRef>
+            <a:fontRef idx="minor">
+              <a:schemeClr val="tx1"/>
+            </a:fontRef>
+          </p:style>
+        </p:cxnSp>
+        <p:sp>
+          <p:nvSpPr>
+            <p:cNvPr id="18" name="テキスト ボックス 17">
+              <a:extLst>
+                <a:ext uri="{FF2B5EF4-FFF2-40B4-BE49-F238E27FC236}">
+                  <a16:creationId xmlns:a16="http://schemas.microsoft.com/office/drawing/2014/main" id="{FA9AEE42-BB5E-DBE4-287B-A8C285F3C39A}"/>
+                </a:ext>
+              </a:extLst>
+            </p:cNvPr>
+            <p:cNvSpPr txBox="1"/>
+            <p:nvPr/>
+          </p:nvSpPr>
+          <p:spPr>
+            <a:xfrm>
+              <a:off x="7330878" y="7508923"/>
+              <a:ext cx="683527" cy="646331"/>
+            </a:xfrm>
+            <a:prstGeom prst="rect">
+              <a:avLst/>
+            </a:prstGeom>
+            <a:noFill/>
+          </p:spPr>
+          <p:txBody>
+            <a:bodyPr wrap="square" rtlCol="0">
+              <a:spAutoFit/>
+            </a:bodyPr>
+            <a:lstStyle/>
+            <a:p>
+              <a:pPr algn="ctr"/>
+              <a:r>
+                <a:rPr kumimoji="1" lang="en-US" altLang="ja-JP" sz="3600" dirty="0">
+                  <a:latin typeface="Hiragino Kaku Gothic StdN W8" panose="020B0800000000000000" pitchFamily="34" charset="-128"/>
+                  <a:ea typeface="Hiragino Kaku Gothic StdN W8" panose="020B0800000000000000" pitchFamily="34" charset="-128"/>
+                </a:rPr>
+                <a:t>B</a:t>
+              </a:r>
+            </a:p>
+          </p:txBody>
+        </p:sp>
+      </p:grpSp>
+    </p:spTree>
+    <p:extLst>
+      <p:ext uri="{BB962C8B-B14F-4D97-AF65-F5344CB8AC3E}">
+        <p14:creationId xmlns:p14="http://schemas.microsoft.com/office/powerpoint/2010/main" val="3101687406"/>
+      </p:ext>
+    </p:extLst>
+  </p:cSld>
+  <p:clrMapOvr>
+    <a:masterClrMapping/>
+  </p:clrMapOvr>
+</p:sld>
+</file>
+
+<file path=ppt/slides/slide14.xml><?xml version="1.0" encoding="utf-8"?>
+<p:sld xmlns:a="http://schemas.openxmlformats.org/drawingml/2006/main" xmlns:r="http://schemas.openxmlformats.org/officeDocument/2006/relationships" xmlns:p="http://schemas.openxmlformats.org/presentationml/2006/main">
+  <p:cSld>
+    <p:spTree>
+      <p:nvGrpSpPr>
+        <p:cNvPr id="1" name=""/>
+        <p:cNvGrpSpPr/>
+        <p:nvPr/>
+      </p:nvGrpSpPr>
+      <p:grpSpPr>
+        <a:xfrm>
+          <a:off x="0" y="0"/>
+          <a:ext cx="0" cy="0"/>
+          <a:chOff x="0" y="0"/>
+          <a:chExt cx="0" cy="0"/>
+        </a:xfrm>
+      </p:grpSpPr>
+      <p:grpSp>
+        <p:nvGrpSpPr>
+          <p:cNvPr id="12" name="グループ化 11">
+            <a:extLst>
+              <a:ext uri="{FF2B5EF4-FFF2-40B4-BE49-F238E27FC236}">
+                <a16:creationId xmlns:a16="http://schemas.microsoft.com/office/drawing/2014/main" id="{FD85492D-033C-EC21-02A4-0EE566667461}"/>
+              </a:ext>
+            </a:extLst>
+          </p:cNvPr>
+          <p:cNvGrpSpPr/>
+          <p:nvPr/>
+        </p:nvGrpSpPr>
+        <p:grpSpPr>
+          <a:xfrm>
+            <a:off x="4668757" y="869454"/>
+            <a:ext cx="3464087" cy="7627598"/>
+            <a:chOff x="4668757" y="869454"/>
+            <a:chExt cx="3464087" cy="7627598"/>
+          </a:xfrm>
+        </p:grpSpPr>
+        <p:pic>
+          <p:nvPicPr>
+            <p:cNvPr id="7" name="グラフィックス 6">
+              <a:extLst>
+                <a:ext uri="{FF2B5EF4-FFF2-40B4-BE49-F238E27FC236}">
+                  <a16:creationId xmlns:a16="http://schemas.microsoft.com/office/drawing/2014/main" id="{8FA6DBF5-BDA5-3F98-BDC4-193A39893A05}"/>
+                </a:ext>
+              </a:extLst>
+            </p:cNvPr>
+            <p:cNvPicPr>
+              <a:picLocks noChangeAspect="1"/>
+            </p:cNvPicPr>
+            <p:nvPr/>
+          </p:nvPicPr>
+          <p:blipFill>
+            <a:blip>
+              <a:extLst>
+                <a:ext uri="{96DAC541-7B7A-43D3-8B79-37D633B846F1}">
+                  <asvg:svgBlip xmlns:asvg="http://schemas.microsoft.com/office/drawing/2016/SVG/main" r:embed="rId2"/>
+                </a:ext>
+              </a:extLst>
+            </a:blip>
+            <a:stretch>
+              <a:fillRect/>
+            </a:stretch>
+          </p:blipFill>
+          <p:spPr>
+            <a:xfrm>
+              <a:off x="4668757" y="4558734"/>
+              <a:ext cx="3464086" cy="1625652"/>
+            </a:xfrm>
+            <a:prstGeom prst="rect">
+              <a:avLst/>
+            </a:prstGeom>
+          </p:spPr>
+        </p:pic>
+        <p:pic>
+          <p:nvPicPr>
+            <p:cNvPr id="9" name="グラフィックス 8">
+              <a:extLst>
+                <a:ext uri="{FF2B5EF4-FFF2-40B4-BE49-F238E27FC236}">
+                  <a16:creationId xmlns:a16="http://schemas.microsoft.com/office/drawing/2014/main" id="{C5DC1682-1756-69D5-CDEF-2EAB7FDFD703}"/>
+                </a:ext>
+              </a:extLst>
+            </p:cNvPr>
+            <p:cNvPicPr>
+              <a:picLocks noChangeAspect="1"/>
+            </p:cNvPicPr>
+            <p:nvPr/>
+          </p:nvPicPr>
+          <p:blipFill>
+            <a:blip>
+              <a:extLst>
+                <a:ext uri="{96DAC541-7B7A-43D3-8B79-37D633B846F1}">
+                  <asvg:svgBlip xmlns:asvg="http://schemas.microsoft.com/office/drawing/2016/SVG/main" r:embed="rId3"/>
+                </a:ext>
+              </a:extLst>
+            </a:blip>
+            <a:stretch>
+              <a:fillRect/>
+            </a:stretch>
+          </p:blipFill>
+          <p:spPr>
+            <a:xfrm>
+              <a:off x="4668757" y="869454"/>
+              <a:ext cx="3464086" cy="3464086"/>
+            </a:xfrm>
+            <a:prstGeom prst="rect">
+              <a:avLst/>
+            </a:prstGeom>
+          </p:spPr>
+        </p:pic>
+        <p:pic>
+          <p:nvPicPr>
+            <p:cNvPr id="11" name="図 10">
+              <a:extLst>
+                <a:ext uri="{FF2B5EF4-FFF2-40B4-BE49-F238E27FC236}">
+                  <a16:creationId xmlns:a16="http://schemas.microsoft.com/office/drawing/2014/main" id="{7B3259A7-8547-96D8-EB59-A7FB21BF8A51}"/>
+                </a:ext>
+              </a:extLst>
+            </p:cNvPr>
+            <p:cNvPicPr>
+              <a:picLocks noChangeAspect="1"/>
+            </p:cNvPicPr>
+            <p:nvPr/>
+          </p:nvPicPr>
+          <p:blipFill>
+            <a:blip r:embed="rId4"/>
+            <a:stretch>
+              <a:fillRect/>
+            </a:stretch>
+          </p:blipFill>
+          <p:spPr>
+            <a:xfrm>
+              <a:off x="4668758" y="6409580"/>
+              <a:ext cx="3464086" cy="2087472"/>
+            </a:xfrm>
+            <a:prstGeom prst="rect">
+              <a:avLst/>
+            </a:prstGeom>
+          </p:spPr>
+        </p:pic>
+      </p:grpSp>
+    </p:spTree>
+    <p:extLst>
+      <p:ext uri="{BB962C8B-B14F-4D97-AF65-F5344CB8AC3E}">
+        <p14:creationId xmlns:p14="http://schemas.microsoft.com/office/powerpoint/2010/main" val="652963492"/>
+      </p:ext>
+    </p:extLst>
+  </p:cSld>
+  <p:clrMapOvr>
+    <a:masterClrMapping/>
+  </p:clrMapOvr>
+</p:sld>
+</file>
+
 <file path=ppt/slides/slide2.xml><?xml version="1.0" encoding="utf-8"?>
 <p:sld xmlns:a="http://schemas.openxmlformats.org/drawingml/2006/main" xmlns:r="http://schemas.openxmlformats.org/officeDocument/2006/relationships" xmlns:p="http://schemas.openxmlformats.org/presentationml/2006/main">
   <p:cSld>

</xml_diff>

<commit_message>
Updated 10/Party Competition & Cooperation
</commit_message>
<xml_diff>
--- a/figs/DIYfigures_pp.pptx
+++ b/figs/DIYfigures_pp.pptx
@@ -21,6 +21,7 @@
     <p:sldId id="269" r:id="rId15"/>
     <p:sldId id="270" r:id="rId16"/>
     <p:sldId id="271" r:id="rId17"/>
+    <p:sldId id="272" r:id="rId18"/>
   </p:sldIdLst>
   <p:sldSz cx="12801600" cy="9601200" type="A3"/>
   <p:notesSz cx="6858000" cy="9144000"/>
@@ -258,7 +259,7 @@
           <a:p>
             <a:fld id="{DBD89380-344E-284F-BE0F-D796858BF56F}" type="datetimeFigureOut">
               <a:rPr kumimoji="1" lang="ja-JP" altLang="en-US" smtClean="0"/>
-              <a:t>2026/6/9</a:t>
+              <a:t>2026/6/15</a:t>
             </a:fld>
             <a:endParaRPr kumimoji="1" lang="ja-JP" altLang="en-US"/>
           </a:p>
@@ -460,7 +461,7 @@
           <a:p>
             <a:fld id="{DBD89380-344E-284F-BE0F-D796858BF56F}" type="datetimeFigureOut">
               <a:rPr kumimoji="1" lang="ja-JP" altLang="en-US" smtClean="0"/>
-              <a:t>2026/6/9</a:t>
+              <a:t>2026/6/15</a:t>
             </a:fld>
             <a:endParaRPr kumimoji="1" lang="ja-JP" altLang="en-US"/>
           </a:p>
@@ -672,7 +673,7 @@
           <a:p>
             <a:fld id="{DBD89380-344E-284F-BE0F-D796858BF56F}" type="datetimeFigureOut">
               <a:rPr kumimoji="1" lang="ja-JP" altLang="en-US" smtClean="0"/>
-              <a:t>2026/6/9</a:t>
+              <a:t>2026/6/15</a:t>
             </a:fld>
             <a:endParaRPr kumimoji="1" lang="ja-JP" altLang="en-US"/>
           </a:p>
@@ -874,7 +875,7 @@
           <a:p>
             <a:fld id="{DBD89380-344E-284F-BE0F-D796858BF56F}" type="datetimeFigureOut">
               <a:rPr kumimoji="1" lang="ja-JP" altLang="en-US" smtClean="0"/>
-              <a:t>2026/6/9</a:t>
+              <a:t>2026/6/15</a:t>
             </a:fld>
             <a:endParaRPr kumimoji="1" lang="ja-JP" altLang="en-US"/>
           </a:p>
@@ -1118,7 +1119,7 @@
           <a:p>
             <a:fld id="{DBD89380-344E-284F-BE0F-D796858BF56F}" type="datetimeFigureOut">
               <a:rPr kumimoji="1" lang="ja-JP" altLang="en-US" smtClean="0"/>
-              <a:t>2026/6/9</a:t>
+              <a:t>2026/6/15</a:t>
             </a:fld>
             <a:endParaRPr kumimoji="1" lang="ja-JP" altLang="en-US"/>
           </a:p>
@@ -1414,7 +1415,7 @@
           <a:p>
             <a:fld id="{DBD89380-344E-284F-BE0F-D796858BF56F}" type="datetimeFigureOut">
               <a:rPr kumimoji="1" lang="ja-JP" altLang="en-US" smtClean="0"/>
-              <a:t>2026/6/9</a:t>
+              <a:t>2026/6/15</a:t>
             </a:fld>
             <a:endParaRPr kumimoji="1" lang="ja-JP" altLang="en-US"/>
           </a:p>
@@ -1845,7 +1846,7 @@
           <a:p>
             <a:fld id="{DBD89380-344E-284F-BE0F-D796858BF56F}" type="datetimeFigureOut">
               <a:rPr kumimoji="1" lang="ja-JP" altLang="en-US" smtClean="0"/>
-              <a:t>2026/6/9</a:t>
+              <a:t>2026/6/15</a:t>
             </a:fld>
             <a:endParaRPr kumimoji="1" lang="ja-JP" altLang="en-US"/>
           </a:p>
@@ -1963,7 +1964,7 @@
           <a:p>
             <a:fld id="{DBD89380-344E-284F-BE0F-D796858BF56F}" type="datetimeFigureOut">
               <a:rPr kumimoji="1" lang="ja-JP" altLang="en-US" smtClean="0"/>
-              <a:t>2026/6/9</a:t>
+              <a:t>2026/6/15</a:t>
             </a:fld>
             <a:endParaRPr kumimoji="1" lang="ja-JP" altLang="en-US"/>
           </a:p>
@@ -2058,7 +2059,7 @@
           <a:p>
             <a:fld id="{DBD89380-344E-284F-BE0F-D796858BF56F}" type="datetimeFigureOut">
               <a:rPr kumimoji="1" lang="ja-JP" altLang="en-US" smtClean="0"/>
-              <a:t>2026/6/9</a:t>
+              <a:t>2026/6/15</a:t>
             </a:fld>
             <a:endParaRPr kumimoji="1" lang="ja-JP" altLang="en-US"/>
           </a:p>
@@ -2367,7 +2368,7 @@
           <a:p>
             <a:fld id="{DBD89380-344E-284F-BE0F-D796858BF56F}" type="datetimeFigureOut">
               <a:rPr kumimoji="1" lang="ja-JP" altLang="en-US" smtClean="0"/>
-              <a:t>2026/6/9</a:t>
+              <a:t>2026/6/15</a:t>
             </a:fld>
             <a:endParaRPr kumimoji="1" lang="ja-JP" altLang="en-US"/>
           </a:p>
@@ -2624,7 +2625,7 @@
           <a:p>
             <a:fld id="{DBD89380-344E-284F-BE0F-D796858BF56F}" type="datetimeFigureOut">
               <a:rPr kumimoji="1" lang="ja-JP" altLang="en-US" smtClean="0"/>
-              <a:t>2026/6/9</a:t>
+              <a:t>2026/6/15</a:t>
             </a:fld>
             <a:endParaRPr kumimoji="1" lang="ja-JP" altLang="en-US"/>
           </a:p>
@@ -2869,7 +2870,7 @@
           <a:p>
             <a:fld id="{DBD89380-344E-284F-BE0F-D796858BF56F}" type="datetimeFigureOut">
               <a:rPr kumimoji="1" lang="ja-JP" altLang="en-US" smtClean="0"/>
-              <a:t>2026/6/9</a:t>
+              <a:t>2026/6/15</a:t>
             </a:fld>
             <a:endParaRPr kumimoji="1" lang="ja-JP" altLang="en-US"/>
           </a:p>
@@ -11814,6 +11815,932 @@
 </p:sld>
 </file>
 
+<file path=ppt/slides/slide17.xml><?xml version="1.0" encoding="utf-8"?>
+<p:sld xmlns:a="http://schemas.openxmlformats.org/drawingml/2006/main" xmlns:r="http://schemas.openxmlformats.org/officeDocument/2006/relationships" xmlns:p="http://schemas.openxmlformats.org/presentationml/2006/main">
+  <p:cSld>
+    <p:spTree>
+      <p:nvGrpSpPr>
+        <p:cNvPr id="1" name=""/>
+        <p:cNvGrpSpPr/>
+        <p:nvPr/>
+      </p:nvGrpSpPr>
+      <p:grpSpPr>
+        <a:xfrm>
+          <a:off x="0" y="0"/>
+          <a:ext cx="0" cy="0"/>
+          <a:chOff x="0" y="0"/>
+          <a:chExt cx="0" cy="0"/>
+        </a:xfrm>
+      </p:grpSpPr>
+      <p:grpSp>
+        <p:nvGrpSpPr>
+          <p:cNvPr id="25" name="グループ化 24">
+            <a:extLst>
+              <a:ext uri="{FF2B5EF4-FFF2-40B4-BE49-F238E27FC236}">
+                <a16:creationId xmlns:a16="http://schemas.microsoft.com/office/drawing/2014/main" id="{D0D22EA7-51CA-5C92-92CD-1F24458BDEF3}"/>
+              </a:ext>
+            </a:extLst>
+          </p:cNvPr>
+          <p:cNvGrpSpPr/>
+          <p:nvPr/>
+        </p:nvGrpSpPr>
+        <p:grpSpPr>
+          <a:xfrm>
+            <a:off x="746782" y="960895"/>
+            <a:ext cx="11358208" cy="6960139"/>
+            <a:chOff x="746782" y="960895"/>
+            <a:chExt cx="11358208" cy="6960139"/>
+          </a:xfrm>
+        </p:grpSpPr>
+        <p:sp>
+          <p:nvSpPr>
+            <p:cNvPr id="2" name="角丸四角形 1">
+              <a:extLst>
+                <a:ext uri="{FF2B5EF4-FFF2-40B4-BE49-F238E27FC236}">
+                  <a16:creationId xmlns:a16="http://schemas.microsoft.com/office/drawing/2014/main" id="{5444705F-2363-561C-64FC-2623AAD874DE}"/>
+                </a:ext>
+              </a:extLst>
+            </p:cNvPr>
+            <p:cNvSpPr/>
+            <p:nvPr/>
+          </p:nvSpPr>
+          <p:spPr>
+            <a:xfrm>
+              <a:off x="4613547" y="960895"/>
+              <a:ext cx="3574506" cy="2357679"/>
+            </a:xfrm>
+            <a:prstGeom prst="roundRect">
+              <a:avLst/>
+            </a:prstGeom>
+            <a:noFill/>
+            <a:ln w="28575">
+              <a:solidFill>
+                <a:schemeClr val="tx1"/>
+              </a:solidFill>
+            </a:ln>
+          </p:spPr>
+          <p:style>
+            <a:lnRef idx="2">
+              <a:schemeClr val="accent1">
+                <a:shade val="15000"/>
+              </a:schemeClr>
+            </a:lnRef>
+            <a:fillRef idx="1">
+              <a:schemeClr val="accent1"/>
+            </a:fillRef>
+            <a:effectRef idx="0">
+              <a:schemeClr val="accent1"/>
+            </a:effectRef>
+            <a:fontRef idx="minor">
+              <a:schemeClr val="lt1"/>
+            </a:fontRef>
+          </p:style>
+          <p:txBody>
+            <a:bodyPr rtlCol="0" anchor="ctr"/>
+            <a:lstStyle/>
+            <a:p>
+              <a:pPr algn="ctr"/>
+              <a:endParaRPr kumimoji="1" lang="ja-JP" altLang="en-US"/>
+            </a:p>
+          </p:txBody>
+        </p:sp>
+        <p:sp>
+          <p:nvSpPr>
+            <p:cNvPr id="6" name="テキスト ボックス 5">
+              <a:extLst>
+                <a:ext uri="{FF2B5EF4-FFF2-40B4-BE49-F238E27FC236}">
+                  <a16:creationId xmlns:a16="http://schemas.microsoft.com/office/drawing/2014/main" id="{A6E9DF6D-031A-1971-F3D5-77096528DA75}"/>
+                </a:ext>
+              </a:extLst>
+            </p:cNvPr>
+            <p:cNvSpPr txBox="1"/>
+            <p:nvPr/>
+          </p:nvSpPr>
+          <p:spPr>
+            <a:xfrm>
+              <a:off x="5181008" y="1755013"/>
+              <a:ext cx="2439583" cy="769441"/>
+            </a:xfrm>
+            <a:prstGeom prst="rect">
+              <a:avLst/>
+            </a:prstGeom>
+            <a:noFill/>
+          </p:spPr>
+          <p:txBody>
+            <a:bodyPr wrap="square" rtlCol="0" anchor="ctr">
+              <a:spAutoFit/>
+            </a:bodyPr>
+            <a:lstStyle/>
+            <a:p>
+              <a:pPr algn="ctr"/>
+              <a:r>
+                <a:rPr kumimoji="1" lang="ja-JP" altLang="en-US" sz="4400">
+                  <a:latin typeface="Hiragino Kaku Gothic StdN W8" panose="020B0800000000000000" pitchFamily="34" charset="-128"/>
+                  <a:ea typeface="Hiragino Kaku Gothic StdN W8" panose="020B0800000000000000" pitchFamily="34" charset="-128"/>
+                </a:rPr>
+                <a:t>利益団体</a:t>
+              </a:r>
+            </a:p>
+          </p:txBody>
+        </p:sp>
+        <p:sp>
+          <p:nvSpPr>
+            <p:cNvPr id="7" name="角丸四角形 6">
+              <a:extLst>
+                <a:ext uri="{FF2B5EF4-FFF2-40B4-BE49-F238E27FC236}">
+                  <a16:creationId xmlns:a16="http://schemas.microsoft.com/office/drawing/2014/main" id="{7FA0E5B8-2E62-B7EC-423E-E5231D1C7435}"/>
+                </a:ext>
+              </a:extLst>
+            </p:cNvPr>
+            <p:cNvSpPr/>
+            <p:nvPr/>
+          </p:nvSpPr>
+          <p:spPr>
+            <a:xfrm>
+              <a:off x="1039041" y="5406326"/>
+              <a:ext cx="3574506" cy="2357679"/>
+            </a:xfrm>
+            <a:prstGeom prst="roundRect">
+              <a:avLst/>
+            </a:prstGeom>
+            <a:noFill/>
+            <a:ln w="28575">
+              <a:solidFill>
+                <a:schemeClr val="tx1"/>
+              </a:solidFill>
+            </a:ln>
+          </p:spPr>
+          <p:style>
+            <a:lnRef idx="2">
+              <a:schemeClr val="accent1">
+                <a:shade val="15000"/>
+              </a:schemeClr>
+            </a:lnRef>
+            <a:fillRef idx="1">
+              <a:schemeClr val="accent1"/>
+            </a:fillRef>
+            <a:effectRef idx="0">
+              <a:schemeClr val="accent1"/>
+            </a:effectRef>
+            <a:fontRef idx="minor">
+              <a:schemeClr val="lt1"/>
+            </a:fontRef>
+          </p:style>
+          <p:txBody>
+            <a:bodyPr rtlCol="0" anchor="ctr"/>
+            <a:lstStyle/>
+            <a:p>
+              <a:pPr algn="ctr"/>
+              <a:endParaRPr kumimoji="1" lang="ja-JP" altLang="en-US"/>
+            </a:p>
+          </p:txBody>
+        </p:sp>
+        <p:sp>
+          <p:nvSpPr>
+            <p:cNvPr id="8" name="テキスト ボックス 7">
+              <a:extLst>
+                <a:ext uri="{FF2B5EF4-FFF2-40B4-BE49-F238E27FC236}">
+                  <a16:creationId xmlns:a16="http://schemas.microsoft.com/office/drawing/2014/main" id="{CD59E102-84B0-A110-F7BC-22468A9198B8}"/>
+                </a:ext>
+              </a:extLst>
+            </p:cNvPr>
+            <p:cNvSpPr txBox="1"/>
+            <p:nvPr/>
+          </p:nvSpPr>
+          <p:spPr>
+            <a:xfrm>
+              <a:off x="1606502" y="6200444"/>
+              <a:ext cx="2439583" cy="769441"/>
+            </a:xfrm>
+            <a:prstGeom prst="rect">
+              <a:avLst/>
+            </a:prstGeom>
+            <a:noFill/>
+          </p:spPr>
+          <p:txBody>
+            <a:bodyPr wrap="square" rtlCol="0" anchor="ctr">
+              <a:spAutoFit/>
+            </a:bodyPr>
+            <a:lstStyle/>
+            <a:p>
+              <a:pPr algn="ctr"/>
+              <a:r>
+                <a:rPr kumimoji="1" lang="ja-JP" altLang="en-US" sz="4400">
+                  <a:latin typeface="Hiragino Kaku Gothic StdN W8" panose="020B0800000000000000" pitchFamily="34" charset="-128"/>
+                  <a:ea typeface="Hiragino Kaku Gothic StdN W8" panose="020B0800000000000000" pitchFamily="34" charset="-128"/>
+                </a:rPr>
+                <a:t>政治家</a:t>
+              </a:r>
+            </a:p>
+          </p:txBody>
+        </p:sp>
+        <p:sp>
+          <p:nvSpPr>
+            <p:cNvPr id="9" name="角丸四角形 8">
+              <a:extLst>
+                <a:ext uri="{FF2B5EF4-FFF2-40B4-BE49-F238E27FC236}">
+                  <a16:creationId xmlns:a16="http://schemas.microsoft.com/office/drawing/2014/main" id="{E446D13B-6BDA-A05B-FEAB-9B905FE90026}"/>
+                </a:ext>
+              </a:extLst>
+            </p:cNvPr>
+            <p:cNvSpPr/>
+            <p:nvPr/>
+          </p:nvSpPr>
+          <p:spPr>
+            <a:xfrm>
+              <a:off x="8188053" y="5406326"/>
+              <a:ext cx="3574506" cy="2357679"/>
+            </a:xfrm>
+            <a:prstGeom prst="roundRect">
+              <a:avLst/>
+            </a:prstGeom>
+            <a:noFill/>
+            <a:ln w="28575">
+              <a:solidFill>
+                <a:schemeClr val="tx1"/>
+              </a:solidFill>
+            </a:ln>
+          </p:spPr>
+          <p:style>
+            <a:lnRef idx="2">
+              <a:schemeClr val="accent1">
+                <a:shade val="15000"/>
+              </a:schemeClr>
+            </a:lnRef>
+            <a:fillRef idx="1">
+              <a:schemeClr val="accent1"/>
+            </a:fillRef>
+            <a:effectRef idx="0">
+              <a:schemeClr val="accent1"/>
+            </a:effectRef>
+            <a:fontRef idx="minor">
+              <a:schemeClr val="lt1"/>
+            </a:fontRef>
+          </p:style>
+          <p:txBody>
+            <a:bodyPr rtlCol="0" anchor="ctr"/>
+            <a:lstStyle/>
+            <a:p>
+              <a:pPr algn="ctr"/>
+              <a:endParaRPr kumimoji="1" lang="ja-JP" altLang="en-US"/>
+            </a:p>
+          </p:txBody>
+        </p:sp>
+        <p:sp>
+          <p:nvSpPr>
+            <p:cNvPr id="10" name="テキスト ボックス 9">
+              <a:extLst>
+                <a:ext uri="{FF2B5EF4-FFF2-40B4-BE49-F238E27FC236}">
+                  <a16:creationId xmlns:a16="http://schemas.microsoft.com/office/drawing/2014/main" id="{7FB546EF-7C9E-D6B2-137C-4FBE3905C785}"/>
+                </a:ext>
+              </a:extLst>
+            </p:cNvPr>
+            <p:cNvSpPr txBox="1"/>
+            <p:nvPr/>
+          </p:nvSpPr>
+          <p:spPr>
+            <a:xfrm>
+              <a:off x="8755514" y="6200444"/>
+              <a:ext cx="2439583" cy="769441"/>
+            </a:xfrm>
+            <a:prstGeom prst="rect">
+              <a:avLst/>
+            </a:prstGeom>
+            <a:noFill/>
+          </p:spPr>
+          <p:txBody>
+            <a:bodyPr wrap="square" rtlCol="0" anchor="ctr">
+              <a:spAutoFit/>
+            </a:bodyPr>
+            <a:lstStyle/>
+            <a:p>
+              <a:pPr algn="ctr"/>
+              <a:r>
+                <a:rPr kumimoji="1" lang="ja-JP" altLang="en-US" sz="4400">
+                  <a:latin typeface="Hiragino Kaku Gothic StdN W8" panose="020B0800000000000000" pitchFamily="34" charset="-128"/>
+                  <a:ea typeface="Hiragino Kaku Gothic StdN W8" panose="020B0800000000000000" pitchFamily="34" charset="-128"/>
+                </a:rPr>
+                <a:t>官僚</a:t>
+              </a:r>
+            </a:p>
+          </p:txBody>
+        </p:sp>
+        <p:sp>
+          <p:nvSpPr>
+            <p:cNvPr id="11" name="下矢印 10">
+              <a:extLst>
+                <a:ext uri="{FF2B5EF4-FFF2-40B4-BE49-F238E27FC236}">
+                  <a16:creationId xmlns:a16="http://schemas.microsoft.com/office/drawing/2014/main" id="{1CCE5B5A-1AD2-EFF1-13E5-254A8536B666}"/>
+                </a:ext>
+              </a:extLst>
+            </p:cNvPr>
+            <p:cNvSpPr/>
+            <p:nvPr/>
+          </p:nvSpPr>
+          <p:spPr>
+            <a:xfrm rot="16200000">
+              <a:off x="6230318" y="4580870"/>
+              <a:ext cx="340964" cy="2898183"/>
+            </a:xfrm>
+            <a:prstGeom prst="downArrow">
+              <a:avLst/>
+            </a:prstGeom>
+            <a:solidFill>
+              <a:schemeClr val="tx1"/>
+            </a:solidFill>
+            <a:ln>
+              <a:noFill/>
+            </a:ln>
+          </p:spPr>
+          <p:style>
+            <a:lnRef idx="2">
+              <a:schemeClr val="accent1">
+                <a:shade val="15000"/>
+              </a:schemeClr>
+            </a:lnRef>
+            <a:fillRef idx="1">
+              <a:schemeClr val="accent1"/>
+            </a:fillRef>
+            <a:effectRef idx="0">
+              <a:schemeClr val="accent1"/>
+            </a:effectRef>
+            <a:fontRef idx="minor">
+              <a:schemeClr val="lt1"/>
+            </a:fontRef>
+          </p:style>
+          <p:txBody>
+            <a:bodyPr rtlCol="0" anchor="ctr"/>
+            <a:lstStyle/>
+            <a:p>
+              <a:pPr algn="ctr"/>
+              <a:endParaRPr kumimoji="1" lang="ja-JP" altLang="en-US"/>
+            </a:p>
+          </p:txBody>
+        </p:sp>
+        <p:sp>
+          <p:nvSpPr>
+            <p:cNvPr id="12" name="下矢印 11">
+              <a:extLst>
+                <a:ext uri="{FF2B5EF4-FFF2-40B4-BE49-F238E27FC236}">
+                  <a16:creationId xmlns:a16="http://schemas.microsoft.com/office/drawing/2014/main" id="{55CA0CD9-1DC7-3559-EFB7-C8F49DE89332}"/>
+                </a:ext>
+              </a:extLst>
+            </p:cNvPr>
+            <p:cNvSpPr/>
+            <p:nvPr/>
+          </p:nvSpPr>
+          <p:spPr>
+            <a:xfrm rot="5400000">
+              <a:off x="6230316" y="5691276"/>
+              <a:ext cx="340964" cy="2898183"/>
+            </a:xfrm>
+            <a:prstGeom prst="downArrow">
+              <a:avLst/>
+            </a:prstGeom>
+            <a:solidFill>
+              <a:schemeClr val="tx1"/>
+            </a:solidFill>
+            <a:ln>
+              <a:noFill/>
+            </a:ln>
+          </p:spPr>
+          <p:style>
+            <a:lnRef idx="2">
+              <a:schemeClr val="accent1">
+                <a:shade val="15000"/>
+              </a:schemeClr>
+            </a:lnRef>
+            <a:fillRef idx="1">
+              <a:schemeClr val="accent1"/>
+            </a:fillRef>
+            <a:effectRef idx="0">
+              <a:schemeClr val="accent1"/>
+            </a:effectRef>
+            <a:fontRef idx="minor">
+              <a:schemeClr val="lt1"/>
+            </a:fontRef>
+          </p:style>
+          <p:txBody>
+            <a:bodyPr rtlCol="0" anchor="ctr"/>
+            <a:lstStyle/>
+            <a:p>
+              <a:pPr algn="ctr"/>
+              <a:endParaRPr kumimoji="1" lang="ja-JP" altLang="en-US"/>
+            </a:p>
+          </p:txBody>
+        </p:sp>
+        <p:grpSp>
+          <p:nvGrpSpPr>
+            <p:cNvPr id="15" name="グループ化 14">
+              <a:extLst>
+                <a:ext uri="{FF2B5EF4-FFF2-40B4-BE49-F238E27FC236}">
+                  <a16:creationId xmlns:a16="http://schemas.microsoft.com/office/drawing/2014/main" id="{E99B7208-9C26-596C-840F-DE7F6601286F}"/>
+                </a:ext>
+              </a:extLst>
+            </p:cNvPr>
+            <p:cNvGrpSpPr/>
+            <p:nvPr/>
+          </p:nvGrpSpPr>
+          <p:grpSpPr>
+            <a:xfrm rot="18946011">
+              <a:off x="1789026" y="3149823"/>
+              <a:ext cx="2898185" cy="1451370"/>
+              <a:chOff x="1715361" y="2648985"/>
+              <a:chExt cx="2898185" cy="1451370"/>
+            </a:xfrm>
+          </p:grpSpPr>
+          <p:sp>
+            <p:nvSpPr>
+              <p:cNvPr id="13" name="下矢印 12">
+                <a:extLst>
+                  <a:ext uri="{FF2B5EF4-FFF2-40B4-BE49-F238E27FC236}">
+                    <a16:creationId xmlns:a16="http://schemas.microsoft.com/office/drawing/2014/main" id="{EA18E6E5-13B3-BE80-A13F-ADA4F1FDDC02}"/>
+                  </a:ext>
+                </a:extLst>
+              </p:cNvPr>
+              <p:cNvSpPr/>
+              <p:nvPr/>
+            </p:nvSpPr>
+            <p:spPr>
+              <a:xfrm rot="16200000">
+                <a:off x="2993973" y="1370375"/>
+                <a:ext cx="340964" cy="2898183"/>
+              </a:xfrm>
+              <a:prstGeom prst="downArrow">
+                <a:avLst/>
+              </a:prstGeom>
+              <a:solidFill>
+                <a:schemeClr val="tx1"/>
+              </a:solidFill>
+              <a:ln>
+                <a:noFill/>
+              </a:ln>
+            </p:spPr>
+            <p:style>
+              <a:lnRef idx="2">
+                <a:schemeClr val="accent1">
+                  <a:shade val="15000"/>
+                </a:schemeClr>
+              </a:lnRef>
+              <a:fillRef idx="1">
+                <a:schemeClr val="accent1"/>
+              </a:fillRef>
+              <a:effectRef idx="0">
+                <a:schemeClr val="accent1"/>
+              </a:effectRef>
+              <a:fontRef idx="minor">
+                <a:schemeClr val="lt1"/>
+              </a:fontRef>
+            </p:style>
+            <p:txBody>
+              <a:bodyPr rtlCol="0" anchor="ctr"/>
+              <a:lstStyle/>
+              <a:p>
+                <a:pPr algn="ctr"/>
+                <a:endParaRPr kumimoji="1" lang="ja-JP" altLang="en-US"/>
+              </a:p>
+            </p:txBody>
+          </p:sp>
+          <p:sp>
+            <p:nvSpPr>
+              <p:cNvPr id="14" name="下矢印 13">
+                <a:extLst>
+                  <a:ext uri="{FF2B5EF4-FFF2-40B4-BE49-F238E27FC236}">
+                    <a16:creationId xmlns:a16="http://schemas.microsoft.com/office/drawing/2014/main" id="{330F52D8-5313-25BD-FB15-5251A8E29851}"/>
+                  </a:ext>
+                </a:extLst>
+              </p:cNvPr>
+              <p:cNvSpPr/>
+              <p:nvPr/>
+            </p:nvSpPr>
+            <p:spPr>
+              <a:xfrm rot="5400000">
+                <a:off x="2993971" y="2480781"/>
+                <a:ext cx="340964" cy="2898183"/>
+              </a:xfrm>
+              <a:prstGeom prst="downArrow">
+                <a:avLst/>
+              </a:prstGeom>
+              <a:solidFill>
+                <a:schemeClr val="tx1"/>
+              </a:solidFill>
+              <a:ln>
+                <a:noFill/>
+              </a:ln>
+            </p:spPr>
+            <p:style>
+              <a:lnRef idx="2">
+                <a:schemeClr val="accent1">
+                  <a:shade val="15000"/>
+                </a:schemeClr>
+              </a:lnRef>
+              <a:fillRef idx="1">
+                <a:schemeClr val="accent1"/>
+              </a:fillRef>
+              <a:effectRef idx="0">
+                <a:schemeClr val="accent1"/>
+              </a:effectRef>
+              <a:fontRef idx="minor">
+                <a:schemeClr val="lt1"/>
+              </a:fontRef>
+            </p:style>
+            <p:txBody>
+              <a:bodyPr rtlCol="0" anchor="ctr"/>
+              <a:lstStyle/>
+              <a:p>
+                <a:pPr algn="ctr"/>
+                <a:endParaRPr kumimoji="1" lang="ja-JP" altLang="en-US"/>
+              </a:p>
+            </p:txBody>
+          </p:sp>
+        </p:grpSp>
+        <p:grpSp>
+          <p:nvGrpSpPr>
+            <p:cNvPr id="16" name="グループ化 15">
+              <a:extLst>
+                <a:ext uri="{FF2B5EF4-FFF2-40B4-BE49-F238E27FC236}">
+                  <a16:creationId xmlns:a16="http://schemas.microsoft.com/office/drawing/2014/main" id="{7D5E2D45-F751-8ECD-D05D-F2FC3F014C8C}"/>
+                </a:ext>
+              </a:extLst>
+            </p:cNvPr>
+            <p:cNvGrpSpPr/>
+            <p:nvPr/>
+          </p:nvGrpSpPr>
+          <p:grpSpPr>
+            <a:xfrm rot="2748835">
+              <a:off x="8128519" y="3135727"/>
+              <a:ext cx="2898185" cy="1451370"/>
+              <a:chOff x="1715361" y="2648985"/>
+              <a:chExt cx="2898185" cy="1451370"/>
+            </a:xfrm>
+          </p:grpSpPr>
+          <p:sp>
+            <p:nvSpPr>
+              <p:cNvPr id="17" name="下矢印 16">
+                <a:extLst>
+                  <a:ext uri="{FF2B5EF4-FFF2-40B4-BE49-F238E27FC236}">
+                    <a16:creationId xmlns:a16="http://schemas.microsoft.com/office/drawing/2014/main" id="{BEFCFB73-255E-966C-88CD-0C407AA17A91}"/>
+                  </a:ext>
+                </a:extLst>
+              </p:cNvPr>
+              <p:cNvSpPr/>
+              <p:nvPr/>
+            </p:nvSpPr>
+            <p:spPr>
+              <a:xfrm rot="16200000">
+                <a:off x="2993973" y="1370375"/>
+                <a:ext cx="340964" cy="2898183"/>
+              </a:xfrm>
+              <a:prstGeom prst="downArrow">
+                <a:avLst/>
+              </a:prstGeom>
+              <a:solidFill>
+                <a:schemeClr val="tx1"/>
+              </a:solidFill>
+              <a:ln>
+                <a:noFill/>
+              </a:ln>
+            </p:spPr>
+            <p:style>
+              <a:lnRef idx="2">
+                <a:schemeClr val="accent1">
+                  <a:shade val="15000"/>
+                </a:schemeClr>
+              </a:lnRef>
+              <a:fillRef idx="1">
+                <a:schemeClr val="accent1"/>
+              </a:fillRef>
+              <a:effectRef idx="0">
+                <a:schemeClr val="accent1"/>
+              </a:effectRef>
+              <a:fontRef idx="minor">
+                <a:schemeClr val="lt1"/>
+              </a:fontRef>
+            </p:style>
+            <p:txBody>
+              <a:bodyPr rtlCol="0" anchor="ctr"/>
+              <a:lstStyle/>
+              <a:p>
+                <a:pPr algn="ctr"/>
+                <a:endParaRPr kumimoji="1" lang="ja-JP" altLang="en-US"/>
+              </a:p>
+            </p:txBody>
+          </p:sp>
+          <p:sp>
+            <p:nvSpPr>
+              <p:cNvPr id="18" name="下矢印 17">
+                <a:extLst>
+                  <a:ext uri="{FF2B5EF4-FFF2-40B4-BE49-F238E27FC236}">
+                    <a16:creationId xmlns:a16="http://schemas.microsoft.com/office/drawing/2014/main" id="{C867BBAA-D320-7BE8-CE54-2E28DA1FF54F}"/>
+                  </a:ext>
+                </a:extLst>
+              </p:cNvPr>
+              <p:cNvSpPr/>
+              <p:nvPr/>
+            </p:nvSpPr>
+            <p:spPr>
+              <a:xfrm rot="5400000">
+                <a:off x="2993971" y="2480781"/>
+                <a:ext cx="340964" cy="2898183"/>
+              </a:xfrm>
+              <a:prstGeom prst="downArrow">
+                <a:avLst/>
+              </a:prstGeom>
+              <a:solidFill>
+                <a:schemeClr val="tx1"/>
+              </a:solidFill>
+              <a:ln>
+                <a:noFill/>
+              </a:ln>
+            </p:spPr>
+            <p:style>
+              <a:lnRef idx="2">
+                <a:schemeClr val="accent1">
+                  <a:shade val="15000"/>
+                </a:schemeClr>
+              </a:lnRef>
+              <a:fillRef idx="1">
+                <a:schemeClr val="accent1"/>
+              </a:fillRef>
+              <a:effectRef idx="0">
+                <a:schemeClr val="accent1"/>
+              </a:effectRef>
+              <a:fontRef idx="minor">
+                <a:schemeClr val="lt1"/>
+              </a:fontRef>
+            </p:style>
+            <p:txBody>
+              <a:bodyPr rtlCol="0" anchor="ctr"/>
+              <a:lstStyle/>
+              <a:p>
+                <a:pPr algn="ctr"/>
+                <a:endParaRPr kumimoji="1" lang="ja-JP" altLang="en-US"/>
+              </a:p>
+            </p:txBody>
+          </p:sp>
+        </p:grpSp>
+        <p:sp>
+          <p:nvSpPr>
+            <p:cNvPr id="19" name="テキスト ボックス 18">
+              <a:extLst>
+                <a:ext uri="{FF2B5EF4-FFF2-40B4-BE49-F238E27FC236}">
+                  <a16:creationId xmlns:a16="http://schemas.microsoft.com/office/drawing/2014/main" id="{14029790-E533-3F8E-89E7-8548F16BC61C}"/>
+                </a:ext>
+              </a:extLst>
+            </p:cNvPr>
+            <p:cNvSpPr txBox="1"/>
+            <p:nvPr/>
+          </p:nvSpPr>
+          <p:spPr>
+            <a:xfrm>
+              <a:off x="746782" y="2890633"/>
+              <a:ext cx="2439583" cy="584775"/>
+            </a:xfrm>
+            <a:prstGeom prst="rect">
+              <a:avLst/>
+            </a:prstGeom>
+            <a:noFill/>
+          </p:spPr>
+          <p:txBody>
+            <a:bodyPr wrap="square" rtlCol="0" anchor="ctr">
+              <a:spAutoFit/>
+            </a:bodyPr>
+            <a:lstStyle/>
+            <a:p>
+              <a:pPr algn="ctr"/>
+              <a:r>
+                <a:rPr kumimoji="1" lang="ja-JP" altLang="en-US" sz="3200">
+                  <a:latin typeface="Hiragino Sans W4" panose="020B0400000000000000" pitchFamily="34" charset="-128"/>
+                  <a:ea typeface="Hiragino Sans W4" panose="020B0400000000000000" pitchFamily="34" charset="-128"/>
+                </a:rPr>
+                <a:t>票・カネ</a:t>
+              </a:r>
+            </a:p>
+          </p:txBody>
+        </p:sp>
+        <p:sp>
+          <p:nvSpPr>
+            <p:cNvPr id="20" name="テキスト ボックス 19">
+              <a:extLst>
+                <a:ext uri="{FF2B5EF4-FFF2-40B4-BE49-F238E27FC236}">
+                  <a16:creationId xmlns:a16="http://schemas.microsoft.com/office/drawing/2014/main" id="{79380E9C-19C4-BC66-57FE-2067E6F0FC95}"/>
+                </a:ext>
+              </a:extLst>
+            </p:cNvPr>
+            <p:cNvSpPr txBox="1"/>
+            <p:nvPr/>
+          </p:nvSpPr>
+          <p:spPr>
+            <a:xfrm>
+              <a:off x="3625416" y="4215825"/>
+              <a:ext cx="2439583" cy="584775"/>
+            </a:xfrm>
+            <a:prstGeom prst="rect">
+              <a:avLst/>
+            </a:prstGeom>
+            <a:noFill/>
+          </p:spPr>
+          <p:txBody>
+            <a:bodyPr wrap="square" rtlCol="0" anchor="ctr">
+              <a:spAutoFit/>
+            </a:bodyPr>
+            <a:lstStyle/>
+            <a:p>
+              <a:pPr algn="ctr"/>
+              <a:r>
+                <a:rPr kumimoji="1" lang="ja-JP" altLang="en-US" sz="3200">
+                  <a:latin typeface="Hiragino Sans W4" panose="020B0400000000000000" pitchFamily="34" charset="-128"/>
+                  <a:ea typeface="Hiragino Sans W4" panose="020B0400000000000000" pitchFamily="34" charset="-128"/>
+                </a:rPr>
+                <a:t>有利な政策</a:t>
+              </a:r>
+            </a:p>
+          </p:txBody>
+        </p:sp>
+        <p:sp>
+          <p:nvSpPr>
+            <p:cNvPr id="21" name="テキスト ボックス 20">
+              <a:extLst>
+                <a:ext uri="{FF2B5EF4-FFF2-40B4-BE49-F238E27FC236}">
+                  <a16:creationId xmlns:a16="http://schemas.microsoft.com/office/drawing/2014/main" id="{080E85C4-3030-DCF6-3F08-ECAAE2EBDB97}"/>
+                </a:ext>
+              </a:extLst>
+            </p:cNvPr>
+            <p:cNvSpPr txBox="1"/>
+            <p:nvPr/>
+          </p:nvSpPr>
+          <p:spPr>
+            <a:xfrm>
+              <a:off x="6861250" y="4214929"/>
+              <a:ext cx="2439583" cy="584775"/>
+            </a:xfrm>
+            <a:prstGeom prst="rect">
+              <a:avLst/>
+            </a:prstGeom>
+            <a:noFill/>
+          </p:spPr>
+          <p:txBody>
+            <a:bodyPr wrap="square" rtlCol="0" anchor="ctr">
+              <a:spAutoFit/>
+            </a:bodyPr>
+            <a:lstStyle/>
+            <a:p>
+              <a:pPr algn="ctr"/>
+              <a:r>
+                <a:rPr kumimoji="1" lang="ja-JP" altLang="en-US" sz="3200">
+                  <a:latin typeface="Hiragino Sans W4" panose="020B0400000000000000" pitchFamily="34" charset="-128"/>
+                  <a:ea typeface="Hiragino Sans W4" panose="020B0400000000000000" pitchFamily="34" charset="-128"/>
+                </a:rPr>
+                <a:t>有利な政策</a:t>
+              </a:r>
+            </a:p>
+          </p:txBody>
+        </p:sp>
+        <p:sp>
+          <p:nvSpPr>
+            <p:cNvPr id="22" name="テキスト ボックス 21">
+              <a:extLst>
+                <a:ext uri="{FF2B5EF4-FFF2-40B4-BE49-F238E27FC236}">
+                  <a16:creationId xmlns:a16="http://schemas.microsoft.com/office/drawing/2014/main" id="{F4BBBE1B-0E12-E3C5-A459-EFA5642BC3E1}"/>
+                </a:ext>
+              </a:extLst>
+            </p:cNvPr>
+            <p:cNvSpPr txBox="1"/>
+            <p:nvPr/>
+          </p:nvSpPr>
+          <p:spPr>
+            <a:xfrm>
+              <a:off x="9665407" y="2379392"/>
+              <a:ext cx="2439583" cy="1077218"/>
+            </a:xfrm>
+            <a:prstGeom prst="rect">
+              <a:avLst/>
+            </a:prstGeom>
+            <a:noFill/>
+          </p:spPr>
+          <p:txBody>
+            <a:bodyPr wrap="square" rtlCol="0" anchor="ctr">
+              <a:spAutoFit/>
+            </a:bodyPr>
+            <a:lstStyle/>
+            <a:p>
+              <a:pPr algn="ctr"/>
+              <a:r>
+                <a:rPr kumimoji="1" lang="ja-JP" altLang="en-US" sz="3200">
+                  <a:latin typeface="Hiragino Sans W4" panose="020B0400000000000000" pitchFamily="34" charset="-128"/>
+                  <a:ea typeface="Hiragino Sans W4" panose="020B0400000000000000" pitchFamily="34" charset="-128"/>
+                </a:rPr>
+                <a:t>天下り先・</a:t>
+              </a:r>
+              <a:endParaRPr kumimoji="1" lang="en-US" altLang="ja-JP" sz="3200" dirty="0">
+                <a:latin typeface="Hiragino Sans W4" panose="020B0400000000000000" pitchFamily="34" charset="-128"/>
+                <a:ea typeface="Hiragino Sans W4" panose="020B0400000000000000" pitchFamily="34" charset="-128"/>
+              </a:endParaRPr>
+            </a:p>
+            <a:p>
+              <a:pPr algn="ctr"/>
+              <a:r>
+                <a:rPr kumimoji="1" lang="ja-JP" altLang="en-US" sz="3200">
+                  <a:latin typeface="Hiragino Sans W4" panose="020B0400000000000000" pitchFamily="34" charset="-128"/>
+                  <a:ea typeface="Hiragino Sans W4" panose="020B0400000000000000" pitchFamily="34" charset="-128"/>
+                </a:rPr>
+                <a:t>政策支援</a:t>
+              </a:r>
+            </a:p>
+          </p:txBody>
+        </p:sp>
+        <p:sp>
+          <p:nvSpPr>
+            <p:cNvPr id="23" name="テキスト ボックス 22">
+              <a:extLst>
+                <a:ext uri="{FF2B5EF4-FFF2-40B4-BE49-F238E27FC236}">
+                  <a16:creationId xmlns:a16="http://schemas.microsoft.com/office/drawing/2014/main" id="{4D43D604-E3CB-1680-8903-7B7D4E56D270}"/>
+                </a:ext>
+              </a:extLst>
+            </p:cNvPr>
+            <p:cNvSpPr txBox="1"/>
+            <p:nvPr/>
+          </p:nvSpPr>
+          <p:spPr>
+            <a:xfrm>
+              <a:off x="4708306" y="7336259"/>
+              <a:ext cx="3141584" cy="584775"/>
+            </a:xfrm>
+            <a:prstGeom prst="rect">
+              <a:avLst/>
+            </a:prstGeom>
+            <a:noFill/>
+          </p:spPr>
+          <p:txBody>
+            <a:bodyPr wrap="square" rtlCol="0" anchor="ctr">
+              <a:spAutoFit/>
+            </a:bodyPr>
+            <a:lstStyle/>
+            <a:p>
+              <a:pPr algn="ctr"/>
+              <a:r>
+                <a:rPr kumimoji="1" lang="ja-JP" altLang="en-US" sz="3200">
+                  <a:latin typeface="Hiragino Sans W4" panose="020B0400000000000000" pitchFamily="34" charset="-128"/>
+                  <a:ea typeface="Hiragino Sans W4" panose="020B0400000000000000" pitchFamily="34" charset="-128"/>
+                </a:rPr>
+                <a:t>専門知識・情報</a:t>
+              </a:r>
+            </a:p>
+          </p:txBody>
+        </p:sp>
+        <p:sp>
+          <p:nvSpPr>
+            <p:cNvPr id="24" name="テキスト ボックス 23">
+              <a:extLst>
+                <a:ext uri="{FF2B5EF4-FFF2-40B4-BE49-F238E27FC236}">
+                  <a16:creationId xmlns:a16="http://schemas.microsoft.com/office/drawing/2014/main" id="{8A9BD05C-8695-B7EF-B3DE-072F73488E87}"/>
+                </a:ext>
+              </a:extLst>
+            </p:cNvPr>
+            <p:cNvSpPr txBox="1"/>
+            <p:nvPr/>
+          </p:nvSpPr>
+          <p:spPr>
+            <a:xfrm>
+              <a:off x="4819803" y="5276757"/>
+              <a:ext cx="3161994" cy="584775"/>
+            </a:xfrm>
+            <a:prstGeom prst="rect">
+              <a:avLst/>
+            </a:prstGeom>
+            <a:noFill/>
+          </p:spPr>
+          <p:txBody>
+            <a:bodyPr wrap="square" rtlCol="0" anchor="ctr">
+              <a:spAutoFit/>
+            </a:bodyPr>
+            <a:lstStyle/>
+            <a:p>
+              <a:pPr algn="ctr"/>
+              <a:r>
+                <a:rPr kumimoji="1" lang="ja-JP" altLang="en-US" sz="3200">
+                  <a:latin typeface="Hiragino Sans W4" panose="020B0400000000000000" pitchFamily="34" charset="-128"/>
+                  <a:ea typeface="Hiragino Sans W4" panose="020B0400000000000000" pitchFamily="34" charset="-128"/>
+                </a:rPr>
+                <a:t>出世のチャンス</a:t>
+              </a:r>
+            </a:p>
+          </p:txBody>
+        </p:sp>
+      </p:grpSp>
+    </p:spTree>
+    <p:extLst>
+      <p:ext uri="{BB962C8B-B14F-4D97-AF65-F5344CB8AC3E}">
+        <p14:creationId xmlns:p14="http://schemas.microsoft.com/office/powerpoint/2010/main" val="1329324493"/>
+      </p:ext>
+    </p:extLst>
+  </p:cSld>
+  <p:clrMapOvr>
+    <a:masterClrMapping/>
+  </p:clrMapOvr>
+</p:sld>
+</file>
+
 <file path=ppt/slides/slide2.xml><?xml version="1.0" encoding="utf-8"?>
 <p:sld xmlns:a="http://schemas.openxmlformats.org/drawingml/2006/main" xmlns:r="http://schemas.openxmlformats.org/officeDocument/2006/relationships" xmlns:p="http://schemas.openxmlformats.org/presentationml/2006/main">
   <p:cSld>

</xml_diff>

<commit_message>
Updated 12/Interest Theories and Added 14/Review
</commit_message>
<xml_diff>
--- a/figs/DIYfigures_pp.pptx
+++ b/figs/DIYfigures_pp.pptx
@@ -22,6 +22,9 @@
     <p:sldId id="270" r:id="rId16"/>
     <p:sldId id="271" r:id="rId17"/>
     <p:sldId id="272" r:id="rId18"/>
+    <p:sldId id="273" r:id="rId19"/>
+    <p:sldId id="274" r:id="rId20"/>
+    <p:sldId id="275" r:id="rId21"/>
   </p:sldIdLst>
   <p:sldSz cx="12801600" cy="9601200" type="A3"/>
   <p:notesSz cx="6858000" cy="9144000"/>
@@ -259,7 +262,7 @@
           <a:p>
             <a:fld id="{DBD89380-344E-284F-BE0F-D796858BF56F}" type="datetimeFigureOut">
               <a:rPr kumimoji="1" lang="ja-JP" altLang="en-US" smtClean="0"/>
-              <a:t>2026/6/15</a:t>
+              <a:t>2026/6/25</a:t>
             </a:fld>
             <a:endParaRPr kumimoji="1" lang="ja-JP" altLang="en-US"/>
           </a:p>
@@ -461,7 +464,7 @@
           <a:p>
             <a:fld id="{DBD89380-344E-284F-BE0F-D796858BF56F}" type="datetimeFigureOut">
               <a:rPr kumimoji="1" lang="ja-JP" altLang="en-US" smtClean="0"/>
-              <a:t>2026/6/15</a:t>
+              <a:t>2026/6/25</a:t>
             </a:fld>
             <a:endParaRPr kumimoji="1" lang="ja-JP" altLang="en-US"/>
           </a:p>
@@ -673,7 +676,7 @@
           <a:p>
             <a:fld id="{DBD89380-344E-284F-BE0F-D796858BF56F}" type="datetimeFigureOut">
               <a:rPr kumimoji="1" lang="ja-JP" altLang="en-US" smtClean="0"/>
-              <a:t>2026/6/15</a:t>
+              <a:t>2026/6/25</a:t>
             </a:fld>
             <a:endParaRPr kumimoji="1" lang="ja-JP" altLang="en-US"/>
           </a:p>
@@ -875,7 +878,7 @@
           <a:p>
             <a:fld id="{DBD89380-344E-284F-BE0F-D796858BF56F}" type="datetimeFigureOut">
               <a:rPr kumimoji="1" lang="ja-JP" altLang="en-US" smtClean="0"/>
-              <a:t>2026/6/15</a:t>
+              <a:t>2026/6/25</a:t>
             </a:fld>
             <a:endParaRPr kumimoji="1" lang="ja-JP" altLang="en-US"/>
           </a:p>
@@ -1119,7 +1122,7 @@
           <a:p>
             <a:fld id="{DBD89380-344E-284F-BE0F-D796858BF56F}" type="datetimeFigureOut">
               <a:rPr kumimoji="1" lang="ja-JP" altLang="en-US" smtClean="0"/>
-              <a:t>2026/6/15</a:t>
+              <a:t>2026/6/25</a:t>
             </a:fld>
             <a:endParaRPr kumimoji="1" lang="ja-JP" altLang="en-US"/>
           </a:p>
@@ -1415,7 +1418,7 @@
           <a:p>
             <a:fld id="{DBD89380-344E-284F-BE0F-D796858BF56F}" type="datetimeFigureOut">
               <a:rPr kumimoji="1" lang="ja-JP" altLang="en-US" smtClean="0"/>
-              <a:t>2026/6/15</a:t>
+              <a:t>2026/6/25</a:t>
             </a:fld>
             <a:endParaRPr kumimoji="1" lang="ja-JP" altLang="en-US"/>
           </a:p>
@@ -1846,7 +1849,7 @@
           <a:p>
             <a:fld id="{DBD89380-344E-284F-BE0F-D796858BF56F}" type="datetimeFigureOut">
               <a:rPr kumimoji="1" lang="ja-JP" altLang="en-US" smtClean="0"/>
-              <a:t>2026/6/15</a:t>
+              <a:t>2026/6/25</a:t>
             </a:fld>
             <a:endParaRPr kumimoji="1" lang="ja-JP" altLang="en-US"/>
           </a:p>
@@ -1964,7 +1967,7 @@
           <a:p>
             <a:fld id="{DBD89380-344E-284F-BE0F-D796858BF56F}" type="datetimeFigureOut">
               <a:rPr kumimoji="1" lang="ja-JP" altLang="en-US" smtClean="0"/>
-              <a:t>2026/6/15</a:t>
+              <a:t>2026/6/25</a:t>
             </a:fld>
             <a:endParaRPr kumimoji="1" lang="ja-JP" altLang="en-US"/>
           </a:p>
@@ -2059,7 +2062,7 @@
           <a:p>
             <a:fld id="{DBD89380-344E-284F-BE0F-D796858BF56F}" type="datetimeFigureOut">
               <a:rPr kumimoji="1" lang="ja-JP" altLang="en-US" smtClean="0"/>
-              <a:t>2026/6/15</a:t>
+              <a:t>2026/6/25</a:t>
             </a:fld>
             <a:endParaRPr kumimoji="1" lang="ja-JP" altLang="en-US"/>
           </a:p>
@@ -2368,7 +2371,7 @@
           <a:p>
             <a:fld id="{DBD89380-344E-284F-BE0F-D796858BF56F}" type="datetimeFigureOut">
               <a:rPr kumimoji="1" lang="ja-JP" altLang="en-US" smtClean="0"/>
-              <a:t>2026/6/15</a:t>
+              <a:t>2026/6/25</a:t>
             </a:fld>
             <a:endParaRPr kumimoji="1" lang="ja-JP" altLang="en-US"/>
           </a:p>
@@ -2625,7 +2628,7 @@
           <a:p>
             <a:fld id="{DBD89380-344E-284F-BE0F-D796858BF56F}" type="datetimeFigureOut">
               <a:rPr kumimoji="1" lang="ja-JP" altLang="en-US" smtClean="0"/>
-              <a:t>2026/6/15</a:t>
+              <a:t>2026/6/25</a:t>
             </a:fld>
             <a:endParaRPr kumimoji="1" lang="ja-JP" altLang="en-US"/>
           </a:p>
@@ -2870,7 +2873,7 @@
           <a:p>
             <a:fld id="{DBD89380-344E-284F-BE0F-D796858BF56F}" type="datetimeFigureOut">
               <a:rPr kumimoji="1" lang="ja-JP" altLang="en-US" smtClean="0"/>
-              <a:t>2026/6/15</a:t>
+              <a:t>2026/6/25</a:t>
             </a:fld>
             <a:endParaRPr kumimoji="1" lang="ja-JP" altLang="en-US"/>
           </a:p>
@@ -12741,6 +12744,4197 @@
 </p:sld>
 </file>
 
+<file path=ppt/slides/slide18.xml><?xml version="1.0" encoding="utf-8"?>
+<p:sld xmlns:a="http://schemas.openxmlformats.org/drawingml/2006/main" xmlns:r="http://schemas.openxmlformats.org/officeDocument/2006/relationships" xmlns:p="http://schemas.openxmlformats.org/presentationml/2006/main">
+  <p:cSld>
+    <p:spTree>
+      <p:nvGrpSpPr>
+        <p:cNvPr id="1" name=""/>
+        <p:cNvGrpSpPr/>
+        <p:nvPr/>
+      </p:nvGrpSpPr>
+      <p:grpSpPr>
+        <a:xfrm>
+          <a:off x="0" y="0"/>
+          <a:ext cx="0" cy="0"/>
+          <a:chOff x="0" y="0"/>
+          <a:chExt cx="0" cy="0"/>
+        </a:xfrm>
+      </p:grpSpPr>
+      <p:grpSp>
+        <p:nvGrpSpPr>
+          <p:cNvPr id="74" name="グループ化 73">
+            <a:extLst>
+              <a:ext uri="{FF2B5EF4-FFF2-40B4-BE49-F238E27FC236}">
+                <a16:creationId xmlns:a16="http://schemas.microsoft.com/office/drawing/2014/main" id="{D886DFFB-752D-DC17-E3AA-2176F4D591FE}"/>
+              </a:ext>
+            </a:extLst>
+          </p:cNvPr>
+          <p:cNvGrpSpPr/>
+          <p:nvPr/>
+        </p:nvGrpSpPr>
+        <p:grpSpPr>
+          <a:xfrm>
+            <a:off x="790413" y="382291"/>
+            <a:ext cx="11220774" cy="8073574"/>
+            <a:chOff x="790413" y="382291"/>
+            <a:chExt cx="11220774" cy="8073574"/>
+          </a:xfrm>
+        </p:grpSpPr>
+        <p:sp>
+          <p:nvSpPr>
+            <p:cNvPr id="10" name="角丸四角形 9">
+              <a:extLst>
+                <a:ext uri="{FF2B5EF4-FFF2-40B4-BE49-F238E27FC236}">
+                  <a16:creationId xmlns:a16="http://schemas.microsoft.com/office/drawing/2014/main" id="{C3E923A2-EE39-7369-77B7-883247458A0C}"/>
+                </a:ext>
+              </a:extLst>
+            </p:cNvPr>
+            <p:cNvSpPr/>
+            <p:nvPr/>
+          </p:nvSpPr>
+          <p:spPr>
+            <a:xfrm>
+              <a:off x="5262001" y="382291"/>
+              <a:ext cx="2277597" cy="836909"/>
+            </a:xfrm>
+            <a:prstGeom prst="roundRect">
+              <a:avLst/>
+            </a:prstGeom>
+            <a:noFill/>
+            <a:ln w="28575">
+              <a:solidFill>
+                <a:schemeClr val="tx1"/>
+              </a:solidFill>
+            </a:ln>
+          </p:spPr>
+          <p:style>
+            <a:lnRef idx="2">
+              <a:schemeClr val="accent1">
+                <a:shade val="15000"/>
+              </a:schemeClr>
+            </a:lnRef>
+            <a:fillRef idx="1">
+              <a:schemeClr val="accent1"/>
+            </a:fillRef>
+            <a:effectRef idx="0">
+              <a:schemeClr val="accent1"/>
+            </a:effectRef>
+            <a:fontRef idx="minor">
+              <a:schemeClr val="lt1"/>
+            </a:fontRef>
+          </p:style>
+          <p:txBody>
+            <a:bodyPr rtlCol="0" anchor="ctr"/>
+            <a:lstStyle/>
+            <a:p>
+              <a:pPr algn="ctr"/>
+              <a:r>
+                <a:rPr kumimoji="1" lang="ja-JP" altLang="en-US" sz="4400">
+                  <a:solidFill>
+                    <a:schemeClr val="tx1"/>
+                  </a:solidFill>
+                  <a:latin typeface="Hiragino Kaku Gothic StdN W8" panose="020B0800000000000000" pitchFamily="34" charset="-128"/>
+                  <a:ea typeface="Hiragino Kaku Gothic StdN W8" panose="020B0800000000000000" pitchFamily="34" charset="-128"/>
+                </a:rPr>
+                <a:t>政府</a:t>
+              </a:r>
+              <a:endParaRPr kumimoji="1" lang="ja-JP" altLang="en-US" sz="3000"/>
+            </a:p>
+          </p:txBody>
+        </p:sp>
+        <p:grpSp>
+          <p:nvGrpSpPr>
+            <p:cNvPr id="20" name="グループ化 19">
+              <a:extLst>
+                <a:ext uri="{FF2B5EF4-FFF2-40B4-BE49-F238E27FC236}">
+                  <a16:creationId xmlns:a16="http://schemas.microsoft.com/office/drawing/2014/main" id="{006AF209-8C92-4D26-0A78-686B7ED4A35A}"/>
+                </a:ext>
+              </a:extLst>
+            </p:cNvPr>
+            <p:cNvGrpSpPr/>
+            <p:nvPr/>
+          </p:nvGrpSpPr>
+          <p:grpSpPr>
+            <a:xfrm>
+              <a:off x="790413" y="2522350"/>
+              <a:ext cx="2774196" cy="3006385"/>
+              <a:chOff x="790413" y="2522350"/>
+              <a:chExt cx="2774196" cy="3006385"/>
+            </a:xfrm>
+          </p:grpSpPr>
+          <p:sp>
+            <p:nvSpPr>
+              <p:cNvPr id="14" name="三角形 13">
+                <a:extLst>
+                  <a:ext uri="{FF2B5EF4-FFF2-40B4-BE49-F238E27FC236}">
+                    <a16:creationId xmlns:a16="http://schemas.microsoft.com/office/drawing/2014/main" id="{4581BE06-BA1B-D0DA-B4D2-DA1FA0078F60}"/>
+                  </a:ext>
+                </a:extLst>
+              </p:cNvPr>
+              <p:cNvSpPr/>
+              <p:nvPr/>
+            </p:nvSpPr>
+            <p:spPr>
+              <a:xfrm>
+                <a:off x="790413" y="2522350"/>
+                <a:ext cx="2774196" cy="2421610"/>
+              </a:xfrm>
+              <a:prstGeom prst="triangle">
+                <a:avLst/>
+              </a:prstGeom>
+              <a:noFill/>
+              <a:ln w="28575">
+                <a:solidFill>
+                  <a:schemeClr val="tx1"/>
+                </a:solidFill>
+              </a:ln>
+            </p:spPr>
+            <p:style>
+              <a:lnRef idx="2">
+                <a:schemeClr val="accent1">
+                  <a:shade val="15000"/>
+                </a:schemeClr>
+              </a:lnRef>
+              <a:fillRef idx="1">
+                <a:schemeClr val="accent1"/>
+              </a:fillRef>
+              <a:effectRef idx="0">
+                <a:schemeClr val="accent1"/>
+              </a:effectRef>
+              <a:fontRef idx="minor">
+                <a:schemeClr val="lt1"/>
+              </a:fontRef>
+            </p:style>
+            <p:txBody>
+              <a:bodyPr rtlCol="0" anchor="ctr"/>
+              <a:lstStyle/>
+              <a:p>
+                <a:pPr algn="ctr"/>
+                <a:endParaRPr kumimoji="1" lang="ja-JP" altLang="en-US"/>
+              </a:p>
+            </p:txBody>
+          </p:sp>
+          <p:sp>
+            <p:nvSpPr>
+              <p:cNvPr id="15" name="円/楕円 14">
+                <a:extLst>
+                  <a:ext uri="{FF2B5EF4-FFF2-40B4-BE49-F238E27FC236}">
+                    <a16:creationId xmlns:a16="http://schemas.microsoft.com/office/drawing/2014/main" id="{25FA0376-5357-1925-E846-0C8DF11FE858}"/>
+                  </a:ext>
+                </a:extLst>
+              </p:cNvPr>
+              <p:cNvSpPr/>
+              <p:nvPr/>
+            </p:nvSpPr>
+            <p:spPr>
+              <a:xfrm>
+                <a:off x="1363028" y="4118492"/>
+                <a:ext cx="573438" cy="573438"/>
+              </a:xfrm>
+              <a:prstGeom prst="ellipse">
+                <a:avLst/>
+              </a:prstGeom>
+              <a:noFill/>
+              <a:ln w="19050">
+                <a:solidFill>
+                  <a:schemeClr val="tx1"/>
+                </a:solidFill>
+              </a:ln>
+            </p:spPr>
+            <p:style>
+              <a:lnRef idx="2">
+                <a:schemeClr val="accent1">
+                  <a:shade val="15000"/>
+                </a:schemeClr>
+              </a:lnRef>
+              <a:fillRef idx="1">
+                <a:schemeClr val="accent1"/>
+              </a:fillRef>
+              <a:effectRef idx="0">
+                <a:schemeClr val="accent1"/>
+              </a:effectRef>
+              <a:fontRef idx="minor">
+                <a:schemeClr val="lt1"/>
+              </a:fontRef>
+            </p:style>
+            <p:txBody>
+              <a:bodyPr rtlCol="0" anchor="ctr"/>
+              <a:lstStyle/>
+              <a:p>
+                <a:pPr algn="ctr"/>
+                <a:r>
+                  <a:rPr kumimoji="1" lang="ja-JP" altLang="en-US" sz="2400">
+                    <a:solidFill>
+                      <a:schemeClr val="tx1"/>
+                    </a:solidFill>
+                    <a:latin typeface="Hiragino Sans W4" panose="020B0400000000000000" pitchFamily="34" charset="-128"/>
+                    <a:ea typeface="Hiragino Sans W4" panose="020B0400000000000000" pitchFamily="34" charset="-128"/>
+                  </a:rPr>
+                  <a:t>労</a:t>
+                </a:r>
+              </a:p>
+            </p:txBody>
+          </p:sp>
+          <p:sp>
+            <p:nvSpPr>
+              <p:cNvPr id="17" name="円/楕円 16">
+                <a:extLst>
+                  <a:ext uri="{FF2B5EF4-FFF2-40B4-BE49-F238E27FC236}">
+                    <a16:creationId xmlns:a16="http://schemas.microsoft.com/office/drawing/2014/main" id="{9A420F46-B2C1-CDB5-8618-C3F0A7373B66}"/>
+                  </a:ext>
+                </a:extLst>
+              </p:cNvPr>
+              <p:cNvSpPr/>
+              <p:nvPr/>
+            </p:nvSpPr>
+            <p:spPr>
+              <a:xfrm>
+                <a:off x="2463818" y="4118492"/>
+                <a:ext cx="573438" cy="573438"/>
+              </a:xfrm>
+              <a:prstGeom prst="ellipse">
+                <a:avLst/>
+              </a:prstGeom>
+              <a:noFill/>
+              <a:ln w="19050">
+                <a:solidFill>
+                  <a:schemeClr val="tx1"/>
+                </a:solidFill>
+              </a:ln>
+            </p:spPr>
+            <p:style>
+              <a:lnRef idx="2">
+                <a:schemeClr val="accent1">
+                  <a:shade val="15000"/>
+                </a:schemeClr>
+              </a:lnRef>
+              <a:fillRef idx="1">
+                <a:schemeClr val="accent1"/>
+              </a:fillRef>
+              <a:effectRef idx="0">
+                <a:schemeClr val="accent1"/>
+              </a:effectRef>
+              <a:fontRef idx="minor">
+                <a:schemeClr val="lt1"/>
+              </a:fontRef>
+            </p:style>
+            <p:txBody>
+              <a:bodyPr rtlCol="0" anchor="ctr"/>
+              <a:lstStyle/>
+              <a:p>
+                <a:pPr algn="ctr"/>
+                <a:r>
+                  <a:rPr kumimoji="1" lang="ja-JP" altLang="en-US" sz="2400">
+                    <a:solidFill>
+                      <a:schemeClr val="tx1"/>
+                    </a:solidFill>
+                    <a:latin typeface="Hiragino Sans W4" panose="020B0400000000000000" pitchFamily="34" charset="-128"/>
+                    <a:ea typeface="Hiragino Sans W4" panose="020B0400000000000000" pitchFamily="34" charset="-128"/>
+                  </a:rPr>
+                  <a:t>労</a:t>
+                </a:r>
+              </a:p>
+            </p:txBody>
+          </p:sp>
+          <p:sp>
+            <p:nvSpPr>
+              <p:cNvPr id="18" name="円/楕円 17">
+                <a:extLst>
+                  <a:ext uri="{FF2B5EF4-FFF2-40B4-BE49-F238E27FC236}">
+                    <a16:creationId xmlns:a16="http://schemas.microsoft.com/office/drawing/2014/main" id="{C7F637D0-C1B3-B230-40F4-28E0FC9D99DF}"/>
+                  </a:ext>
+                </a:extLst>
+              </p:cNvPr>
+              <p:cNvSpPr/>
+              <p:nvPr/>
+            </p:nvSpPr>
+            <p:spPr>
+              <a:xfrm>
+                <a:off x="1890792" y="3033702"/>
+                <a:ext cx="573438" cy="573438"/>
+              </a:xfrm>
+              <a:prstGeom prst="ellipse">
+                <a:avLst/>
+              </a:prstGeom>
+              <a:noFill/>
+              <a:ln w="19050">
+                <a:solidFill>
+                  <a:schemeClr val="tx1"/>
+                </a:solidFill>
+              </a:ln>
+            </p:spPr>
+            <p:style>
+              <a:lnRef idx="2">
+                <a:schemeClr val="accent1">
+                  <a:shade val="15000"/>
+                </a:schemeClr>
+              </a:lnRef>
+              <a:fillRef idx="1">
+                <a:schemeClr val="accent1"/>
+              </a:fillRef>
+              <a:effectRef idx="0">
+                <a:schemeClr val="accent1"/>
+              </a:effectRef>
+              <a:fontRef idx="minor">
+                <a:schemeClr val="lt1"/>
+              </a:fontRef>
+            </p:style>
+            <p:txBody>
+              <a:bodyPr rtlCol="0" anchor="ctr"/>
+              <a:lstStyle/>
+              <a:p>
+                <a:pPr algn="ctr"/>
+                <a:r>
+                  <a:rPr kumimoji="1" lang="ja-JP" altLang="en-US" sz="2400">
+                    <a:solidFill>
+                      <a:schemeClr val="tx1"/>
+                    </a:solidFill>
+                    <a:latin typeface="Hiragino Sans W4" panose="020B0400000000000000" pitchFamily="34" charset="-128"/>
+                    <a:ea typeface="Hiragino Sans W4" panose="020B0400000000000000" pitchFamily="34" charset="-128"/>
+                  </a:rPr>
+                  <a:t>労</a:t>
+                </a:r>
+              </a:p>
+            </p:txBody>
+          </p:sp>
+          <p:sp>
+            <p:nvSpPr>
+              <p:cNvPr id="19" name="テキスト ボックス 18">
+                <a:extLst>
+                  <a:ext uri="{FF2B5EF4-FFF2-40B4-BE49-F238E27FC236}">
+                    <a16:creationId xmlns:a16="http://schemas.microsoft.com/office/drawing/2014/main" id="{F38CD63C-67C4-8F23-7EAF-26AB30879826}"/>
+                  </a:ext>
+                </a:extLst>
+              </p:cNvPr>
+              <p:cNvSpPr txBox="1"/>
+              <p:nvPr/>
+            </p:nvSpPr>
+            <p:spPr>
+              <a:xfrm>
+                <a:off x="1136812" y="4943960"/>
+                <a:ext cx="2081398" cy="584775"/>
+              </a:xfrm>
+              <a:prstGeom prst="rect">
+                <a:avLst/>
+              </a:prstGeom>
+              <a:noFill/>
+            </p:spPr>
+            <p:txBody>
+              <a:bodyPr wrap="square" rtlCol="0">
+                <a:spAutoFit/>
+              </a:bodyPr>
+              <a:lstStyle/>
+              <a:p>
+                <a:pPr algn="ctr"/>
+                <a:r>
+                  <a:rPr kumimoji="1" lang="ja-JP" altLang="en-US" sz="3200">
+                    <a:latin typeface="Hiragino Kaku Gothic StdN W8" panose="020B0800000000000000" pitchFamily="34" charset="-128"/>
+                    <a:ea typeface="Hiragino Kaku Gothic StdN W8" panose="020B0800000000000000" pitchFamily="34" charset="-128"/>
+                  </a:rPr>
+                  <a:t>労働組合</a:t>
+                </a:r>
+              </a:p>
+            </p:txBody>
+          </p:sp>
+        </p:grpSp>
+        <p:grpSp>
+          <p:nvGrpSpPr>
+            <p:cNvPr id="21" name="グループ化 20">
+              <a:extLst>
+                <a:ext uri="{FF2B5EF4-FFF2-40B4-BE49-F238E27FC236}">
+                  <a16:creationId xmlns:a16="http://schemas.microsoft.com/office/drawing/2014/main" id="{96EE3A86-64E8-F48A-18AC-3461D8357316}"/>
+                </a:ext>
+              </a:extLst>
+            </p:cNvPr>
+            <p:cNvGrpSpPr/>
+            <p:nvPr/>
+          </p:nvGrpSpPr>
+          <p:grpSpPr>
+            <a:xfrm>
+              <a:off x="2245436" y="5449480"/>
+              <a:ext cx="2774196" cy="3006385"/>
+              <a:chOff x="790413" y="2522350"/>
+              <a:chExt cx="2774196" cy="3006385"/>
+            </a:xfrm>
+          </p:grpSpPr>
+          <p:sp>
+            <p:nvSpPr>
+              <p:cNvPr id="22" name="三角形 21">
+                <a:extLst>
+                  <a:ext uri="{FF2B5EF4-FFF2-40B4-BE49-F238E27FC236}">
+                    <a16:creationId xmlns:a16="http://schemas.microsoft.com/office/drawing/2014/main" id="{92273071-5427-591A-5469-74DAF2B71FFE}"/>
+                  </a:ext>
+                </a:extLst>
+              </p:cNvPr>
+              <p:cNvSpPr/>
+              <p:nvPr/>
+            </p:nvSpPr>
+            <p:spPr>
+              <a:xfrm>
+                <a:off x="790413" y="2522350"/>
+                <a:ext cx="2774196" cy="2421610"/>
+              </a:xfrm>
+              <a:prstGeom prst="triangle">
+                <a:avLst/>
+              </a:prstGeom>
+              <a:noFill/>
+              <a:ln w="28575">
+                <a:solidFill>
+                  <a:schemeClr val="tx1"/>
+                </a:solidFill>
+              </a:ln>
+            </p:spPr>
+            <p:style>
+              <a:lnRef idx="2">
+                <a:schemeClr val="accent1">
+                  <a:shade val="15000"/>
+                </a:schemeClr>
+              </a:lnRef>
+              <a:fillRef idx="1">
+                <a:schemeClr val="accent1"/>
+              </a:fillRef>
+              <a:effectRef idx="0">
+                <a:schemeClr val="accent1"/>
+              </a:effectRef>
+              <a:fontRef idx="minor">
+                <a:schemeClr val="lt1"/>
+              </a:fontRef>
+            </p:style>
+            <p:txBody>
+              <a:bodyPr rtlCol="0" anchor="ctr"/>
+              <a:lstStyle/>
+              <a:p>
+                <a:pPr algn="ctr"/>
+                <a:endParaRPr kumimoji="1" lang="ja-JP" altLang="en-US"/>
+              </a:p>
+            </p:txBody>
+          </p:sp>
+          <p:sp>
+            <p:nvSpPr>
+              <p:cNvPr id="23" name="円/楕円 22">
+                <a:extLst>
+                  <a:ext uri="{FF2B5EF4-FFF2-40B4-BE49-F238E27FC236}">
+                    <a16:creationId xmlns:a16="http://schemas.microsoft.com/office/drawing/2014/main" id="{D9B168C9-3980-83D9-4173-3E7CACF154F3}"/>
+                  </a:ext>
+                </a:extLst>
+              </p:cNvPr>
+              <p:cNvSpPr/>
+              <p:nvPr/>
+            </p:nvSpPr>
+            <p:spPr>
+              <a:xfrm>
+                <a:off x="1363028" y="4118492"/>
+                <a:ext cx="573438" cy="573438"/>
+              </a:xfrm>
+              <a:prstGeom prst="ellipse">
+                <a:avLst/>
+              </a:prstGeom>
+              <a:noFill/>
+              <a:ln w="19050">
+                <a:solidFill>
+                  <a:schemeClr val="tx1"/>
+                </a:solidFill>
+              </a:ln>
+            </p:spPr>
+            <p:style>
+              <a:lnRef idx="2">
+                <a:schemeClr val="accent1">
+                  <a:shade val="15000"/>
+                </a:schemeClr>
+              </a:lnRef>
+              <a:fillRef idx="1">
+                <a:schemeClr val="accent1"/>
+              </a:fillRef>
+              <a:effectRef idx="0">
+                <a:schemeClr val="accent1"/>
+              </a:effectRef>
+              <a:fontRef idx="minor">
+                <a:schemeClr val="lt1"/>
+              </a:fontRef>
+            </p:style>
+            <p:txBody>
+              <a:bodyPr rtlCol="0" anchor="ctr"/>
+              <a:lstStyle/>
+              <a:p>
+                <a:pPr algn="ctr"/>
+                <a:r>
+                  <a:rPr kumimoji="1" lang="ja-JP" altLang="en-US" sz="2400">
+                    <a:solidFill>
+                      <a:schemeClr val="tx1"/>
+                    </a:solidFill>
+                    <a:latin typeface="Hiragino Sans W4" panose="020B0400000000000000" pitchFamily="34" charset="-128"/>
+                    <a:ea typeface="Hiragino Sans W4" panose="020B0400000000000000" pitchFamily="34" charset="-128"/>
+                  </a:rPr>
+                  <a:t>労</a:t>
+                </a:r>
+              </a:p>
+            </p:txBody>
+          </p:sp>
+          <p:sp>
+            <p:nvSpPr>
+              <p:cNvPr id="24" name="円/楕円 23">
+                <a:extLst>
+                  <a:ext uri="{FF2B5EF4-FFF2-40B4-BE49-F238E27FC236}">
+                    <a16:creationId xmlns:a16="http://schemas.microsoft.com/office/drawing/2014/main" id="{0F7B4B6D-E771-FAE3-9C01-7CE84D649394}"/>
+                  </a:ext>
+                </a:extLst>
+              </p:cNvPr>
+              <p:cNvSpPr/>
+              <p:nvPr/>
+            </p:nvSpPr>
+            <p:spPr>
+              <a:xfrm>
+                <a:off x="2463818" y="4118492"/>
+                <a:ext cx="573438" cy="573438"/>
+              </a:xfrm>
+              <a:prstGeom prst="ellipse">
+                <a:avLst/>
+              </a:prstGeom>
+              <a:noFill/>
+              <a:ln w="19050">
+                <a:solidFill>
+                  <a:schemeClr val="tx1"/>
+                </a:solidFill>
+              </a:ln>
+            </p:spPr>
+            <p:style>
+              <a:lnRef idx="2">
+                <a:schemeClr val="accent1">
+                  <a:shade val="15000"/>
+                </a:schemeClr>
+              </a:lnRef>
+              <a:fillRef idx="1">
+                <a:schemeClr val="accent1"/>
+              </a:fillRef>
+              <a:effectRef idx="0">
+                <a:schemeClr val="accent1"/>
+              </a:effectRef>
+              <a:fontRef idx="minor">
+                <a:schemeClr val="lt1"/>
+              </a:fontRef>
+            </p:style>
+            <p:txBody>
+              <a:bodyPr rtlCol="0" anchor="ctr"/>
+              <a:lstStyle/>
+              <a:p>
+                <a:pPr algn="ctr"/>
+                <a:r>
+                  <a:rPr kumimoji="1" lang="ja-JP" altLang="en-US" sz="2400">
+                    <a:solidFill>
+                      <a:schemeClr val="tx1"/>
+                    </a:solidFill>
+                    <a:latin typeface="Hiragino Sans W4" panose="020B0400000000000000" pitchFamily="34" charset="-128"/>
+                    <a:ea typeface="Hiragino Sans W4" panose="020B0400000000000000" pitchFamily="34" charset="-128"/>
+                  </a:rPr>
+                  <a:t>労</a:t>
+                </a:r>
+              </a:p>
+            </p:txBody>
+          </p:sp>
+          <p:sp>
+            <p:nvSpPr>
+              <p:cNvPr id="25" name="円/楕円 24">
+                <a:extLst>
+                  <a:ext uri="{FF2B5EF4-FFF2-40B4-BE49-F238E27FC236}">
+                    <a16:creationId xmlns:a16="http://schemas.microsoft.com/office/drawing/2014/main" id="{08086261-372F-4EEE-2452-8531904E25E0}"/>
+                  </a:ext>
+                </a:extLst>
+              </p:cNvPr>
+              <p:cNvSpPr/>
+              <p:nvPr/>
+            </p:nvSpPr>
+            <p:spPr>
+              <a:xfrm>
+                <a:off x="1890792" y="3033702"/>
+                <a:ext cx="573438" cy="573438"/>
+              </a:xfrm>
+              <a:prstGeom prst="ellipse">
+                <a:avLst/>
+              </a:prstGeom>
+              <a:noFill/>
+              <a:ln w="19050">
+                <a:solidFill>
+                  <a:schemeClr val="tx1"/>
+                </a:solidFill>
+              </a:ln>
+            </p:spPr>
+            <p:style>
+              <a:lnRef idx="2">
+                <a:schemeClr val="accent1">
+                  <a:shade val="15000"/>
+                </a:schemeClr>
+              </a:lnRef>
+              <a:fillRef idx="1">
+                <a:schemeClr val="accent1"/>
+              </a:fillRef>
+              <a:effectRef idx="0">
+                <a:schemeClr val="accent1"/>
+              </a:effectRef>
+              <a:fontRef idx="minor">
+                <a:schemeClr val="lt1"/>
+              </a:fontRef>
+            </p:style>
+            <p:txBody>
+              <a:bodyPr rtlCol="0" anchor="ctr"/>
+              <a:lstStyle/>
+              <a:p>
+                <a:pPr algn="ctr"/>
+                <a:r>
+                  <a:rPr kumimoji="1" lang="ja-JP" altLang="en-US" sz="2400">
+                    <a:solidFill>
+                      <a:schemeClr val="tx1"/>
+                    </a:solidFill>
+                    <a:latin typeface="Hiragino Sans W4" panose="020B0400000000000000" pitchFamily="34" charset="-128"/>
+                    <a:ea typeface="Hiragino Sans W4" panose="020B0400000000000000" pitchFamily="34" charset="-128"/>
+                  </a:rPr>
+                  <a:t>労</a:t>
+                </a:r>
+              </a:p>
+            </p:txBody>
+          </p:sp>
+          <p:sp>
+            <p:nvSpPr>
+              <p:cNvPr id="26" name="テキスト ボックス 25">
+                <a:extLst>
+                  <a:ext uri="{FF2B5EF4-FFF2-40B4-BE49-F238E27FC236}">
+                    <a16:creationId xmlns:a16="http://schemas.microsoft.com/office/drawing/2014/main" id="{BAD4A64B-992A-BB04-FC14-B6E83E955088}"/>
+                  </a:ext>
+                </a:extLst>
+              </p:cNvPr>
+              <p:cNvSpPr txBox="1"/>
+              <p:nvPr/>
+            </p:nvSpPr>
+            <p:spPr>
+              <a:xfrm>
+                <a:off x="1136812" y="4943960"/>
+                <a:ext cx="2081398" cy="584775"/>
+              </a:xfrm>
+              <a:prstGeom prst="rect">
+                <a:avLst/>
+              </a:prstGeom>
+              <a:noFill/>
+            </p:spPr>
+            <p:txBody>
+              <a:bodyPr wrap="square" rtlCol="0">
+                <a:spAutoFit/>
+              </a:bodyPr>
+              <a:lstStyle/>
+              <a:p>
+                <a:pPr algn="ctr"/>
+                <a:r>
+                  <a:rPr kumimoji="1" lang="ja-JP" altLang="en-US" sz="3200">
+                    <a:latin typeface="Hiragino Kaku Gothic StdN W8" panose="020B0800000000000000" pitchFamily="34" charset="-128"/>
+                    <a:ea typeface="Hiragino Kaku Gothic StdN W8" panose="020B0800000000000000" pitchFamily="34" charset="-128"/>
+                  </a:rPr>
+                  <a:t>労働組合</a:t>
+                </a:r>
+              </a:p>
+            </p:txBody>
+          </p:sp>
+        </p:grpSp>
+        <p:grpSp>
+          <p:nvGrpSpPr>
+            <p:cNvPr id="27" name="グループ化 26">
+              <a:extLst>
+                <a:ext uri="{FF2B5EF4-FFF2-40B4-BE49-F238E27FC236}">
+                  <a16:creationId xmlns:a16="http://schemas.microsoft.com/office/drawing/2014/main" id="{C96888A0-07EE-9A21-BECD-71D2E7F8B392}"/>
+                </a:ext>
+              </a:extLst>
+            </p:cNvPr>
+            <p:cNvGrpSpPr/>
+            <p:nvPr/>
+          </p:nvGrpSpPr>
+          <p:grpSpPr>
+            <a:xfrm>
+              <a:off x="7781968" y="5437816"/>
+              <a:ext cx="2774196" cy="3018049"/>
+              <a:chOff x="790413" y="2522350"/>
+              <a:chExt cx="2774196" cy="3018049"/>
+            </a:xfrm>
+          </p:grpSpPr>
+          <p:sp>
+            <p:nvSpPr>
+              <p:cNvPr id="28" name="三角形 27">
+                <a:extLst>
+                  <a:ext uri="{FF2B5EF4-FFF2-40B4-BE49-F238E27FC236}">
+                    <a16:creationId xmlns:a16="http://schemas.microsoft.com/office/drawing/2014/main" id="{8C1BE2F5-D621-F855-98D7-430D2FA7742A}"/>
+                  </a:ext>
+                </a:extLst>
+              </p:cNvPr>
+              <p:cNvSpPr/>
+              <p:nvPr/>
+            </p:nvSpPr>
+            <p:spPr>
+              <a:xfrm>
+                <a:off x="790413" y="2522350"/>
+                <a:ext cx="2774196" cy="2421610"/>
+              </a:xfrm>
+              <a:prstGeom prst="triangle">
+                <a:avLst/>
+              </a:prstGeom>
+              <a:noFill/>
+              <a:ln w="28575">
+                <a:solidFill>
+                  <a:schemeClr val="tx1"/>
+                </a:solidFill>
+              </a:ln>
+            </p:spPr>
+            <p:style>
+              <a:lnRef idx="2">
+                <a:schemeClr val="accent1">
+                  <a:shade val="15000"/>
+                </a:schemeClr>
+              </a:lnRef>
+              <a:fillRef idx="1">
+                <a:schemeClr val="accent1"/>
+              </a:fillRef>
+              <a:effectRef idx="0">
+                <a:schemeClr val="accent1"/>
+              </a:effectRef>
+              <a:fontRef idx="minor">
+                <a:schemeClr val="lt1"/>
+              </a:fontRef>
+            </p:style>
+            <p:txBody>
+              <a:bodyPr rtlCol="0" anchor="ctr"/>
+              <a:lstStyle/>
+              <a:p>
+                <a:pPr algn="ctr"/>
+                <a:endParaRPr kumimoji="1" lang="ja-JP" altLang="en-US"/>
+              </a:p>
+            </p:txBody>
+          </p:sp>
+          <p:sp>
+            <p:nvSpPr>
+              <p:cNvPr id="29" name="円/楕円 28">
+                <a:extLst>
+                  <a:ext uri="{FF2B5EF4-FFF2-40B4-BE49-F238E27FC236}">
+                    <a16:creationId xmlns:a16="http://schemas.microsoft.com/office/drawing/2014/main" id="{6B8D3128-4FF5-7749-3382-A669E04FC76F}"/>
+                  </a:ext>
+                </a:extLst>
+              </p:cNvPr>
+              <p:cNvSpPr/>
+              <p:nvPr/>
+            </p:nvSpPr>
+            <p:spPr>
+              <a:xfrm>
+                <a:off x="1363028" y="4118492"/>
+                <a:ext cx="573438" cy="573438"/>
+              </a:xfrm>
+              <a:prstGeom prst="ellipse">
+                <a:avLst/>
+              </a:prstGeom>
+              <a:noFill/>
+              <a:ln w="19050">
+                <a:solidFill>
+                  <a:schemeClr val="tx1"/>
+                </a:solidFill>
+              </a:ln>
+            </p:spPr>
+            <p:style>
+              <a:lnRef idx="2">
+                <a:schemeClr val="accent1">
+                  <a:shade val="15000"/>
+                </a:schemeClr>
+              </a:lnRef>
+              <a:fillRef idx="1">
+                <a:schemeClr val="accent1"/>
+              </a:fillRef>
+              <a:effectRef idx="0">
+                <a:schemeClr val="accent1"/>
+              </a:effectRef>
+              <a:fontRef idx="minor">
+                <a:schemeClr val="lt1"/>
+              </a:fontRef>
+            </p:style>
+            <p:txBody>
+              <a:bodyPr rtlCol="0" anchor="ctr"/>
+              <a:lstStyle/>
+              <a:p>
+                <a:pPr algn="ctr"/>
+                <a:r>
+                  <a:rPr kumimoji="1" lang="ja-JP" altLang="en-US" sz="2400">
+                    <a:solidFill>
+                      <a:schemeClr val="tx1"/>
+                    </a:solidFill>
+                    <a:latin typeface="Hiragino Sans W4" panose="020B0400000000000000" pitchFamily="34" charset="-128"/>
+                    <a:ea typeface="Hiragino Sans W4" panose="020B0400000000000000" pitchFamily="34" charset="-128"/>
+                  </a:rPr>
+                  <a:t>企</a:t>
+                </a:r>
+              </a:p>
+            </p:txBody>
+          </p:sp>
+          <p:sp>
+            <p:nvSpPr>
+              <p:cNvPr id="30" name="円/楕円 29">
+                <a:extLst>
+                  <a:ext uri="{FF2B5EF4-FFF2-40B4-BE49-F238E27FC236}">
+                    <a16:creationId xmlns:a16="http://schemas.microsoft.com/office/drawing/2014/main" id="{B50D5708-E2FB-153B-7466-E57ED57CE1AF}"/>
+                  </a:ext>
+                </a:extLst>
+              </p:cNvPr>
+              <p:cNvSpPr/>
+              <p:nvPr/>
+            </p:nvSpPr>
+            <p:spPr>
+              <a:xfrm>
+                <a:off x="2463818" y="4118492"/>
+                <a:ext cx="573438" cy="573438"/>
+              </a:xfrm>
+              <a:prstGeom prst="ellipse">
+                <a:avLst/>
+              </a:prstGeom>
+              <a:noFill/>
+              <a:ln w="19050">
+                <a:solidFill>
+                  <a:schemeClr val="tx1"/>
+                </a:solidFill>
+              </a:ln>
+            </p:spPr>
+            <p:style>
+              <a:lnRef idx="2">
+                <a:schemeClr val="accent1">
+                  <a:shade val="15000"/>
+                </a:schemeClr>
+              </a:lnRef>
+              <a:fillRef idx="1">
+                <a:schemeClr val="accent1"/>
+              </a:fillRef>
+              <a:effectRef idx="0">
+                <a:schemeClr val="accent1"/>
+              </a:effectRef>
+              <a:fontRef idx="minor">
+                <a:schemeClr val="lt1"/>
+              </a:fontRef>
+            </p:style>
+            <p:txBody>
+              <a:bodyPr rtlCol="0" anchor="ctr"/>
+              <a:lstStyle/>
+              <a:p>
+                <a:pPr algn="ctr"/>
+                <a:r>
+                  <a:rPr kumimoji="1" lang="ja-JP" altLang="en-US" sz="2400">
+                    <a:solidFill>
+                      <a:schemeClr val="tx1"/>
+                    </a:solidFill>
+                    <a:latin typeface="Hiragino Sans W4" panose="020B0400000000000000" pitchFamily="34" charset="-128"/>
+                    <a:ea typeface="Hiragino Sans W4" panose="020B0400000000000000" pitchFamily="34" charset="-128"/>
+                  </a:rPr>
+                  <a:t>企</a:t>
+                </a:r>
+              </a:p>
+            </p:txBody>
+          </p:sp>
+          <p:sp>
+            <p:nvSpPr>
+              <p:cNvPr id="31" name="円/楕円 30">
+                <a:extLst>
+                  <a:ext uri="{FF2B5EF4-FFF2-40B4-BE49-F238E27FC236}">
+                    <a16:creationId xmlns:a16="http://schemas.microsoft.com/office/drawing/2014/main" id="{8782C489-C147-04B9-40D3-16838A1F5315}"/>
+                  </a:ext>
+                </a:extLst>
+              </p:cNvPr>
+              <p:cNvSpPr/>
+              <p:nvPr/>
+            </p:nvSpPr>
+            <p:spPr>
+              <a:xfrm>
+                <a:off x="1890792" y="3033702"/>
+                <a:ext cx="573438" cy="573438"/>
+              </a:xfrm>
+              <a:prstGeom prst="ellipse">
+                <a:avLst/>
+              </a:prstGeom>
+              <a:noFill/>
+              <a:ln w="19050">
+                <a:solidFill>
+                  <a:schemeClr val="tx1"/>
+                </a:solidFill>
+              </a:ln>
+            </p:spPr>
+            <p:style>
+              <a:lnRef idx="2">
+                <a:schemeClr val="accent1">
+                  <a:shade val="15000"/>
+                </a:schemeClr>
+              </a:lnRef>
+              <a:fillRef idx="1">
+                <a:schemeClr val="accent1"/>
+              </a:fillRef>
+              <a:effectRef idx="0">
+                <a:schemeClr val="accent1"/>
+              </a:effectRef>
+              <a:fontRef idx="minor">
+                <a:schemeClr val="lt1"/>
+              </a:fontRef>
+            </p:style>
+            <p:txBody>
+              <a:bodyPr rtlCol="0" anchor="ctr"/>
+              <a:lstStyle/>
+              <a:p>
+                <a:pPr algn="ctr"/>
+                <a:r>
+                  <a:rPr kumimoji="1" lang="ja-JP" altLang="en-US" sz="2400">
+                    <a:solidFill>
+                      <a:schemeClr val="tx1"/>
+                    </a:solidFill>
+                    <a:latin typeface="Hiragino Sans W4" panose="020B0400000000000000" pitchFamily="34" charset="-128"/>
+                    <a:ea typeface="Hiragino Sans W4" panose="020B0400000000000000" pitchFamily="34" charset="-128"/>
+                  </a:rPr>
+                  <a:t>企</a:t>
+                </a:r>
+              </a:p>
+            </p:txBody>
+          </p:sp>
+          <p:sp>
+            <p:nvSpPr>
+              <p:cNvPr id="32" name="テキスト ボックス 31">
+                <a:extLst>
+                  <a:ext uri="{FF2B5EF4-FFF2-40B4-BE49-F238E27FC236}">
+                    <a16:creationId xmlns:a16="http://schemas.microsoft.com/office/drawing/2014/main" id="{9ECEC042-3289-4801-33D9-2DB0B1D712BD}"/>
+                  </a:ext>
+                </a:extLst>
+              </p:cNvPr>
+              <p:cNvSpPr txBox="1"/>
+              <p:nvPr/>
+            </p:nvSpPr>
+            <p:spPr>
+              <a:xfrm>
+                <a:off x="1033326" y="4955624"/>
+                <a:ext cx="2288369" cy="584775"/>
+              </a:xfrm>
+              <a:prstGeom prst="rect">
+                <a:avLst/>
+              </a:prstGeom>
+              <a:noFill/>
+            </p:spPr>
+            <p:txBody>
+              <a:bodyPr wrap="square" rtlCol="0">
+                <a:spAutoFit/>
+              </a:bodyPr>
+              <a:lstStyle/>
+              <a:p>
+                <a:pPr algn="ctr"/>
+                <a:r>
+                  <a:rPr kumimoji="1" lang="ja-JP" altLang="en-US" sz="3200">
+                    <a:latin typeface="Hiragino Kaku Gothic StdN W8" panose="020B0800000000000000" pitchFamily="34" charset="-128"/>
+                    <a:ea typeface="Hiragino Kaku Gothic StdN W8" panose="020B0800000000000000" pitchFamily="34" charset="-128"/>
+                  </a:rPr>
+                  <a:t>使用者団体</a:t>
+                </a:r>
+              </a:p>
+            </p:txBody>
+          </p:sp>
+        </p:grpSp>
+        <p:grpSp>
+          <p:nvGrpSpPr>
+            <p:cNvPr id="33" name="グループ化 32">
+              <a:extLst>
+                <a:ext uri="{FF2B5EF4-FFF2-40B4-BE49-F238E27FC236}">
+                  <a16:creationId xmlns:a16="http://schemas.microsoft.com/office/drawing/2014/main" id="{19EA6FE8-818B-EEE6-6CF6-47B5643EB5A0}"/>
+                </a:ext>
+              </a:extLst>
+            </p:cNvPr>
+            <p:cNvGrpSpPr/>
+            <p:nvPr/>
+          </p:nvGrpSpPr>
+          <p:grpSpPr>
+            <a:xfrm>
+              <a:off x="9236991" y="2522350"/>
+              <a:ext cx="2774196" cy="3018049"/>
+              <a:chOff x="790413" y="2522350"/>
+              <a:chExt cx="2774196" cy="3018049"/>
+            </a:xfrm>
+          </p:grpSpPr>
+          <p:sp>
+            <p:nvSpPr>
+              <p:cNvPr id="34" name="三角形 33">
+                <a:extLst>
+                  <a:ext uri="{FF2B5EF4-FFF2-40B4-BE49-F238E27FC236}">
+                    <a16:creationId xmlns:a16="http://schemas.microsoft.com/office/drawing/2014/main" id="{2D1F9528-C60D-F62C-0946-18844D00D6DE}"/>
+                  </a:ext>
+                </a:extLst>
+              </p:cNvPr>
+              <p:cNvSpPr/>
+              <p:nvPr/>
+            </p:nvSpPr>
+            <p:spPr>
+              <a:xfrm>
+                <a:off x="790413" y="2522350"/>
+                <a:ext cx="2774196" cy="2421610"/>
+              </a:xfrm>
+              <a:prstGeom prst="triangle">
+                <a:avLst/>
+              </a:prstGeom>
+              <a:noFill/>
+              <a:ln w="28575">
+                <a:solidFill>
+                  <a:schemeClr val="tx1"/>
+                </a:solidFill>
+              </a:ln>
+            </p:spPr>
+            <p:style>
+              <a:lnRef idx="2">
+                <a:schemeClr val="accent1">
+                  <a:shade val="15000"/>
+                </a:schemeClr>
+              </a:lnRef>
+              <a:fillRef idx="1">
+                <a:schemeClr val="accent1"/>
+              </a:fillRef>
+              <a:effectRef idx="0">
+                <a:schemeClr val="accent1"/>
+              </a:effectRef>
+              <a:fontRef idx="minor">
+                <a:schemeClr val="lt1"/>
+              </a:fontRef>
+            </p:style>
+            <p:txBody>
+              <a:bodyPr rtlCol="0" anchor="ctr"/>
+              <a:lstStyle/>
+              <a:p>
+                <a:pPr algn="ctr"/>
+                <a:endParaRPr kumimoji="1" lang="ja-JP" altLang="en-US"/>
+              </a:p>
+            </p:txBody>
+          </p:sp>
+          <p:sp>
+            <p:nvSpPr>
+              <p:cNvPr id="35" name="円/楕円 34">
+                <a:extLst>
+                  <a:ext uri="{FF2B5EF4-FFF2-40B4-BE49-F238E27FC236}">
+                    <a16:creationId xmlns:a16="http://schemas.microsoft.com/office/drawing/2014/main" id="{70A284DC-12BB-9746-72F0-1DBB72C7B97E}"/>
+                  </a:ext>
+                </a:extLst>
+              </p:cNvPr>
+              <p:cNvSpPr/>
+              <p:nvPr/>
+            </p:nvSpPr>
+            <p:spPr>
+              <a:xfrm>
+                <a:off x="1363028" y="4118492"/>
+                <a:ext cx="573438" cy="573438"/>
+              </a:xfrm>
+              <a:prstGeom prst="ellipse">
+                <a:avLst/>
+              </a:prstGeom>
+              <a:noFill/>
+              <a:ln w="19050">
+                <a:solidFill>
+                  <a:schemeClr val="tx1"/>
+                </a:solidFill>
+              </a:ln>
+            </p:spPr>
+            <p:style>
+              <a:lnRef idx="2">
+                <a:schemeClr val="accent1">
+                  <a:shade val="15000"/>
+                </a:schemeClr>
+              </a:lnRef>
+              <a:fillRef idx="1">
+                <a:schemeClr val="accent1"/>
+              </a:fillRef>
+              <a:effectRef idx="0">
+                <a:schemeClr val="accent1"/>
+              </a:effectRef>
+              <a:fontRef idx="minor">
+                <a:schemeClr val="lt1"/>
+              </a:fontRef>
+            </p:style>
+            <p:txBody>
+              <a:bodyPr rtlCol="0" anchor="ctr"/>
+              <a:lstStyle/>
+              <a:p>
+                <a:pPr algn="ctr"/>
+                <a:r>
+                  <a:rPr kumimoji="1" lang="ja-JP" altLang="en-US" sz="2400">
+                    <a:solidFill>
+                      <a:schemeClr val="tx1"/>
+                    </a:solidFill>
+                    <a:latin typeface="Hiragino Sans W4" panose="020B0400000000000000" pitchFamily="34" charset="-128"/>
+                    <a:ea typeface="Hiragino Sans W4" panose="020B0400000000000000" pitchFamily="34" charset="-128"/>
+                  </a:rPr>
+                  <a:t>企</a:t>
+                </a:r>
+              </a:p>
+            </p:txBody>
+          </p:sp>
+          <p:sp>
+            <p:nvSpPr>
+              <p:cNvPr id="36" name="円/楕円 35">
+                <a:extLst>
+                  <a:ext uri="{FF2B5EF4-FFF2-40B4-BE49-F238E27FC236}">
+                    <a16:creationId xmlns:a16="http://schemas.microsoft.com/office/drawing/2014/main" id="{157A1591-F809-DDDA-9730-4A2CF0D76DED}"/>
+                  </a:ext>
+                </a:extLst>
+              </p:cNvPr>
+              <p:cNvSpPr/>
+              <p:nvPr/>
+            </p:nvSpPr>
+            <p:spPr>
+              <a:xfrm>
+                <a:off x="2463818" y="4118492"/>
+                <a:ext cx="573438" cy="573438"/>
+              </a:xfrm>
+              <a:prstGeom prst="ellipse">
+                <a:avLst/>
+              </a:prstGeom>
+              <a:noFill/>
+              <a:ln w="19050">
+                <a:solidFill>
+                  <a:schemeClr val="tx1"/>
+                </a:solidFill>
+              </a:ln>
+            </p:spPr>
+            <p:style>
+              <a:lnRef idx="2">
+                <a:schemeClr val="accent1">
+                  <a:shade val="15000"/>
+                </a:schemeClr>
+              </a:lnRef>
+              <a:fillRef idx="1">
+                <a:schemeClr val="accent1"/>
+              </a:fillRef>
+              <a:effectRef idx="0">
+                <a:schemeClr val="accent1"/>
+              </a:effectRef>
+              <a:fontRef idx="minor">
+                <a:schemeClr val="lt1"/>
+              </a:fontRef>
+            </p:style>
+            <p:txBody>
+              <a:bodyPr rtlCol="0" anchor="ctr"/>
+              <a:lstStyle/>
+              <a:p>
+                <a:pPr algn="ctr"/>
+                <a:r>
+                  <a:rPr kumimoji="1" lang="ja-JP" altLang="en-US" sz="2400">
+                    <a:solidFill>
+                      <a:schemeClr val="tx1"/>
+                    </a:solidFill>
+                    <a:latin typeface="Hiragino Sans W4" panose="020B0400000000000000" pitchFamily="34" charset="-128"/>
+                    <a:ea typeface="Hiragino Sans W4" panose="020B0400000000000000" pitchFamily="34" charset="-128"/>
+                  </a:rPr>
+                  <a:t>企</a:t>
+                </a:r>
+              </a:p>
+            </p:txBody>
+          </p:sp>
+          <p:sp>
+            <p:nvSpPr>
+              <p:cNvPr id="37" name="円/楕円 36">
+                <a:extLst>
+                  <a:ext uri="{FF2B5EF4-FFF2-40B4-BE49-F238E27FC236}">
+                    <a16:creationId xmlns:a16="http://schemas.microsoft.com/office/drawing/2014/main" id="{6D6C271C-F0AD-CAB6-4932-AAC0C9E265E8}"/>
+                  </a:ext>
+                </a:extLst>
+              </p:cNvPr>
+              <p:cNvSpPr/>
+              <p:nvPr/>
+            </p:nvSpPr>
+            <p:spPr>
+              <a:xfrm>
+                <a:off x="1890792" y="3033702"/>
+                <a:ext cx="573438" cy="573438"/>
+              </a:xfrm>
+              <a:prstGeom prst="ellipse">
+                <a:avLst/>
+              </a:prstGeom>
+              <a:noFill/>
+              <a:ln w="19050">
+                <a:solidFill>
+                  <a:schemeClr val="tx1"/>
+                </a:solidFill>
+              </a:ln>
+            </p:spPr>
+            <p:style>
+              <a:lnRef idx="2">
+                <a:schemeClr val="accent1">
+                  <a:shade val="15000"/>
+                </a:schemeClr>
+              </a:lnRef>
+              <a:fillRef idx="1">
+                <a:schemeClr val="accent1"/>
+              </a:fillRef>
+              <a:effectRef idx="0">
+                <a:schemeClr val="accent1"/>
+              </a:effectRef>
+              <a:fontRef idx="minor">
+                <a:schemeClr val="lt1"/>
+              </a:fontRef>
+            </p:style>
+            <p:txBody>
+              <a:bodyPr rtlCol="0" anchor="ctr"/>
+              <a:lstStyle/>
+              <a:p>
+                <a:pPr algn="ctr"/>
+                <a:r>
+                  <a:rPr kumimoji="1" lang="ja-JP" altLang="en-US" sz="2400">
+                    <a:solidFill>
+                      <a:schemeClr val="tx1"/>
+                    </a:solidFill>
+                    <a:latin typeface="Hiragino Sans W4" panose="020B0400000000000000" pitchFamily="34" charset="-128"/>
+                    <a:ea typeface="Hiragino Sans W4" panose="020B0400000000000000" pitchFamily="34" charset="-128"/>
+                  </a:rPr>
+                  <a:t>企</a:t>
+                </a:r>
+              </a:p>
+            </p:txBody>
+          </p:sp>
+          <p:sp>
+            <p:nvSpPr>
+              <p:cNvPr id="38" name="テキスト ボックス 37">
+                <a:extLst>
+                  <a:ext uri="{FF2B5EF4-FFF2-40B4-BE49-F238E27FC236}">
+                    <a16:creationId xmlns:a16="http://schemas.microsoft.com/office/drawing/2014/main" id="{6B307519-1446-C959-28AD-BCDE98AEFA12}"/>
+                  </a:ext>
+                </a:extLst>
+              </p:cNvPr>
+              <p:cNvSpPr txBox="1"/>
+              <p:nvPr/>
+            </p:nvSpPr>
+            <p:spPr>
+              <a:xfrm>
+                <a:off x="1033326" y="4955624"/>
+                <a:ext cx="2288369" cy="584775"/>
+              </a:xfrm>
+              <a:prstGeom prst="rect">
+                <a:avLst/>
+              </a:prstGeom>
+              <a:noFill/>
+            </p:spPr>
+            <p:txBody>
+              <a:bodyPr wrap="square" rtlCol="0">
+                <a:spAutoFit/>
+              </a:bodyPr>
+              <a:lstStyle/>
+              <a:p>
+                <a:pPr algn="ctr"/>
+                <a:r>
+                  <a:rPr kumimoji="1" lang="ja-JP" altLang="en-US" sz="3200">
+                    <a:latin typeface="Hiragino Kaku Gothic StdN W8" panose="020B0800000000000000" pitchFamily="34" charset="-128"/>
+                    <a:ea typeface="Hiragino Kaku Gothic StdN W8" panose="020B0800000000000000" pitchFamily="34" charset="-128"/>
+                  </a:rPr>
+                  <a:t>使用者団体</a:t>
+                </a:r>
+              </a:p>
+            </p:txBody>
+          </p:sp>
+        </p:grpSp>
+        <p:cxnSp>
+          <p:nvCxnSpPr>
+            <p:cNvPr id="43" name="直線矢印コネクタ 42">
+              <a:extLst>
+                <a:ext uri="{FF2B5EF4-FFF2-40B4-BE49-F238E27FC236}">
+                  <a16:creationId xmlns:a16="http://schemas.microsoft.com/office/drawing/2014/main" id="{F4510149-27CF-0560-C8E7-D42022986622}"/>
+                </a:ext>
+              </a:extLst>
+            </p:cNvPr>
+            <p:cNvCxnSpPr>
+              <a:cxnSpLocks/>
+              <a:stCxn id="14" idx="0"/>
+              <a:endCxn id="10" idx="2"/>
+            </p:cNvCxnSpPr>
+            <p:nvPr/>
+          </p:nvCxnSpPr>
+          <p:spPr>
+            <a:xfrm flipV="1">
+              <a:off x="2177511" y="1219200"/>
+              <a:ext cx="4223289" cy="1303150"/>
+            </a:xfrm>
+            <a:prstGeom prst="straightConnector1">
+              <a:avLst/>
+            </a:prstGeom>
+            <a:ln w="63500" cap="sq">
+              <a:solidFill>
+                <a:srgbClr val="FF0000"/>
+              </a:solidFill>
+              <a:headEnd type="none"/>
+              <a:tailEnd type="stealth"/>
+            </a:ln>
+          </p:spPr>
+          <p:style>
+            <a:lnRef idx="1">
+              <a:schemeClr val="accent1"/>
+            </a:lnRef>
+            <a:fillRef idx="0">
+              <a:schemeClr val="accent1"/>
+            </a:fillRef>
+            <a:effectRef idx="0">
+              <a:schemeClr val="accent1"/>
+            </a:effectRef>
+            <a:fontRef idx="minor">
+              <a:schemeClr val="tx1"/>
+            </a:fontRef>
+          </p:style>
+        </p:cxnSp>
+        <p:cxnSp>
+          <p:nvCxnSpPr>
+            <p:cNvPr id="47" name="直線矢印コネクタ 46">
+              <a:extLst>
+                <a:ext uri="{FF2B5EF4-FFF2-40B4-BE49-F238E27FC236}">
+                  <a16:creationId xmlns:a16="http://schemas.microsoft.com/office/drawing/2014/main" id="{DD4DD2B8-9560-2B50-BE29-95D927A6282C}"/>
+                </a:ext>
+              </a:extLst>
+            </p:cNvPr>
+            <p:cNvCxnSpPr>
+              <a:cxnSpLocks/>
+              <a:stCxn id="22" idx="0"/>
+              <a:endCxn id="10" idx="2"/>
+            </p:cNvCxnSpPr>
+            <p:nvPr/>
+          </p:nvCxnSpPr>
+          <p:spPr>
+            <a:xfrm flipV="1">
+              <a:off x="3632534" y="1219200"/>
+              <a:ext cx="2768266" cy="4230280"/>
+            </a:xfrm>
+            <a:prstGeom prst="straightConnector1">
+              <a:avLst/>
+            </a:prstGeom>
+            <a:ln w="63500" cap="sq">
+              <a:solidFill>
+                <a:srgbClr val="FF0000"/>
+              </a:solidFill>
+              <a:headEnd type="none"/>
+              <a:tailEnd type="stealth"/>
+            </a:ln>
+          </p:spPr>
+          <p:style>
+            <a:lnRef idx="1">
+              <a:schemeClr val="accent1"/>
+            </a:lnRef>
+            <a:fillRef idx="0">
+              <a:schemeClr val="accent1"/>
+            </a:fillRef>
+            <a:effectRef idx="0">
+              <a:schemeClr val="accent1"/>
+            </a:effectRef>
+            <a:fontRef idx="minor">
+              <a:schemeClr val="tx1"/>
+            </a:fontRef>
+          </p:style>
+        </p:cxnSp>
+        <p:cxnSp>
+          <p:nvCxnSpPr>
+            <p:cNvPr id="50" name="直線矢印コネクタ 49">
+              <a:extLst>
+                <a:ext uri="{FF2B5EF4-FFF2-40B4-BE49-F238E27FC236}">
+                  <a16:creationId xmlns:a16="http://schemas.microsoft.com/office/drawing/2014/main" id="{EF9AC690-144C-0106-CC1C-1B8E7CCCBBD3}"/>
+                </a:ext>
+              </a:extLst>
+            </p:cNvPr>
+            <p:cNvCxnSpPr>
+              <a:cxnSpLocks/>
+              <a:stCxn id="28" idx="0"/>
+              <a:endCxn id="10" idx="2"/>
+            </p:cNvCxnSpPr>
+            <p:nvPr/>
+          </p:nvCxnSpPr>
+          <p:spPr>
+            <a:xfrm flipH="1" flipV="1">
+              <a:off x="6400800" y="1219200"/>
+              <a:ext cx="2768266" cy="4218616"/>
+            </a:xfrm>
+            <a:prstGeom prst="straightConnector1">
+              <a:avLst/>
+            </a:prstGeom>
+            <a:ln w="63500" cap="sq">
+              <a:solidFill>
+                <a:srgbClr val="FF0000"/>
+              </a:solidFill>
+              <a:headEnd type="none"/>
+              <a:tailEnd type="stealth"/>
+            </a:ln>
+          </p:spPr>
+          <p:style>
+            <a:lnRef idx="1">
+              <a:schemeClr val="accent1"/>
+            </a:lnRef>
+            <a:fillRef idx="0">
+              <a:schemeClr val="accent1"/>
+            </a:fillRef>
+            <a:effectRef idx="0">
+              <a:schemeClr val="accent1"/>
+            </a:effectRef>
+            <a:fontRef idx="minor">
+              <a:schemeClr val="tx1"/>
+            </a:fontRef>
+          </p:style>
+        </p:cxnSp>
+        <p:cxnSp>
+          <p:nvCxnSpPr>
+            <p:cNvPr id="55" name="直線矢印コネクタ 54">
+              <a:extLst>
+                <a:ext uri="{FF2B5EF4-FFF2-40B4-BE49-F238E27FC236}">
+                  <a16:creationId xmlns:a16="http://schemas.microsoft.com/office/drawing/2014/main" id="{3B251AB8-B8DD-C99A-2FF2-13C08E2ACDA9}"/>
+                </a:ext>
+              </a:extLst>
+            </p:cNvPr>
+            <p:cNvCxnSpPr>
+              <a:cxnSpLocks/>
+              <a:stCxn id="34" idx="0"/>
+              <a:endCxn id="10" idx="2"/>
+            </p:cNvCxnSpPr>
+            <p:nvPr/>
+          </p:nvCxnSpPr>
+          <p:spPr>
+            <a:xfrm flipH="1" flipV="1">
+              <a:off x="6400800" y="1219200"/>
+              <a:ext cx="4223289" cy="1303150"/>
+            </a:xfrm>
+            <a:prstGeom prst="straightConnector1">
+              <a:avLst/>
+            </a:prstGeom>
+            <a:ln w="63500" cap="sq">
+              <a:solidFill>
+                <a:srgbClr val="FF0000"/>
+              </a:solidFill>
+              <a:headEnd type="none"/>
+              <a:tailEnd type="stealth"/>
+            </a:ln>
+          </p:spPr>
+          <p:style>
+            <a:lnRef idx="1">
+              <a:schemeClr val="accent1"/>
+            </a:lnRef>
+            <a:fillRef idx="0">
+              <a:schemeClr val="accent1"/>
+            </a:fillRef>
+            <a:effectRef idx="0">
+              <a:schemeClr val="accent1"/>
+            </a:effectRef>
+            <a:fontRef idx="minor">
+              <a:schemeClr val="tx1"/>
+            </a:fontRef>
+          </p:style>
+        </p:cxnSp>
+        <p:cxnSp>
+          <p:nvCxnSpPr>
+            <p:cNvPr id="62" name="直線矢印コネクタ 61">
+              <a:extLst>
+                <a:ext uri="{FF2B5EF4-FFF2-40B4-BE49-F238E27FC236}">
+                  <a16:creationId xmlns:a16="http://schemas.microsoft.com/office/drawing/2014/main" id="{CDDD4E37-8783-C4D1-E2F2-9EBF0B54FD16}"/>
+                </a:ext>
+              </a:extLst>
+            </p:cNvPr>
+            <p:cNvCxnSpPr>
+              <a:cxnSpLocks/>
+              <a:stCxn id="28" idx="1"/>
+              <a:endCxn id="22" idx="5"/>
+            </p:cNvCxnSpPr>
+            <p:nvPr/>
+          </p:nvCxnSpPr>
+          <p:spPr>
+            <a:xfrm flipH="1">
+              <a:off x="4326083" y="6648621"/>
+              <a:ext cx="4149434" cy="11664"/>
+            </a:xfrm>
+            <a:prstGeom prst="straightConnector1">
+              <a:avLst/>
+            </a:prstGeom>
+            <a:ln w="63500" cap="sq" cmpd="dbl">
+              <a:solidFill>
+                <a:schemeClr val="tx1"/>
+              </a:solidFill>
+              <a:headEnd type="stealth"/>
+              <a:tailEnd type="stealth"/>
+            </a:ln>
+          </p:spPr>
+          <p:style>
+            <a:lnRef idx="1">
+              <a:schemeClr val="accent1"/>
+            </a:lnRef>
+            <a:fillRef idx="0">
+              <a:schemeClr val="accent1"/>
+            </a:fillRef>
+            <a:effectRef idx="0">
+              <a:schemeClr val="accent1"/>
+            </a:effectRef>
+            <a:fontRef idx="minor">
+              <a:schemeClr val="tx1"/>
+            </a:fontRef>
+          </p:style>
+        </p:cxnSp>
+        <p:cxnSp>
+          <p:nvCxnSpPr>
+            <p:cNvPr id="66" name="直線矢印コネクタ 65">
+              <a:extLst>
+                <a:ext uri="{FF2B5EF4-FFF2-40B4-BE49-F238E27FC236}">
+                  <a16:creationId xmlns:a16="http://schemas.microsoft.com/office/drawing/2014/main" id="{39A300DE-16E7-A5A9-B18E-39140C6F548C}"/>
+                </a:ext>
+              </a:extLst>
+            </p:cNvPr>
+            <p:cNvCxnSpPr>
+              <a:cxnSpLocks/>
+              <a:stCxn id="34" idx="1"/>
+              <a:endCxn id="14" idx="5"/>
+            </p:cNvCxnSpPr>
+            <p:nvPr/>
+          </p:nvCxnSpPr>
+          <p:spPr>
+            <a:xfrm flipH="1">
+              <a:off x="2871060" y="3733155"/>
+              <a:ext cx="7059480" cy="0"/>
+            </a:xfrm>
+            <a:prstGeom prst="straightConnector1">
+              <a:avLst/>
+            </a:prstGeom>
+            <a:ln w="63500" cap="sq" cmpd="dbl">
+              <a:solidFill>
+                <a:schemeClr val="tx1"/>
+              </a:solidFill>
+              <a:headEnd type="stealth"/>
+              <a:tailEnd type="stealth"/>
+            </a:ln>
+          </p:spPr>
+          <p:style>
+            <a:lnRef idx="1">
+              <a:schemeClr val="accent1"/>
+            </a:lnRef>
+            <a:fillRef idx="0">
+              <a:schemeClr val="accent1"/>
+            </a:fillRef>
+            <a:effectRef idx="0">
+              <a:schemeClr val="accent1"/>
+            </a:effectRef>
+            <a:fontRef idx="minor">
+              <a:schemeClr val="tx1"/>
+            </a:fontRef>
+          </p:style>
+        </p:cxnSp>
+        <p:sp>
+          <p:nvSpPr>
+            <p:cNvPr id="70" name="テキスト ボックス 69">
+              <a:extLst>
+                <a:ext uri="{FF2B5EF4-FFF2-40B4-BE49-F238E27FC236}">
+                  <a16:creationId xmlns:a16="http://schemas.microsoft.com/office/drawing/2014/main" id="{DA212AA4-0F75-CCDE-21C4-80852F5C45D1}"/>
+                </a:ext>
+              </a:extLst>
+            </p:cNvPr>
+            <p:cNvSpPr txBox="1"/>
+            <p:nvPr/>
+          </p:nvSpPr>
+          <p:spPr>
+            <a:xfrm>
+              <a:off x="8247696" y="1409110"/>
+              <a:ext cx="1415772" cy="461665"/>
+            </a:xfrm>
+            <a:prstGeom prst="rect">
+              <a:avLst/>
+            </a:prstGeom>
+            <a:noFill/>
+            <a:ln>
+              <a:noFill/>
+            </a:ln>
+          </p:spPr>
+          <p:txBody>
+            <a:bodyPr wrap="none" rtlCol="0">
+              <a:spAutoFit/>
+            </a:bodyPr>
+            <a:lstStyle/>
+            <a:p>
+              <a:pPr algn="ctr"/>
+              <a:r>
+                <a:rPr kumimoji="1" lang="ja-JP" altLang="en-US" sz="2400">
+                  <a:solidFill>
+                    <a:srgbClr val="FF0000"/>
+                  </a:solidFill>
+                  <a:latin typeface="Hiragino Sans W4" panose="020B0400000000000000" pitchFamily="34" charset="-128"/>
+                  <a:ea typeface="Hiragino Sans W4" panose="020B0400000000000000" pitchFamily="34" charset="-128"/>
+                </a:rPr>
+                <a:t>働きかけ</a:t>
+              </a:r>
+            </a:p>
+          </p:txBody>
+        </p:sp>
+        <p:sp>
+          <p:nvSpPr>
+            <p:cNvPr id="72" name="テキスト ボックス 71">
+              <a:extLst>
+                <a:ext uri="{FF2B5EF4-FFF2-40B4-BE49-F238E27FC236}">
+                  <a16:creationId xmlns:a16="http://schemas.microsoft.com/office/drawing/2014/main" id="{EE775F73-48AF-D561-0BDC-0FFB2F28BC69}"/>
+                </a:ext>
+              </a:extLst>
+            </p:cNvPr>
+            <p:cNvSpPr txBox="1"/>
+            <p:nvPr/>
+          </p:nvSpPr>
+          <p:spPr>
+            <a:xfrm>
+              <a:off x="5692913" y="3871061"/>
+              <a:ext cx="1415772" cy="461665"/>
+            </a:xfrm>
+            <a:prstGeom prst="rect">
+              <a:avLst/>
+            </a:prstGeom>
+            <a:noFill/>
+            <a:ln>
+              <a:noFill/>
+            </a:ln>
+          </p:spPr>
+          <p:txBody>
+            <a:bodyPr wrap="none" rtlCol="0">
+              <a:spAutoFit/>
+            </a:bodyPr>
+            <a:lstStyle/>
+            <a:p>
+              <a:pPr algn="ctr"/>
+              <a:r>
+                <a:rPr kumimoji="1" lang="ja-JP" altLang="en-US" sz="2400">
+                  <a:latin typeface="Hiragino Sans W4" panose="020B0400000000000000" pitchFamily="34" charset="-128"/>
+                  <a:ea typeface="Hiragino Sans W4" panose="020B0400000000000000" pitchFamily="34" charset="-128"/>
+                </a:rPr>
+                <a:t>労使交渉</a:t>
+              </a:r>
+            </a:p>
+          </p:txBody>
+        </p:sp>
+        <p:sp>
+          <p:nvSpPr>
+            <p:cNvPr id="73" name="テキスト ボックス 72">
+              <a:extLst>
+                <a:ext uri="{FF2B5EF4-FFF2-40B4-BE49-F238E27FC236}">
+                  <a16:creationId xmlns:a16="http://schemas.microsoft.com/office/drawing/2014/main" id="{D00B7ABE-612F-FF98-00AB-BBCD6EB6C86E}"/>
+                </a:ext>
+              </a:extLst>
+            </p:cNvPr>
+            <p:cNvSpPr txBox="1"/>
+            <p:nvPr/>
+          </p:nvSpPr>
+          <p:spPr>
+            <a:xfrm>
+              <a:off x="5692913" y="6798190"/>
+              <a:ext cx="1415772" cy="461665"/>
+            </a:xfrm>
+            <a:prstGeom prst="rect">
+              <a:avLst/>
+            </a:prstGeom>
+            <a:noFill/>
+            <a:ln>
+              <a:noFill/>
+            </a:ln>
+          </p:spPr>
+          <p:txBody>
+            <a:bodyPr wrap="none" rtlCol="0">
+              <a:spAutoFit/>
+            </a:bodyPr>
+            <a:lstStyle/>
+            <a:p>
+              <a:pPr algn="ctr"/>
+              <a:r>
+                <a:rPr kumimoji="1" lang="ja-JP" altLang="en-US" sz="2400">
+                  <a:latin typeface="Hiragino Sans W4" panose="020B0400000000000000" pitchFamily="34" charset="-128"/>
+                  <a:ea typeface="Hiragino Sans W4" panose="020B0400000000000000" pitchFamily="34" charset="-128"/>
+                </a:rPr>
+                <a:t>労使交渉</a:t>
+              </a:r>
+            </a:p>
+          </p:txBody>
+        </p:sp>
+      </p:grpSp>
+    </p:spTree>
+    <p:extLst>
+      <p:ext uri="{BB962C8B-B14F-4D97-AF65-F5344CB8AC3E}">
+        <p14:creationId xmlns:p14="http://schemas.microsoft.com/office/powerpoint/2010/main" val="2261260219"/>
+      </p:ext>
+    </p:extLst>
+  </p:cSld>
+  <p:clrMapOvr>
+    <a:masterClrMapping/>
+  </p:clrMapOvr>
+</p:sld>
+</file>
+
+<file path=ppt/slides/slide19.xml><?xml version="1.0" encoding="utf-8"?>
+<p:sld xmlns:a="http://schemas.openxmlformats.org/drawingml/2006/main" xmlns:r="http://schemas.openxmlformats.org/officeDocument/2006/relationships" xmlns:p="http://schemas.openxmlformats.org/presentationml/2006/main">
+  <p:cSld>
+    <p:spTree>
+      <p:nvGrpSpPr>
+        <p:cNvPr id="1" name=""/>
+        <p:cNvGrpSpPr/>
+        <p:nvPr/>
+      </p:nvGrpSpPr>
+      <p:grpSpPr>
+        <a:xfrm>
+          <a:off x="0" y="0"/>
+          <a:ext cx="0" cy="0"/>
+          <a:chOff x="0" y="0"/>
+          <a:chExt cx="0" cy="0"/>
+        </a:xfrm>
+      </p:grpSpPr>
+      <p:grpSp>
+        <p:nvGrpSpPr>
+          <p:cNvPr id="84" name="グループ化 83">
+            <a:extLst>
+              <a:ext uri="{FF2B5EF4-FFF2-40B4-BE49-F238E27FC236}">
+                <a16:creationId xmlns:a16="http://schemas.microsoft.com/office/drawing/2014/main" id="{EEFF685C-DBCB-4E87-CD92-21D93E29F6AC}"/>
+              </a:ext>
+            </a:extLst>
+          </p:cNvPr>
+          <p:cNvGrpSpPr/>
+          <p:nvPr/>
+        </p:nvGrpSpPr>
+        <p:grpSpPr>
+          <a:xfrm>
+            <a:off x="230657" y="508900"/>
+            <a:ext cx="12340286" cy="7973190"/>
+            <a:chOff x="229980" y="241614"/>
+            <a:chExt cx="12340286" cy="7973190"/>
+          </a:xfrm>
+        </p:grpSpPr>
+        <p:sp>
+          <p:nvSpPr>
+            <p:cNvPr id="2" name="角丸四角形 1">
+              <a:extLst>
+                <a:ext uri="{FF2B5EF4-FFF2-40B4-BE49-F238E27FC236}">
+                  <a16:creationId xmlns:a16="http://schemas.microsoft.com/office/drawing/2014/main" id="{02F5795D-0BF8-3A32-511E-F653846F61DD}"/>
+                </a:ext>
+              </a:extLst>
+            </p:cNvPr>
+            <p:cNvSpPr/>
+            <p:nvPr/>
+          </p:nvSpPr>
+          <p:spPr>
+            <a:xfrm>
+              <a:off x="5262001" y="241614"/>
+              <a:ext cx="2277597" cy="836909"/>
+            </a:xfrm>
+            <a:prstGeom prst="roundRect">
+              <a:avLst/>
+            </a:prstGeom>
+            <a:noFill/>
+            <a:ln w="28575">
+              <a:solidFill>
+                <a:schemeClr val="tx1"/>
+              </a:solidFill>
+            </a:ln>
+          </p:spPr>
+          <p:style>
+            <a:lnRef idx="2">
+              <a:schemeClr val="accent1">
+                <a:shade val="15000"/>
+              </a:schemeClr>
+            </a:lnRef>
+            <a:fillRef idx="1">
+              <a:schemeClr val="accent1"/>
+            </a:fillRef>
+            <a:effectRef idx="0">
+              <a:schemeClr val="accent1"/>
+            </a:effectRef>
+            <a:fontRef idx="minor">
+              <a:schemeClr val="lt1"/>
+            </a:fontRef>
+          </p:style>
+          <p:txBody>
+            <a:bodyPr rtlCol="0" anchor="ctr"/>
+            <a:lstStyle/>
+            <a:p>
+              <a:pPr algn="ctr"/>
+              <a:r>
+                <a:rPr kumimoji="1" lang="ja-JP" altLang="en-US" sz="4400">
+                  <a:solidFill>
+                    <a:schemeClr val="tx1"/>
+                  </a:solidFill>
+                  <a:latin typeface="Hiragino Kaku Gothic StdN W8" panose="020B0800000000000000" pitchFamily="34" charset="-128"/>
+                  <a:ea typeface="Hiragino Kaku Gothic StdN W8" panose="020B0800000000000000" pitchFamily="34" charset="-128"/>
+                </a:rPr>
+                <a:t>政府</a:t>
+              </a:r>
+              <a:endParaRPr kumimoji="1" lang="ja-JP" altLang="en-US" sz="3000"/>
+            </a:p>
+          </p:txBody>
+        </p:sp>
+        <p:grpSp>
+          <p:nvGrpSpPr>
+            <p:cNvPr id="9" name="グループ化 8">
+              <a:extLst>
+                <a:ext uri="{FF2B5EF4-FFF2-40B4-BE49-F238E27FC236}">
+                  <a16:creationId xmlns:a16="http://schemas.microsoft.com/office/drawing/2014/main" id="{64A915C2-413A-0C14-BD6A-AC5D03220E02}"/>
+                </a:ext>
+              </a:extLst>
+            </p:cNvPr>
+            <p:cNvGrpSpPr/>
+            <p:nvPr/>
+          </p:nvGrpSpPr>
+          <p:grpSpPr>
+            <a:xfrm>
+              <a:off x="229980" y="6125122"/>
+              <a:ext cx="1840245" cy="2089682"/>
+              <a:chOff x="579398" y="5504701"/>
+              <a:chExt cx="2774196" cy="2995075"/>
+            </a:xfrm>
+          </p:grpSpPr>
+          <p:sp>
+            <p:nvSpPr>
+              <p:cNvPr id="4" name="三角形 3">
+                <a:extLst>
+                  <a:ext uri="{FF2B5EF4-FFF2-40B4-BE49-F238E27FC236}">
+                    <a16:creationId xmlns:a16="http://schemas.microsoft.com/office/drawing/2014/main" id="{3E4D3F3A-5683-24F3-14E2-63A0B116513B}"/>
+                  </a:ext>
+                </a:extLst>
+              </p:cNvPr>
+              <p:cNvSpPr/>
+              <p:nvPr/>
+            </p:nvSpPr>
+            <p:spPr>
+              <a:xfrm>
+                <a:off x="579398" y="5504701"/>
+                <a:ext cx="2774196" cy="2421610"/>
+              </a:xfrm>
+              <a:prstGeom prst="triangle">
+                <a:avLst/>
+              </a:prstGeom>
+              <a:noFill/>
+              <a:ln w="28575">
+                <a:solidFill>
+                  <a:schemeClr val="tx1"/>
+                </a:solidFill>
+              </a:ln>
+            </p:spPr>
+            <p:style>
+              <a:lnRef idx="2">
+                <a:schemeClr val="accent1">
+                  <a:shade val="15000"/>
+                </a:schemeClr>
+              </a:lnRef>
+              <a:fillRef idx="1">
+                <a:schemeClr val="accent1"/>
+              </a:fillRef>
+              <a:effectRef idx="0">
+                <a:schemeClr val="accent1"/>
+              </a:effectRef>
+              <a:fontRef idx="minor">
+                <a:schemeClr val="lt1"/>
+              </a:fontRef>
+            </p:style>
+            <p:txBody>
+              <a:bodyPr rtlCol="0" anchor="ctr"/>
+              <a:lstStyle/>
+              <a:p>
+                <a:pPr algn="ctr"/>
+                <a:endParaRPr kumimoji="1" lang="ja-JP" altLang="en-US"/>
+              </a:p>
+            </p:txBody>
+          </p:sp>
+          <p:sp>
+            <p:nvSpPr>
+              <p:cNvPr id="5" name="円/楕円 4">
+                <a:extLst>
+                  <a:ext uri="{FF2B5EF4-FFF2-40B4-BE49-F238E27FC236}">
+                    <a16:creationId xmlns:a16="http://schemas.microsoft.com/office/drawing/2014/main" id="{522234F1-1001-207B-43A9-B187851D9CAE}"/>
+                  </a:ext>
+                </a:extLst>
+              </p:cNvPr>
+              <p:cNvSpPr/>
+              <p:nvPr/>
+            </p:nvSpPr>
+            <p:spPr>
+              <a:xfrm>
+                <a:off x="1152013" y="7100843"/>
+                <a:ext cx="573438" cy="573438"/>
+              </a:xfrm>
+              <a:prstGeom prst="ellipse">
+                <a:avLst/>
+              </a:prstGeom>
+              <a:noFill/>
+              <a:ln w="19050">
+                <a:solidFill>
+                  <a:schemeClr val="tx1"/>
+                </a:solidFill>
+              </a:ln>
+            </p:spPr>
+            <p:style>
+              <a:lnRef idx="2">
+                <a:schemeClr val="accent1">
+                  <a:shade val="15000"/>
+                </a:schemeClr>
+              </a:lnRef>
+              <a:fillRef idx="1">
+                <a:schemeClr val="accent1"/>
+              </a:fillRef>
+              <a:effectRef idx="0">
+                <a:schemeClr val="accent1"/>
+              </a:effectRef>
+              <a:fontRef idx="minor">
+                <a:schemeClr val="lt1"/>
+              </a:fontRef>
+            </p:style>
+            <p:txBody>
+              <a:bodyPr rtlCol="0" anchor="ctr"/>
+              <a:lstStyle/>
+              <a:p>
+                <a:pPr algn="ctr"/>
+                <a:r>
+                  <a:rPr kumimoji="1" lang="ja-JP" altLang="en-US" sz="2400">
+                    <a:solidFill>
+                      <a:schemeClr val="tx1"/>
+                    </a:solidFill>
+                    <a:latin typeface="Hiragino Sans W4" panose="020B0400000000000000" pitchFamily="34" charset="-128"/>
+                    <a:ea typeface="Hiragino Sans W4" panose="020B0400000000000000" pitchFamily="34" charset="-128"/>
+                  </a:rPr>
+                  <a:t>労</a:t>
+                </a:r>
+              </a:p>
+            </p:txBody>
+          </p:sp>
+          <p:sp>
+            <p:nvSpPr>
+              <p:cNvPr id="6" name="円/楕円 5">
+                <a:extLst>
+                  <a:ext uri="{FF2B5EF4-FFF2-40B4-BE49-F238E27FC236}">
+                    <a16:creationId xmlns:a16="http://schemas.microsoft.com/office/drawing/2014/main" id="{E697A7F3-D216-0366-AE9B-B92B2F609C97}"/>
+                  </a:ext>
+                </a:extLst>
+              </p:cNvPr>
+              <p:cNvSpPr/>
+              <p:nvPr/>
+            </p:nvSpPr>
+            <p:spPr>
+              <a:xfrm>
+                <a:off x="2252803" y="7100843"/>
+                <a:ext cx="573438" cy="573438"/>
+              </a:xfrm>
+              <a:prstGeom prst="ellipse">
+                <a:avLst/>
+              </a:prstGeom>
+              <a:noFill/>
+              <a:ln w="19050">
+                <a:solidFill>
+                  <a:schemeClr val="tx1"/>
+                </a:solidFill>
+              </a:ln>
+            </p:spPr>
+            <p:style>
+              <a:lnRef idx="2">
+                <a:schemeClr val="accent1">
+                  <a:shade val="15000"/>
+                </a:schemeClr>
+              </a:lnRef>
+              <a:fillRef idx="1">
+                <a:schemeClr val="accent1"/>
+              </a:fillRef>
+              <a:effectRef idx="0">
+                <a:schemeClr val="accent1"/>
+              </a:effectRef>
+              <a:fontRef idx="minor">
+                <a:schemeClr val="lt1"/>
+              </a:fontRef>
+            </p:style>
+            <p:txBody>
+              <a:bodyPr rtlCol="0" anchor="ctr"/>
+              <a:lstStyle/>
+              <a:p>
+                <a:pPr algn="ctr"/>
+                <a:r>
+                  <a:rPr kumimoji="1" lang="ja-JP" altLang="en-US" sz="2400">
+                    <a:solidFill>
+                      <a:schemeClr val="tx1"/>
+                    </a:solidFill>
+                    <a:latin typeface="Hiragino Sans W4" panose="020B0400000000000000" pitchFamily="34" charset="-128"/>
+                    <a:ea typeface="Hiragino Sans W4" panose="020B0400000000000000" pitchFamily="34" charset="-128"/>
+                  </a:rPr>
+                  <a:t>労</a:t>
+                </a:r>
+              </a:p>
+            </p:txBody>
+          </p:sp>
+          <p:sp>
+            <p:nvSpPr>
+              <p:cNvPr id="7" name="円/楕円 6">
+                <a:extLst>
+                  <a:ext uri="{FF2B5EF4-FFF2-40B4-BE49-F238E27FC236}">
+                    <a16:creationId xmlns:a16="http://schemas.microsoft.com/office/drawing/2014/main" id="{BB62F5A2-E2C8-AC27-4232-C323CD4F11AA}"/>
+                  </a:ext>
+                </a:extLst>
+              </p:cNvPr>
+              <p:cNvSpPr/>
+              <p:nvPr/>
+            </p:nvSpPr>
+            <p:spPr>
+              <a:xfrm>
+                <a:off x="1679777" y="6016053"/>
+                <a:ext cx="573438" cy="573438"/>
+              </a:xfrm>
+              <a:prstGeom prst="ellipse">
+                <a:avLst/>
+              </a:prstGeom>
+              <a:noFill/>
+              <a:ln w="19050">
+                <a:solidFill>
+                  <a:schemeClr val="tx1"/>
+                </a:solidFill>
+              </a:ln>
+            </p:spPr>
+            <p:style>
+              <a:lnRef idx="2">
+                <a:schemeClr val="accent1">
+                  <a:shade val="15000"/>
+                </a:schemeClr>
+              </a:lnRef>
+              <a:fillRef idx="1">
+                <a:schemeClr val="accent1"/>
+              </a:fillRef>
+              <a:effectRef idx="0">
+                <a:schemeClr val="accent1"/>
+              </a:effectRef>
+              <a:fontRef idx="minor">
+                <a:schemeClr val="lt1"/>
+              </a:fontRef>
+            </p:style>
+            <p:txBody>
+              <a:bodyPr rtlCol="0" anchor="ctr"/>
+              <a:lstStyle/>
+              <a:p>
+                <a:pPr algn="ctr"/>
+                <a:r>
+                  <a:rPr kumimoji="1" lang="ja-JP" altLang="en-US" sz="2400">
+                    <a:solidFill>
+                      <a:schemeClr val="tx1"/>
+                    </a:solidFill>
+                    <a:latin typeface="Hiragino Sans W4" panose="020B0400000000000000" pitchFamily="34" charset="-128"/>
+                    <a:ea typeface="Hiragino Sans W4" panose="020B0400000000000000" pitchFamily="34" charset="-128"/>
+                  </a:rPr>
+                  <a:t>労</a:t>
+                </a:r>
+              </a:p>
+            </p:txBody>
+          </p:sp>
+          <p:sp>
+            <p:nvSpPr>
+              <p:cNvPr id="8" name="テキスト ボックス 7">
+                <a:extLst>
+                  <a:ext uri="{FF2B5EF4-FFF2-40B4-BE49-F238E27FC236}">
+                    <a16:creationId xmlns:a16="http://schemas.microsoft.com/office/drawing/2014/main" id="{AB8F61F6-F738-B584-8FC7-6FCB79C73786}"/>
+                  </a:ext>
+                </a:extLst>
+              </p:cNvPr>
+              <p:cNvSpPr txBox="1"/>
+              <p:nvPr/>
+            </p:nvSpPr>
+            <p:spPr>
+              <a:xfrm>
+                <a:off x="925798" y="7926311"/>
+                <a:ext cx="2081398" cy="573465"/>
+              </a:xfrm>
+              <a:prstGeom prst="rect">
+                <a:avLst/>
+              </a:prstGeom>
+              <a:noFill/>
+            </p:spPr>
+            <p:txBody>
+              <a:bodyPr wrap="square" rtlCol="0">
+                <a:spAutoFit/>
+              </a:bodyPr>
+              <a:lstStyle/>
+              <a:p>
+                <a:pPr algn="ctr"/>
+                <a:r>
+                  <a:rPr kumimoji="1" lang="ja-JP" altLang="en-US" sz="2000">
+                    <a:latin typeface="Hiragino Kaku Gothic StdN W8" panose="020B0800000000000000" pitchFamily="34" charset="-128"/>
+                    <a:ea typeface="Hiragino Kaku Gothic StdN W8" panose="020B0800000000000000" pitchFamily="34" charset="-128"/>
+                  </a:rPr>
+                  <a:t>労働組合</a:t>
+                </a:r>
+              </a:p>
+            </p:txBody>
+          </p:sp>
+        </p:grpSp>
+        <p:grpSp>
+          <p:nvGrpSpPr>
+            <p:cNvPr id="22" name="グループ化 21">
+              <a:extLst>
+                <a:ext uri="{FF2B5EF4-FFF2-40B4-BE49-F238E27FC236}">
+                  <a16:creationId xmlns:a16="http://schemas.microsoft.com/office/drawing/2014/main" id="{BD7868CC-70B3-811A-4503-16919437EFEB}"/>
+                </a:ext>
+              </a:extLst>
+            </p:cNvPr>
+            <p:cNvGrpSpPr/>
+            <p:nvPr/>
+          </p:nvGrpSpPr>
+          <p:grpSpPr>
+            <a:xfrm>
+              <a:off x="2260008" y="6123680"/>
+              <a:ext cx="1840245" cy="2089682"/>
+              <a:chOff x="579398" y="5504701"/>
+              <a:chExt cx="2774196" cy="2995075"/>
+            </a:xfrm>
+          </p:grpSpPr>
+          <p:sp>
+            <p:nvSpPr>
+              <p:cNvPr id="23" name="三角形 22">
+                <a:extLst>
+                  <a:ext uri="{FF2B5EF4-FFF2-40B4-BE49-F238E27FC236}">
+                    <a16:creationId xmlns:a16="http://schemas.microsoft.com/office/drawing/2014/main" id="{63D1F1AE-600D-5BAA-BCC4-0E4282EF4938}"/>
+                  </a:ext>
+                </a:extLst>
+              </p:cNvPr>
+              <p:cNvSpPr/>
+              <p:nvPr/>
+            </p:nvSpPr>
+            <p:spPr>
+              <a:xfrm>
+                <a:off x="579398" y="5504701"/>
+                <a:ext cx="2774196" cy="2421610"/>
+              </a:xfrm>
+              <a:prstGeom prst="triangle">
+                <a:avLst/>
+              </a:prstGeom>
+              <a:noFill/>
+              <a:ln w="28575">
+                <a:solidFill>
+                  <a:schemeClr val="tx1"/>
+                </a:solidFill>
+              </a:ln>
+            </p:spPr>
+            <p:style>
+              <a:lnRef idx="2">
+                <a:schemeClr val="accent1">
+                  <a:shade val="15000"/>
+                </a:schemeClr>
+              </a:lnRef>
+              <a:fillRef idx="1">
+                <a:schemeClr val="accent1"/>
+              </a:fillRef>
+              <a:effectRef idx="0">
+                <a:schemeClr val="accent1"/>
+              </a:effectRef>
+              <a:fontRef idx="minor">
+                <a:schemeClr val="lt1"/>
+              </a:fontRef>
+            </p:style>
+            <p:txBody>
+              <a:bodyPr rtlCol="0" anchor="ctr"/>
+              <a:lstStyle/>
+              <a:p>
+                <a:pPr algn="ctr"/>
+                <a:endParaRPr kumimoji="1" lang="ja-JP" altLang="en-US"/>
+              </a:p>
+            </p:txBody>
+          </p:sp>
+          <p:sp>
+            <p:nvSpPr>
+              <p:cNvPr id="24" name="円/楕円 23">
+                <a:extLst>
+                  <a:ext uri="{FF2B5EF4-FFF2-40B4-BE49-F238E27FC236}">
+                    <a16:creationId xmlns:a16="http://schemas.microsoft.com/office/drawing/2014/main" id="{B682C1E8-7FE9-6820-B3DB-354D075494BF}"/>
+                  </a:ext>
+                </a:extLst>
+              </p:cNvPr>
+              <p:cNvSpPr/>
+              <p:nvPr/>
+            </p:nvSpPr>
+            <p:spPr>
+              <a:xfrm>
+                <a:off x="1152013" y="7100843"/>
+                <a:ext cx="573438" cy="573438"/>
+              </a:xfrm>
+              <a:prstGeom prst="ellipse">
+                <a:avLst/>
+              </a:prstGeom>
+              <a:noFill/>
+              <a:ln w="19050">
+                <a:solidFill>
+                  <a:schemeClr val="tx1"/>
+                </a:solidFill>
+              </a:ln>
+            </p:spPr>
+            <p:style>
+              <a:lnRef idx="2">
+                <a:schemeClr val="accent1">
+                  <a:shade val="15000"/>
+                </a:schemeClr>
+              </a:lnRef>
+              <a:fillRef idx="1">
+                <a:schemeClr val="accent1"/>
+              </a:fillRef>
+              <a:effectRef idx="0">
+                <a:schemeClr val="accent1"/>
+              </a:effectRef>
+              <a:fontRef idx="minor">
+                <a:schemeClr val="lt1"/>
+              </a:fontRef>
+            </p:style>
+            <p:txBody>
+              <a:bodyPr rtlCol="0" anchor="ctr"/>
+              <a:lstStyle/>
+              <a:p>
+                <a:pPr algn="ctr"/>
+                <a:r>
+                  <a:rPr kumimoji="1" lang="ja-JP" altLang="en-US" sz="2400">
+                    <a:solidFill>
+                      <a:schemeClr val="tx1"/>
+                    </a:solidFill>
+                    <a:latin typeface="Hiragino Sans W4" panose="020B0400000000000000" pitchFamily="34" charset="-128"/>
+                    <a:ea typeface="Hiragino Sans W4" panose="020B0400000000000000" pitchFamily="34" charset="-128"/>
+                  </a:rPr>
+                  <a:t>労</a:t>
+                </a:r>
+              </a:p>
+            </p:txBody>
+          </p:sp>
+          <p:sp>
+            <p:nvSpPr>
+              <p:cNvPr id="25" name="円/楕円 24">
+                <a:extLst>
+                  <a:ext uri="{FF2B5EF4-FFF2-40B4-BE49-F238E27FC236}">
+                    <a16:creationId xmlns:a16="http://schemas.microsoft.com/office/drawing/2014/main" id="{3688B88D-1B0B-1FFF-D7E2-656590535C46}"/>
+                  </a:ext>
+                </a:extLst>
+              </p:cNvPr>
+              <p:cNvSpPr/>
+              <p:nvPr/>
+            </p:nvSpPr>
+            <p:spPr>
+              <a:xfrm>
+                <a:off x="2252803" y="7100843"/>
+                <a:ext cx="573438" cy="573438"/>
+              </a:xfrm>
+              <a:prstGeom prst="ellipse">
+                <a:avLst/>
+              </a:prstGeom>
+              <a:noFill/>
+              <a:ln w="19050">
+                <a:solidFill>
+                  <a:schemeClr val="tx1"/>
+                </a:solidFill>
+              </a:ln>
+            </p:spPr>
+            <p:style>
+              <a:lnRef idx="2">
+                <a:schemeClr val="accent1">
+                  <a:shade val="15000"/>
+                </a:schemeClr>
+              </a:lnRef>
+              <a:fillRef idx="1">
+                <a:schemeClr val="accent1"/>
+              </a:fillRef>
+              <a:effectRef idx="0">
+                <a:schemeClr val="accent1"/>
+              </a:effectRef>
+              <a:fontRef idx="minor">
+                <a:schemeClr val="lt1"/>
+              </a:fontRef>
+            </p:style>
+            <p:txBody>
+              <a:bodyPr rtlCol="0" anchor="ctr"/>
+              <a:lstStyle/>
+              <a:p>
+                <a:pPr algn="ctr"/>
+                <a:r>
+                  <a:rPr kumimoji="1" lang="ja-JP" altLang="en-US" sz="2400">
+                    <a:solidFill>
+                      <a:schemeClr val="tx1"/>
+                    </a:solidFill>
+                    <a:latin typeface="Hiragino Sans W4" panose="020B0400000000000000" pitchFamily="34" charset="-128"/>
+                    <a:ea typeface="Hiragino Sans W4" panose="020B0400000000000000" pitchFamily="34" charset="-128"/>
+                  </a:rPr>
+                  <a:t>労</a:t>
+                </a:r>
+              </a:p>
+            </p:txBody>
+          </p:sp>
+          <p:sp>
+            <p:nvSpPr>
+              <p:cNvPr id="26" name="円/楕円 25">
+                <a:extLst>
+                  <a:ext uri="{FF2B5EF4-FFF2-40B4-BE49-F238E27FC236}">
+                    <a16:creationId xmlns:a16="http://schemas.microsoft.com/office/drawing/2014/main" id="{3FCE392C-998D-8B6C-7745-376A9A7487FB}"/>
+                  </a:ext>
+                </a:extLst>
+              </p:cNvPr>
+              <p:cNvSpPr/>
+              <p:nvPr/>
+            </p:nvSpPr>
+            <p:spPr>
+              <a:xfrm>
+                <a:off x="1679777" y="6016053"/>
+                <a:ext cx="573438" cy="573438"/>
+              </a:xfrm>
+              <a:prstGeom prst="ellipse">
+                <a:avLst/>
+              </a:prstGeom>
+              <a:noFill/>
+              <a:ln w="19050">
+                <a:solidFill>
+                  <a:schemeClr val="tx1"/>
+                </a:solidFill>
+              </a:ln>
+            </p:spPr>
+            <p:style>
+              <a:lnRef idx="2">
+                <a:schemeClr val="accent1">
+                  <a:shade val="15000"/>
+                </a:schemeClr>
+              </a:lnRef>
+              <a:fillRef idx="1">
+                <a:schemeClr val="accent1"/>
+              </a:fillRef>
+              <a:effectRef idx="0">
+                <a:schemeClr val="accent1"/>
+              </a:effectRef>
+              <a:fontRef idx="minor">
+                <a:schemeClr val="lt1"/>
+              </a:fontRef>
+            </p:style>
+            <p:txBody>
+              <a:bodyPr rtlCol="0" anchor="ctr"/>
+              <a:lstStyle/>
+              <a:p>
+                <a:pPr algn="ctr"/>
+                <a:r>
+                  <a:rPr kumimoji="1" lang="ja-JP" altLang="en-US" sz="2400">
+                    <a:solidFill>
+                      <a:schemeClr val="tx1"/>
+                    </a:solidFill>
+                    <a:latin typeface="Hiragino Sans W4" panose="020B0400000000000000" pitchFamily="34" charset="-128"/>
+                    <a:ea typeface="Hiragino Sans W4" panose="020B0400000000000000" pitchFamily="34" charset="-128"/>
+                  </a:rPr>
+                  <a:t>労</a:t>
+                </a:r>
+              </a:p>
+            </p:txBody>
+          </p:sp>
+          <p:sp>
+            <p:nvSpPr>
+              <p:cNvPr id="27" name="テキスト ボックス 26">
+                <a:extLst>
+                  <a:ext uri="{FF2B5EF4-FFF2-40B4-BE49-F238E27FC236}">
+                    <a16:creationId xmlns:a16="http://schemas.microsoft.com/office/drawing/2014/main" id="{66CF2D3E-8BD2-1B39-5A3C-40CE72ADE693}"/>
+                  </a:ext>
+                </a:extLst>
+              </p:cNvPr>
+              <p:cNvSpPr txBox="1"/>
+              <p:nvPr/>
+            </p:nvSpPr>
+            <p:spPr>
+              <a:xfrm>
+                <a:off x="925798" y="7926311"/>
+                <a:ext cx="2081398" cy="573465"/>
+              </a:xfrm>
+              <a:prstGeom prst="rect">
+                <a:avLst/>
+              </a:prstGeom>
+              <a:noFill/>
+            </p:spPr>
+            <p:txBody>
+              <a:bodyPr wrap="square" rtlCol="0">
+                <a:spAutoFit/>
+              </a:bodyPr>
+              <a:lstStyle/>
+              <a:p>
+                <a:pPr algn="ctr"/>
+                <a:r>
+                  <a:rPr kumimoji="1" lang="ja-JP" altLang="en-US" sz="2000">
+                    <a:latin typeface="Hiragino Kaku Gothic StdN W8" panose="020B0800000000000000" pitchFamily="34" charset="-128"/>
+                    <a:ea typeface="Hiragino Kaku Gothic StdN W8" panose="020B0800000000000000" pitchFamily="34" charset="-128"/>
+                  </a:rPr>
+                  <a:t>労働組合</a:t>
+                </a:r>
+              </a:p>
+            </p:txBody>
+          </p:sp>
+        </p:grpSp>
+        <p:grpSp>
+          <p:nvGrpSpPr>
+            <p:cNvPr id="28" name="グループ化 27">
+              <a:extLst>
+                <a:ext uri="{FF2B5EF4-FFF2-40B4-BE49-F238E27FC236}">
+                  <a16:creationId xmlns:a16="http://schemas.microsoft.com/office/drawing/2014/main" id="{7E8CEA0C-5994-31FB-15BD-087F55BEAC23}"/>
+                </a:ext>
+              </a:extLst>
+            </p:cNvPr>
+            <p:cNvGrpSpPr/>
+            <p:nvPr/>
+          </p:nvGrpSpPr>
+          <p:grpSpPr>
+            <a:xfrm>
+              <a:off x="4290036" y="6123680"/>
+              <a:ext cx="1840245" cy="2089682"/>
+              <a:chOff x="579398" y="5504701"/>
+              <a:chExt cx="2774196" cy="2995075"/>
+            </a:xfrm>
+          </p:grpSpPr>
+          <p:sp>
+            <p:nvSpPr>
+              <p:cNvPr id="29" name="三角形 28">
+                <a:extLst>
+                  <a:ext uri="{FF2B5EF4-FFF2-40B4-BE49-F238E27FC236}">
+                    <a16:creationId xmlns:a16="http://schemas.microsoft.com/office/drawing/2014/main" id="{A4A2A32C-4D7A-2913-27CB-5843DFD1C1CF}"/>
+                  </a:ext>
+                </a:extLst>
+              </p:cNvPr>
+              <p:cNvSpPr/>
+              <p:nvPr/>
+            </p:nvSpPr>
+            <p:spPr>
+              <a:xfrm>
+                <a:off x="579398" y="5504701"/>
+                <a:ext cx="2774196" cy="2421610"/>
+              </a:xfrm>
+              <a:prstGeom prst="triangle">
+                <a:avLst/>
+              </a:prstGeom>
+              <a:noFill/>
+              <a:ln w="28575">
+                <a:solidFill>
+                  <a:schemeClr val="tx1"/>
+                </a:solidFill>
+              </a:ln>
+            </p:spPr>
+            <p:style>
+              <a:lnRef idx="2">
+                <a:schemeClr val="accent1">
+                  <a:shade val="15000"/>
+                </a:schemeClr>
+              </a:lnRef>
+              <a:fillRef idx="1">
+                <a:schemeClr val="accent1"/>
+              </a:fillRef>
+              <a:effectRef idx="0">
+                <a:schemeClr val="accent1"/>
+              </a:effectRef>
+              <a:fontRef idx="minor">
+                <a:schemeClr val="lt1"/>
+              </a:fontRef>
+            </p:style>
+            <p:txBody>
+              <a:bodyPr rtlCol="0" anchor="ctr"/>
+              <a:lstStyle/>
+              <a:p>
+                <a:pPr algn="ctr"/>
+                <a:endParaRPr kumimoji="1" lang="ja-JP" altLang="en-US"/>
+              </a:p>
+            </p:txBody>
+          </p:sp>
+          <p:sp>
+            <p:nvSpPr>
+              <p:cNvPr id="30" name="円/楕円 29">
+                <a:extLst>
+                  <a:ext uri="{FF2B5EF4-FFF2-40B4-BE49-F238E27FC236}">
+                    <a16:creationId xmlns:a16="http://schemas.microsoft.com/office/drawing/2014/main" id="{5615956A-1D6F-EAA0-4E17-5F0A73A4BE4D}"/>
+                  </a:ext>
+                </a:extLst>
+              </p:cNvPr>
+              <p:cNvSpPr/>
+              <p:nvPr/>
+            </p:nvSpPr>
+            <p:spPr>
+              <a:xfrm>
+                <a:off x="1152013" y="7100843"/>
+                <a:ext cx="573438" cy="573438"/>
+              </a:xfrm>
+              <a:prstGeom prst="ellipse">
+                <a:avLst/>
+              </a:prstGeom>
+              <a:noFill/>
+              <a:ln w="19050">
+                <a:solidFill>
+                  <a:schemeClr val="tx1"/>
+                </a:solidFill>
+              </a:ln>
+            </p:spPr>
+            <p:style>
+              <a:lnRef idx="2">
+                <a:schemeClr val="accent1">
+                  <a:shade val="15000"/>
+                </a:schemeClr>
+              </a:lnRef>
+              <a:fillRef idx="1">
+                <a:schemeClr val="accent1"/>
+              </a:fillRef>
+              <a:effectRef idx="0">
+                <a:schemeClr val="accent1"/>
+              </a:effectRef>
+              <a:fontRef idx="minor">
+                <a:schemeClr val="lt1"/>
+              </a:fontRef>
+            </p:style>
+            <p:txBody>
+              <a:bodyPr rtlCol="0" anchor="ctr"/>
+              <a:lstStyle/>
+              <a:p>
+                <a:pPr algn="ctr"/>
+                <a:r>
+                  <a:rPr kumimoji="1" lang="ja-JP" altLang="en-US" sz="2400">
+                    <a:solidFill>
+                      <a:schemeClr val="tx1"/>
+                    </a:solidFill>
+                    <a:latin typeface="Hiragino Sans W4" panose="020B0400000000000000" pitchFamily="34" charset="-128"/>
+                    <a:ea typeface="Hiragino Sans W4" panose="020B0400000000000000" pitchFamily="34" charset="-128"/>
+                  </a:rPr>
+                  <a:t>労</a:t>
+                </a:r>
+              </a:p>
+            </p:txBody>
+          </p:sp>
+          <p:sp>
+            <p:nvSpPr>
+              <p:cNvPr id="31" name="円/楕円 30">
+                <a:extLst>
+                  <a:ext uri="{FF2B5EF4-FFF2-40B4-BE49-F238E27FC236}">
+                    <a16:creationId xmlns:a16="http://schemas.microsoft.com/office/drawing/2014/main" id="{A0C3599C-CBD3-F3F6-D447-81204880F36E}"/>
+                  </a:ext>
+                </a:extLst>
+              </p:cNvPr>
+              <p:cNvSpPr/>
+              <p:nvPr/>
+            </p:nvSpPr>
+            <p:spPr>
+              <a:xfrm>
+                <a:off x="2252803" y="7100843"/>
+                <a:ext cx="573438" cy="573438"/>
+              </a:xfrm>
+              <a:prstGeom prst="ellipse">
+                <a:avLst/>
+              </a:prstGeom>
+              <a:noFill/>
+              <a:ln w="19050">
+                <a:solidFill>
+                  <a:schemeClr val="tx1"/>
+                </a:solidFill>
+              </a:ln>
+            </p:spPr>
+            <p:style>
+              <a:lnRef idx="2">
+                <a:schemeClr val="accent1">
+                  <a:shade val="15000"/>
+                </a:schemeClr>
+              </a:lnRef>
+              <a:fillRef idx="1">
+                <a:schemeClr val="accent1"/>
+              </a:fillRef>
+              <a:effectRef idx="0">
+                <a:schemeClr val="accent1"/>
+              </a:effectRef>
+              <a:fontRef idx="minor">
+                <a:schemeClr val="lt1"/>
+              </a:fontRef>
+            </p:style>
+            <p:txBody>
+              <a:bodyPr rtlCol="0" anchor="ctr"/>
+              <a:lstStyle/>
+              <a:p>
+                <a:pPr algn="ctr"/>
+                <a:r>
+                  <a:rPr kumimoji="1" lang="ja-JP" altLang="en-US" sz="2400">
+                    <a:solidFill>
+                      <a:schemeClr val="tx1"/>
+                    </a:solidFill>
+                    <a:latin typeface="Hiragino Sans W4" panose="020B0400000000000000" pitchFamily="34" charset="-128"/>
+                    <a:ea typeface="Hiragino Sans W4" panose="020B0400000000000000" pitchFamily="34" charset="-128"/>
+                  </a:rPr>
+                  <a:t>労</a:t>
+                </a:r>
+              </a:p>
+            </p:txBody>
+          </p:sp>
+          <p:sp>
+            <p:nvSpPr>
+              <p:cNvPr id="32" name="円/楕円 31">
+                <a:extLst>
+                  <a:ext uri="{FF2B5EF4-FFF2-40B4-BE49-F238E27FC236}">
+                    <a16:creationId xmlns:a16="http://schemas.microsoft.com/office/drawing/2014/main" id="{75C14869-7E96-1CB2-6C23-404F0365ACCA}"/>
+                  </a:ext>
+                </a:extLst>
+              </p:cNvPr>
+              <p:cNvSpPr/>
+              <p:nvPr/>
+            </p:nvSpPr>
+            <p:spPr>
+              <a:xfrm>
+                <a:off x="1679777" y="6016053"/>
+                <a:ext cx="573438" cy="573438"/>
+              </a:xfrm>
+              <a:prstGeom prst="ellipse">
+                <a:avLst/>
+              </a:prstGeom>
+              <a:noFill/>
+              <a:ln w="19050">
+                <a:solidFill>
+                  <a:schemeClr val="tx1"/>
+                </a:solidFill>
+              </a:ln>
+            </p:spPr>
+            <p:style>
+              <a:lnRef idx="2">
+                <a:schemeClr val="accent1">
+                  <a:shade val="15000"/>
+                </a:schemeClr>
+              </a:lnRef>
+              <a:fillRef idx="1">
+                <a:schemeClr val="accent1"/>
+              </a:fillRef>
+              <a:effectRef idx="0">
+                <a:schemeClr val="accent1"/>
+              </a:effectRef>
+              <a:fontRef idx="minor">
+                <a:schemeClr val="lt1"/>
+              </a:fontRef>
+            </p:style>
+            <p:txBody>
+              <a:bodyPr rtlCol="0" anchor="ctr"/>
+              <a:lstStyle/>
+              <a:p>
+                <a:pPr algn="ctr"/>
+                <a:r>
+                  <a:rPr kumimoji="1" lang="ja-JP" altLang="en-US" sz="2400">
+                    <a:solidFill>
+                      <a:schemeClr val="tx1"/>
+                    </a:solidFill>
+                    <a:latin typeface="Hiragino Sans W4" panose="020B0400000000000000" pitchFamily="34" charset="-128"/>
+                    <a:ea typeface="Hiragino Sans W4" panose="020B0400000000000000" pitchFamily="34" charset="-128"/>
+                  </a:rPr>
+                  <a:t>労</a:t>
+                </a:r>
+              </a:p>
+            </p:txBody>
+          </p:sp>
+          <p:sp>
+            <p:nvSpPr>
+              <p:cNvPr id="33" name="テキスト ボックス 32">
+                <a:extLst>
+                  <a:ext uri="{FF2B5EF4-FFF2-40B4-BE49-F238E27FC236}">
+                    <a16:creationId xmlns:a16="http://schemas.microsoft.com/office/drawing/2014/main" id="{9E1B8CB7-C6B3-48C6-CB5D-F31E97C25A3A}"/>
+                  </a:ext>
+                </a:extLst>
+              </p:cNvPr>
+              <p:cNvSpPr txBox="1"/>
+              <p:nvPr/>
+            </p:nvSpPr>
+            <p:spPr>
+              <a:xfrm>
+                <a:off x="925798" y="7926311"/>
+                <a:ext cx="2081398" cy="573465"/>
+              </a:xfrm>
+              <a:prstGeom prst="rect">
+                <a:avLst/>
+              </a:prstGeom>
+              <a:noFill/>
+            </p:spPr>
+            <p:txBody>
+              <a:bodyPr wrap="square" rtlCol="0">
+                <a:spAutoFit/>
+              </a:bodyPr>
+              <a:lstStyle/>
+              <a:p>
+                <a:pPr algn="ctr"/>
+                <a:r>
+                  <a:rPr kumimoji="1" lang="ja-JP" altLang="en-US" sz="2000">
+                    <a:latin typeface="Hiragino Kaku Gothic StdN W8" panose="020B0800000000000000" pitchFamily="34" charset="-128"/>
+                    <a:ea typeface="Hiragino Kaku Gothic StdN W8" panose="020B0800000000000000" pitchFamily="34" charset="-128"/>
+                  </a:rPr>
+                  <a:t>労働組合</a:t>
+                </a:r>
+              </a:p>
+            </p:txBody>
+          </p:sp>
+        </p:grpSp>
+        <p:sp>
+          <p:nvSpPr>
+            <p:cNvPr id="34" name="角丸四角形 33">
+              <a:extLst>
+                <a:ext uri="{FF2B5EF4-FFF2-40B4-BE49-F238E27FC236}">
+                  <a16:creationId xmlns:a16="http://schemas.microsoft.com/office/drawing/2014/main" id="{E6FAE759-C9C6-05F0-11F3-6E9080C7D8F6}"/>
+                </a:ext>
+              </a:extLst>
+            </p:cNvPr>
+            <p:cNvSpPr/>
+            <p:nvPr/>
+          </p:nvSpPr>
+          <p:spPr>
+            <a:xfrm>
+              <a:off x="1920167" y="2729133"/>
+              <a:ext cx="2599651" cy="1273126"/>
+            </a:xfrm>
+            <a:prstGeom prst="roundRect">
+              <a:avLst/>
+            </a:prstGeom>
+            <a:noFill/>
+            <a:ln w="28575">
+              <a:solidFill>
+                <a:schemeClr val="tx1"/>
+              </a:solidFill>
+            </a:ln>
+          </p:spPr>
+          <p:style>
+            <a:lnRef idx="2">
+              <a:schemeClr val="accent1">
+                <a:shade val="15000"/>
+              </a:schemeClr>
+            </a:lnRef>
+            <a:fillRef idx="1">
+              <a:schemeClr val="accent1"/>
+            </a:fillRef>
+            <a:effectRef idx="0">
+              <a:schemeClr val="accent1"/>
+            </a:effectRef>
+            <a:fontRef idx="minor">
+              <a:schemeClr val="lt1"/>
+            </a:fontRef>
+          </p:style>
+          <p:txBody>
+            <a:bodyPr rtlCol="0" anchor="ctr"/>
+            <a:lstStyle/>
+            <a:p>
+              <a:pPr algn="ctr"/>
+              <a:r>
+                <a:rPr kumimoji="1" lang="ja-JP" altLang="en-US" sz="4400">
+                  <a:solidFill>
+                    <a:schemeClr val="tx1"/>
+                  </a:solidFill>
+                  <a:latin typeface="Hiragino Kaku Gothic StdN W8" panose="020B0800000000000000" pitchFamily="34" charset="-128"/>
+                  <a:ea typeface="Hiragino Kaku Gothic StdN W8" panose="020B0800000000000000" pitchFamily="34" charset="-128"/>
+                </a:rPr>
+                <a:t>頂上団体</a:t>
+              </a:r>
+              <a:endParaRPr kumimoji="1" lang="ja-JP" altLang="en-US" sz="3000"/>
+            </a:p>
+          </p:txBody>
+        </p:sp>
+        <p:grpSp>
+          <p:nvGrpSpPr>
+            <p:cNvPr id="37" name="グループ化 36">
+              <a:extLst>
+                <a:ext uri="{FF2B5EF4-FFF2-40B4-BE49-F238E27FC236}">
+                  <a16:creationId xmlns:a16="http://schemas.microsoft.com/office/drawing/2014/main" id="{A1293DB6-C347-5220-9E75-4DBDC594EEBD}"/>
+                </a:ext>
+              </a:extLst>
+            </p:cNvPr>
+            <p:cNvGrpSpPr/>
+            <p:nvPr/>
+          </p:nvGrpSpPr>
+          <p:grpSpPr>
+            <a:xfrm>
+              <a:off x="6669965" y="6125122"/>
+              <a:ext cx="1840245" cy="2088240"/>
+              <a:chOff x="579398" y="5504701"/>
+              <a:chExt cx="2774196" cy="2993008"/>
+            </a:xfrm>
+          </p:grpSpPr>
+          <p:sp>
+            <p:nvSpPr>
+              <p:cNvPr id="38" name="三角形 37">
+                <a:extLst>
+                  <a:ext uri="{FF2B5EF4-FFF2-40B4-BE49-F238E27FC236}">
+                    <a16:creationId xmlns:a16="http://schemas.microsoft.com/office/drawing/2014/main" id="{28A80CC9-D088-2F87-9F8D-1985989A09D3}"/>
+                  </a:ext>
+                </a:extLst>
+              </p:cNvPr>
+              <p:cNvSpPr/>
+              <p:nvPr/>
+            </p:nvSpPr>
+            <p:spPr>
+              <a:xfrm>
+                <a:off x="579398" y="5504701"/>
+                <a:ext cx="2774196" cy="2421610"/>
+              </a:xfrm>
+              <a:prstGeom prst="triangle">
+                <a:avLst/>
+              </a:prstGeom>
+              <a:noFill/>
+              <a:ln w="28575">
+                <a:solidFill>
+                  <a:schemeClr val="tx1"/>
+                </a:solidFill>
+              </a:ln>
+            </p:spPr>
+            <p:style>
+              <a:lnRef idx="2">
+                <a:schemeClr val="accent1">
+                  <a:shade val="15000"/>
+                </a:schemeClr>
+              </a:lnRef>
+              <a:fillRef idx="1">
+                <a:schemeClr val="accent1"/>
+              </a:fillRef>
+              <a:effectRef idx="0">
+                <a:schemeClr val="accent1"/>
+              </a:effectRef>
+              <a:fontRef idx="minor">
+                <a:schemeClr val="lt1"/>
+              </a:fontRef>
+            </p:style>
+            <p:txBody>
+              <a:bodyPr rtlCol="0" anchor="ctr"/>
+              <a:lstStyle/>
+              <a:p>
+                <a:pPr algn="ctr"/>
+                <a:endParaRPr kumimoji="1" lang="ja-JP" altLang="en-US"/>
+              </a:p>
+            </p:txBody>
+          </p:sp>
+          <p:sp>
+            <p:nvSpPr>
+              <p:cNvPr id="39" name="円/楕円 38">
+                <a:extLst>
+                  <a:ext uri="{FF2B5EF4-FFF2-40B4-BE49-F238E27FC236}">
+                    <a16:creationId xmlns:a16="http://schemas.microsoft.com/office/drawing/2014/main" id="{04D10A54-B404-DF67-E5A2-6504F6E32205}"/>
+                  </a:ext>
+                </a:extLst>
+              </p:cNvPr>
+              <p:cNvSpPr/>
+              <p:nvPr/>
+            </p:nvSpPr>
+            <p:spPr>
+              <a:xfrm>
+                <a:off x="1152013" y="7100843"/>
+                <a:ext cx="573438" cy="573438"/>
+              </a:xfrm>
+              <a:prstGeom prst="ellipse">
+                <a:avLst/>
+              </a:prstGeom>
+              <a:noFill/>
+              <a:ln w="19050">
+                <a:solidFill>
+                  <a:schemeClr val="tx1"/>
+                </a:solidFill>
+              </a:ln>
+            </p:spPr>
+            <p:style>
+              <a:lnRef idx="2">
+                <a:schemeClr val="accent1">
+                  <a:shade val="15000"/>
+                </a:schemeClr>
+              </a:lnRef>
+              <a:fillRef idx="1">
+                <a:schemeClr val="accent1"/>
+              </a:fillRef>
+              <a:effectRef idx="0">
+                <a:schemeClr val="accent1"/>
+              </a:effectRef>
+              <a:fontRef idx="minor">
+                <a:schemeClr val="lt1"/>
+              </a:fontRef>
+            </p:style>
+            <p:txBody>
+              <a:bodyPr rtlCol="0" anchor="ctr"/>
+              <a:lstStyle/>
+              <a:p>
+                <a:pPr algn="ctr"/>
+                <a:r>
+                  <a:rPr kumimoji="1" lang="ja-JP" altLang="en-US" sz="2400">
+                    <a:solidFill>
+                      <a:schemeClr val="tx1"/>
+                    </a:solidFill>
+                    <a:latin typeface="Hiragino Sans W4" panose="020B0400000000000000" pitchFamily="34" charset="-128"/>
+                    <a:ea typeface="Hiragino Sans W4" panose="020B0400000000000000" pitchFamily="34" charset="-128"/>
+                  </a:rPr>
+                  <a:t>企</a:t>
+                </a:r>
+              </a:p>
+            </p:txBody>
+          </p:sp>
+          <p:sp>
+            <p:nvSpPr>
+              <p:cNvPr id="40" name="円/楕円 39">
+                <a:extLst>
+                  <a:ext uri="{FF2B5EF4-FFF2-40B4-BE49-F238E27FC236}">
+                    <a16:creationId xmlns:a16="http://schemas.microsoft.com/office/drawing/2014/main" id="{2FF33F5E-1D9B-3D51-E934-2874899DFF04}"/>
+                  </a:ext>
+                </a:extLst>
+              </p:cNvPr>
+              <p:cNvSpPr/>
+              <p:nvPr/>
+            </p:nvSpPr>
+            <p:spPr>
+              <a:xfrm>
+                <a:off x="2252803" y="7100843"/>
+                <a:ext cx="573438" cy="573438"/>
+              </a:xfrm>
+              <a:prstGeom prst="ellipse">
+                <a:avLst/>
+              </a:prstGeom>
+              <a:noFill/>
+              <a:ln w="19050">
+                <a:solidFill>
+                  <a:schemeClr val="tx1"/>
+                </a:solidFill>
+              </a:ln>
+            </p:spPr>
+            <p:style>
+              <a:lnRef idx="2">
+                <a:schemeClr val="accent1">
+                  <a:shade val="15000"/>
+                </a:schemeClr>
+              </a:lnRef>
+              <a:fillRef idx="1">
+                <a:schemeClr val="accent1"/>
+              </a:fillRef>
+              <a:effectRef idx="0">
+                <a:schemeClr val="accent1"/>
+              </a:effectRef>
+              <a:fontRef idx="minor">
+                <a:schemeClr val="lt1"/>
+              </a:fontRef>
+            </p:style>
+            <p:txBody>
+              <a:bodyPr rtlCol="0" anchor="ctr"/>
+              <a:lstStyle/>
+              <a:p>
+                <a:pPr algn="ctr"/>
+                <a:r>
+                  <a:rPr kumimoji="1" lang="ja-JP" altLang="en-US" sz="2400">
+                    <a:solidFill>
+                      <a:schemeClr val="tx1"/>
+                    </a:solidFill>
+                    <a:latin typeface="Hiragino Sans W4" panose="020B0400000000000000" pitchFamily="34" charset="-128"/>
+                    <a:ea typeface="Hiragino Sans W4" panose="020B0400000000000000" pitchFamily="34" charset="-128"/>
+                  </a:rPr>
+                  <a:t>企</a:t>
+                </a:r>
+              </a:p>
+            </p:txBody>
+          </p:sp>
+          <p:sp>
+            <p:nvSpPr>
+              <p:cNvPr id="41" name="円/楕円 40">
+                <a:extLst>
+                  <a:ext uri="{FF2B5EF4-FFF2-40B4-BE49-F238E27FC236}">
+                    <a16:creationId xmlns:a16="http://schemas.microsoft.com/office/drawing/2014/main" id="{50355619-60A0-2823-9A49-A7A45FDC04DE}"/>
+                  </a:ext>
+                </a:extLst>
+              </p:cNvPr>
+              <p:cNvSpPr/>
+              <p:nvPr/>
+            </p:nvSpPr>
+            <p:spPr>
+              <a:xfrm>
+                <a:off x="1679777" y="6016053"/>
+                <a:ext cx="573438" cy="573438"/>
+              </a:xfrm>
+              <a:prstGeom prst="ellipse">
+                <a:avLst/>
+              </a:prstGeom>
+              <a:noFill/>
+              <a:ln w="19050">
+                <a:solidFill>
+                  <a:schemeClr val="tx1"/>
+                </a:solidFill>
+              </a:ln>
+            </p:spPr>
+            <p:style>
+              <a:lnRef idx="2">
+                <a:schemeClr val="accent1">
+                  <a:shade val="15000"/>
+                </a:schemeClr>
+              </a:lnRef>
+              <a:fillRef idx="1">
+                <a:schemeClr val="accent1"/>
+              </a:fillRef>
+              <a:effectRef idx="0">
+                <a:schemeClr val="accent1"/>
+              </a:effectRef>
+              <a:fontRef idx="minor">
+                <a:schemeClr val="lt1"/>
+              </a:fontRef>
+            </p:style>
+            <p:txBody>
+              <a:bodyPr rtlCol="0" anchor="ctr"/>
+              <a:lstStyle/>
+              <a:p>
+                <a:pPr algn="ctr"/>
+                <a:r>
+                  <a:rPr kumimoji="1" lang="ja-JP" altLang="en-US" sz="2400">
+                    <a:solidFill>
+                      <a:schemeClr val="tx1"/>
+                    </a:solidFill>
+                    <a:latin typeface="Hiragino Sans W4" panose="020B0400000000000000" pitchFamily="34" charset="-128"/>
+                    <a:ea typeface="Hiragino Sans W4" panose="020B0400000000000000" pitchFamily="34" charset="-128"/>
+                  </a:rPr>
+                  <a:t>企</a:t>
+                </a:r>
+              </a:p>
+            </p:txBody>
+          </p:sp>
+          <p:sp>
+            <p:nvSpPr>
+              <p:cNvPr id="42" name="テキスト ボックス 41">
+                <a:extLst>
+                  <a:ext uri="{FF2B5EF4-FFF2-40B4-BE49-F238E27FC236}">
+                    <a16:creationId xmlns:a16="http://schemas.microsoft.com/office/drawing/2014/main" id="{409F1D85-5108-854D-2373-2FFE64CA856D}"/>
+                  </a:ext>
+                </a:extLst>
+              </p:cNvPr>
+              <p:cNvSpPr txBox="1"/>
+              <p:nvPr/>
+            </p:nvSpPr>
+            <p:spPr>
+              <a:xfrm>
+                <a:off x="835255" y="7924244"/>
+                <a:ext cx="2262481" cy="573465"/>
+              </a:xfrm>
+              <a:prstGeom prst="rect">
+                <a:avLst/>
+              </a:prstGeom>
+              <a:noFill/>
+            </p:spPr>
+            <p:txBody>
+              <a:bodyPr wrap="square" rtlCol="0">
+                <a:spAutoFit/>
+              </a:bodyPr>
+              <a:lstStyle/>
+              <a:p>
+                <a:pPr algn="ctr"/>
+                <a:r>
+                  <a:rPr kumimoji="1" lang="ja-JP" altLang="en-US" sz="2000">
+                    <a:latin typeface="Hiragino Kaku Gothic StdN W8" panose="020B0800000000000000" pitchFamily="34" charset="-128"/>
+                    <a:ea typeface="Hiragino Kaku Gothic StdN W8" panose="020B0800000000000000" pitchFamily="34" charset="-128"/>
+                  </a:rPr>
+                  <a:t>使用者団体</a:t>
+                </a:r>
+              </a:p>
+            </p:txBody>
+          </p:sp>
+        </p:grpSp>
+        <p:grpSp>
+          <p:nvGrpSpPr>
+            <p:cNvPr id="43" name="グループ化 42">
+              <a:extLst>
+                <a:ext uri="{FF2B5EF4-FFF2-40B4-BE49-F238E27FC236}">
+                  <a16:creationId xmlns:a16="http://schemas.microsoft.com/office/drawing/2014/main" id="{BE77B804-5E76-6F04-B508-C9AFD2D37147}"/>
+                </a:ext>
+              </a:extLst>
+            </p:cNvPr>
+            <p:cNvGrpSpPr/>
+            <p:nvPr/>
+          </p:nvGrpSpPr>
+          <p:grpSpPr>
+            <a:xfrm>
+              <a:off x="8699993" y="6123680"/>
+              <a:ext cx="1840245" cy="1689572"/>
+              <a:chOff x="579398" y="5504701"/>
+              <a:chExt cx="2774196" cy="2421610"/>
+            </a:xfrm>
+          </p:grpSpPr>
+          <p:sp>
+            <p:nvSpPr>
+              <p:cNvPr id="44" name="三角形 43">
+                <a:extLst>
+                  <a:ext uri="{FF2B5EF4-FFF2-40B4-BE49-F238E27FC236}">
+                    <a16:creationId xmlns:a16="http://schemas.microsoft.com/office/drawing/2014/main" id="{22AC3AB6-5294-D115-B494-1557F59461EA}"/>
+                  </a:ext>
+                </a:extLst>
+              </p:cNvPr>
+              <p:cNvSpPr/>
+              <p:nvPr/>
+            </p:nvSpPr>
+            <p:spPr>
+              <a:xfrm>
+                <a:off x="579398" y="5504701"/>
+                <a:ext cx="2774196" cy="2421610"/>
+              </a:xfrm>
+              <a:prstGeom prst="triangle">
+                <a:avLst/>
+              </a:prstGeom>
+              <a:noFill/>
+              <a:ln w="28575">
+                <a:solidFill>
+                  <a:schemeClr val="tx1"/>
+                </a:solidFill>
+              </a:ln>
+            </p:spPr>
+            <p:style>
+              <a:lnRef idx="2">
+                <a:schemeClr val="accent1">
+                  <a:shade val="15000"/>
+                </a:schemeClr>
+              </a:lnRef>
+              <a:fillRef idx="1">
+                <a:schemeClr val="accent1"/>
+              </a:fillRef>
+              <a:effectRef idx="0">
+                <a:schemeClr val="accent1"/>
+              </a:effectRef>
+              <a:fontRef idx="minor">
+                <a:schemeClr val="lt1"/>
+              </a:fontRef>
+            </p:style>
+            <p:txBody>
+              <a:bodyPr rtlCol="0" anchor="ctr"/>
+              <a:lstStyle/>
+              <a:p>
+                <a:pPr algn="ctr"/>
+                <a:endParaRPr kumimoji="1" lang="ja-JP" altLang="en-US"/>
+              </a:p>
+            </p:txBody>
+          </p:sp>
+          <p:sp>
+            <p:nvSpPr>
+              <p:cNvPr id="45" name="円/楕円 44">
+                <a:extLst>
+                  <a:ext uri="{FF2B5EF4-FFF2-40B4-BE49-F238E27FC236}">
+                    <a16:creationId xmlns:a16="http://schemas.microsoft.com/office/drawing/2014/main" id="{04CBDD59-63E0-2C22-754E-1AD9F64C6238}"/>
+                  </a:ext>
+                </a:extLst>
+              </p:cNvPr>
+              <p:cNvSpPr/>
+              <p:nvPr/>
+            </p:nvSpPr>
+            <p:spPr>
+              <a:xfrm>
+                <a:off x="1152013" y="7100843"/>
+                <a:ext cx="573438" cy="573438"/>
+              </a:xfrm>
+              <a:prstGeom prst="ellipse">
+                <a:avLst/>
+              </a:prstGeom>
+              <a:noFill/>
+              <a:ln w="19050">
+                <a:solidFill>
+                  <a:schemeClr val="tx1"/>
+                </a:solidFill>
+              </a:ln>
+            </p:spPr>
+            <p:style>
+              <a:lnRef idx="2">
+                <a:schemeClr val="accent1">
+                  <a:shade val="15000"/>
+                </a:schemeClr>
+              </a:lnRef>
+              <a:fillRef idx="1">
+                <a:schemeClr val="accent1"/>
+              </a:fillRef>
+              <a:effectRef idx="0">
+                <a:schemeClr val="accent1"/>
+              </a:effectRef>
+              <a:fontRef idx="minor">
+                <a:schemeClr val="lt1"/>
+              </a:fontRef>
+            </p:style>
+            <p:txBody>
+              <a:bodyPr rtlCol="0" anchor="ctr"/>
+              <a:lstStyle/>
+              <a:p>
+                <a:pPr algn="ctr"/>
+                <a:r>
+                  <a:rPr kumimoji="1" lang="ja-JP" altLang="en-US" sz="2400">
+                    <a:solidFill>
+                      <a:schemeClr val="tx1"/>
+                    </a:solidFill>
+                    <a:latin typeface="Hiragino Sans W4" panose="020B0400000000000000" pitchFamily="34" charset="-128"/>
+                    <a:ea typeface="Hiragino Sans W4" panose="020B0400000000000000" pitchFamily="34" charset="-128"/>
+                  </a:rPr>
+                  <a:t>企</a:t>
+                </a:r>
+              </a:p>
+            </p:txBody>
+          </p:sp>
+          <p:sp>
+            <p:nvSpPr>
+              <p:cNvPr id="46" name="円/楕円 45">
+                <a:extLst>
+                  <a:ext uri="{FF2B5EF4-FFF2-40B4-BE49-F238E27FC236}">
+                    <a16:creationId xmlns:a16="http://schemas.microsoft.com/office/drawing/2014/main" id="{337820BD-3E14-AA73-ECB4-A075B6608C95}"/>
+                  </a:ext>
+                </a:extLst>
+              </p:cNvPr>
+              <p:cNvSpPr/>
+              <p:nvPr/>
+            </p:nvSpPr>
+            <p:spPr>
+              <a:xfrm>
+                <a:off x="2252803" y="7100843"/>
+                <a:ext cx="573438" cy="573438"/>
+              </a:xfrm>
+              <a:prstGeom prst="ellipse">
+                <a:avLst/>
+              </a:prstGeom>
+              <a:noFill/>
+              <a:ln w="19050">
+                <a:solidFill>
+                  <a:schemeClr val="tx1"/>
+                </a:solidFill>
+              </a:ln>
+            </p:spPr>
+            <p:style>
+              <a:lnRef idx="2">
+                <a:schemeClr val="accent1">
+                  <a:shade val="15000"/>
+                </a:schemeClr>
+              </a:lnRef>
+              <a:fillRef idx="1">
+                <a:schemeClr val="accent1"/>
+              </a:fillRef>
+              <a:effectRef idx="0">
+                <a:schemeClr val="accent1"/>
+              </a:effectRef>
+              <a:fontRef idx="minor">
+                <a:schemeClr val="lt1"/>
+              </a:fontRef>
+            </p:style>
+            <p:txBody>
+              <a:bodyPr rtlCol="0" anchor="ctr"/>
+              <a:lstStyle/>
+              <a:p>
+                <a:pPr algn="ctr"/>
+                <a:r>
+                  <a:rPr kumimoji="1" lang="ja-JP" altLang="en-US" sz="2400">
+                    <a:solidFill>
+                      <a:schemeClr val="tx1"/>
+                    </a:solidFill>
+                    <a:latin typeface="Hiragino Sans W4" panose="020B0400000000000000" pitchFamily="34" charset="-128"/>
+                    <a:ea typeface="Hiragino Sans W4" panose="020B0400000000000000" pitchFamily="34" charset="-128"/>
+                  </a:rPr>
+                  <a:t>企</a:t>
+                </a:r>
+              </a:p>
+            </p:txBody>
+          </p:sp>
+          <p:sp>
+            <p:nvSpPr>
+              <p:cNvPr id="47" name="円/楕円 46">
+                <a:extLst>
+                  <a:ext uri="{FF2B5EF4-FFF2-40B4-BE49-F238E27FC236}">
+                    <a16:creationId xmlns:a16="http://schemas.microsoft.com/office/drawing/2014/main" id="{F5497501-E0EE-9F0F-9B0B-0BD5D21B6675}"/>
+                  </a:ext>
+                </a:extLst>
+              </p:cNvPr>
+              <p:cNvSpPr/>
+              <p:nvPr/>
+            </p:nvSpPr>
+            <p:spPr>
+              <a:xfrm>
+                <a:off x="1679777" y="6016053"/>
+                <a:ext cx="573438" cy="573438"/>
+              </a:xfrm>
+              <a:prstGeom prst="ellipse">
+                <a:avLst/>
+              </a:prstGeom>
+              <a:noFill/>
+              <a:ln w="19050">
+                <a:solidFill>
+                  <a:schemeClr val="tx1"/>
+                </a:solidFill>
+              </a:ln>
+            </p:spPr>
+            <p:style>
+              <a:lnRef idx="2">
+                <a:schemeClr val="accent1">
+                  <a:shade val="15000"/>
+                </a:schemeClr>
+              </a:lnRef>
+              <a:fillRef idx="1">
+                <a:schemeClr val="accent1"/>
+              </a:fillRef>
+              <a:effectRef idx="0">
+                <a:schemeClr val="accent1"/>
+              </a:effectRef>
+              <a:fontRef idx="minor">
+                <a:schemeClr val="lt1"/>
+              </a:fontRef>
+            </p:style>
+            <p:txBody>
+              <a:bodyPr rtlCol="0" anchor="ctr"/>
+              <a:lstStyle/>
+              <a:p>
+                <a:pPr algn="ctr"/>
+                <a:r>
+                  <a:rPr kumimoji="1" lang="ja-JP" altLang="en-US" sz="2400">
+                    <a:solidFill>
+                      <a:schemeClr val="tx1"/>
+                    </a:solidFill>
+                    <a:latin typeface="Hiragino Sans W4" panose="020B0400000000000000" pitchFamily="34" charset="-128"/>
+                    <a:ea typeface="Hiragino Sans W4" panose="020B0400000000000000" pitchFamily="34" charset="-128"/>
+                  </a:rPr>
+                  <a:t>企</a:t>
+                </a:r>
+              </a:p>
+            </p:txBody>
+          </p:sp>
+        </p:grpSp>
+        <p:grpSp>
+          <p:nvGrpSpPr>
+            <p:cNvPr id="49" name="グループ化 48">
+              <a:extLst>
+                <a:ext uri="{FF2B5EF4-FFF2-40B4-BE49-F238E27FC236}">
+                  <a16:creationId xmlns:a16="http://schemas.microsoft.com/office/drawing/2014/main" id="{03809EC9-7C50-5C47-B46A-DDA26D0A7258}"/>
+                </a:ext>
+              </a:extLst>
+            </p:cNvPr>
+            <p:cNvGrpSpPr/>
+            <p:nvPr/>
+          </p:nvGrpSpPr>
+          <p:grpSpPr>
+            <a:xfrm>
+              <a:off x="10730021" y="6123680"/>
+              <a:ext cx="1840245" cy="1689572"/>
+              <a:chOff x="579398" y="5504701"/>
+              <a:chExt cx="2774196" cy="2421610"/>
+            </a:xfrm>
+          </p:grpSpPr>
+          <p:sp>
+            <p:nvSpPr>
+              <p:cNvPr id="50" name="三角形 49">
+                <a:extLst>
+                  <a:ext uri="{FF2B5EF4-FFF2-40B4-BE49-F238E27FC236}">
+                    <a16:creationId xmlns:a16="http://schemas.microsoft.com/office/drawing/2014/main" id="{4107C7D7-9258-1223-B0FC-779512FD8BFF}"/>
+                  </a:ext>
+                </a:extLst>
+              </p:cNvPr>
+              <p:cNvSpPr/>
+              <p:nvPr/>
+            </p:nvSpPr>
+            <p:spPr>
+              <a:xfrm>
+                <a:off x="579398" y="5504701"/>
+                <a:ext cx="2774196" cy="2421610"/>
+              </a:xfrm>
+              <a:prstGeom prst="triangle">
+                <a:avLst/>
+              </a:prstGeom>
+              <a:noFill/>
+              <a:ln w="28575">
+                <a:solidFill>
+                  <a:schemeClr val="tx1"/>
+                </a:solidFill>
+              </a:ln>
+            </p:spPr>
+            <p:style>
+              <a:lnRef idx="2">
+                <a:schemeClr val="accent1">
+                  <a:shade val="15000"/>
+                </a:schemeClr>
+              </a:lnRef>
+              <a:fillRef idx="1">
+                <a:schemeClr val="accent1"/>
+              </a:fillRef>
+              <a:effectRef idx="0">
+                <a:schemeClr val="accent1"/>
+              </a:effectRef>
+              <a:fontRef idx="minor">
+                <a:schemeClr val="lt1"/>
+              </a:fontRef>
+            </p:style>
+            <p:txBody>
+              <a:bodyPr rtlCol="0" anchor="ctr"/>
+              <a:lstStyle/>
+              <a:p>
+                <a:pPr algn="ctr"/>
+                <a:endParaRPr kumimoji="1" lang="ja-JP" altLang="en-US"/>
+              </a:p>
+            </p:txBody>
+          </p:sp>
+          <p:sp>
+            <p:nvSpPr>
+              <p:cNvPr id="51" name="円/楕円 50">
+                <a:extLst>
+                  <a:ext uri="{FF2B5EF4-FFF2-40B4-BE49-F238E27FC236}">
+                    <a16:creationId xmlns:a16="http://schemas.microsoft.com/office/drawing/2014/main" id="{BC547F53-6B55-08C1-3D8E-AC7BE66CE6B8}"/>
+                  </a:ext>
+                </a:extLst>
+              </p:cNvPr>
+              <p:cNvSpPr/>
+              <p:nvPr/>
+            </p:nvSpPr>
+            <p:spPr>
+              <a:xfrm>
+                <a:off x="1152013" y="7100843"/>
+                <a:ext cx="573438" cy="573438"/>
+              </a:xfrm>
+              <a:prstGeom prst="ellipse">
+                <a:avLst/>
+              </a:prstGeom>
+              <a:noFill/>
+              <a:ln w="19050">
+                <a:solidFill>
+                  <a:schemeClr val="tx1"/>
+                </a:solidFill>
+              </a:ln>
+            </p:spPr>
+            <p:style>
+              <a:lnRef idx="2">
+                <a:schemeClr val="accent1">
+                  <a:shade val="15000"/>
+                </a:schemeClr>
+              </a:lnRef>
+              <a:fillRef idx="1">
+                <a:schemeClr val="accent1"/>
+              </a:fillRef>
+              <a:effectRef idx="0">
+                <a:schemeClr val="accent1"/>
+              </a:effectRef>
+              <a:fontRef idx="minor">
+                <a:schemeClr val="lt1"/>
+              </a:fontRef>
+            </p:style>
+            <p:txBody>
+              <a:bodyPr rtlCol="0" anchor="ctr"/>
+              <a:lstStyle/>
+              <a:p>
+                <a:pPr algn="ctr"/>
+                <a:r>
+                  <a:rPr kumimoji="1" lang="ja-JP" altLang="en-US" sz="2400">
+                    <a:solidFill>
+                      <a:schemeClr val="tx1"/>
+                    </a:solidFill>
+                    <a:latin typeface="Hiragino Sans W4" panose="020B0400000000000000" pitchFamily="34" charset="-128"/>
+                    <a:ea typeface="Hiragino Sans W4" panose="020B0400000000000000" pitchFamily="34" charset="-128"/>
+                  </a:rPr>
+                  <a:t>企</a:t>
+                </a:r>
+              </a:p>
+            </p:txBody>
+          </p:sp>
+          <p:sp>
+            <p:nvSpPr>
+              <p:cNvPr id="52" name="円/楕円 51">
+                <a:extLst>
+                  <a:ext uri="{FF2B5EF4-FFF2-40B4-BE49-F238E27FC236}">
+                    <a16:creationId xmlns:a16="http://schemas.microsoft.com/office/drawing/2014/main" id="{2ED1EFB9-401F-C4E8-FA4E-9D3A6A684A5F}"/>
+                  </a:ext>
+                </a:extLst>
+              </p:cNvPr>
+              <p:cNvSpPr/>
+              <p:nvPr/>
+            </p:nvSpPr>
+            <p:spPr>
+              <a:xfrm>
+                <a:off x="2252803" y="7100843"/>
+                <a:ext cx="573438" cy="573438"/>
+              </a:xfrm>
+              <a:prstGeom prst="ellipse">
+                <a:avLst/>
+              </a:prstGeom>
+              <a:noFill/>
+              <a:ln w="19050">
+                <a:solidFill>
+                  <a:schemeClr val="tx1"/>
+                </a:solidFill>
+              </a:ln>
+            </p:spPr>
+            <p:style>
+              <a:lnRef idx="2">
+                <a:schemeClr val="accent1">
+                  <a:shade val="15000"/>
+                </a:schemeClr>
+              </a:lnRef>
+              <a:fillRef idx="1">
+                <a:schemeClr val="accent1"/>
+              </a:fillRef>
+              <a:effectRef idx="0">
+                <a:schemeClr val="accent1"/>
+              </a:effectRef>
+              <a:fontRef idx="minor">
+                <a:schemeClr val="lt1"/>
+              </a:fontRef>
+            </p:style>
+            <p:txBody>
+              <a:bodyPr rtlCol="0" anchor="ctr"/>
+              <a:lstStyle/>
+              <a:p>
+                <a:pPr algn="ctr"/>
+                <a:r>
+                  <a:rPr kumimoji="1" lang="ja-JP" altLang="en-US" sz="2400">
+                    <a:solidFill>
+                      <a:schemeClr val="tx1"/>
+                    </a:solidFill>
+                    <a:latin typeface="Hiragino Sans W4" panose="020B0400000000000000" pitchFamily="34" charset="-128"/>
+                    <a:ea typeface="Hiragino Sans W4" panose="020B0400000000000000" pitchFamily="34" charset="-128"/>
+                  </a:rPr>
+                  <a:t>企</a:t>
+                </a:r>
+              </a:p>
+            </p:txBody>
+          </p:sp>
+          <p:sp>
+            <p:nvSpPr>
+              <p:cNvPr id="53" name="円/楕円 52">
+                <a:extLst>
+                  <a:ext uri="{FF2B5EF4-FFF2-40B4-BE49-F238E27FC236}">
+                    <a16:creationId xmlns:a16="http://schemas.microsoft.com/office/drawing/2014/main" id="{DCC7C095-8795-FB85-5B00-E0A579ED2E0D}"/>
+                  </a:ext>
+                </a:extLst>
+              </p:cNvPr>
+              <p:cNvSpPr/>
+              <p:nvPr/>
+            </p:nvSpPr>
+            <p:spPr>
+              <a:xfrm>
+                <a:off x="1679777" y="6016053"/>
+                <a:ext cx="573438" cy="573438"/>
+              </a:xfrm>
+              <a:prstGeom prst="ellipse">
+                <a:avLst/>
+              </a:prstGeom>
+              <a:noFill/>
+              <a:ln w="19050">
+                <a:solidFill>
+                  <a:schemeClr val="tx1"/>
+                </a:solidFill>
+              </a:ln>
+            </p:spPr>
+            <p:style>
+              <a:lnRef idx="2">
+                <a:schemeClr val="accent1">
+                  <a:shade val="15000"/>
+                </a:schemeClr>
+              </a:lnRef>
+              <a:fillRef idx="1">
+                <a:schemeClr val="accent1"/>
+              </a:fillRef>
+              <a:effectRef idx="0">
+                <a:schemeClr val="accent1"/>
+              </a:effectRef>
+              <a:fontRef idx="minor">
+                <a:schemeClr val="lt1"/>
+              </a:fontRef>
+            </p:style>
+            <p:txBody>
+              <a:bodyPr rtlCol="0" anchor="ctr"/>
+              <a:lstStyle/>
+              <a:p>
+                <a:pPr algn="ctr"/>
+                <a:r>
+                  <a:rPr kumimoji="1" lang="ja-JP" altLang="en-US" sz="2400">
+                    <a:solidFill>
+                      <a:schemeClr val="tx1"/>
+                    </a:solidFill>
+                    <a:latin typeface="Hiragino Sans W4" panose="020B0400000000000000" pitchFamily="34" charset="-128"/>
+                    <a:ea typeface="Hiragino Sans W4" panose="020B0400000000000000" pitchFamily="34" charset="-128"/>
+                  </a:rPr>
+                  <a:t>企</a:t>
+                </a:r>
+              </a:p>
+            </p:txBody>
+          </p:sp>
+        </p:grpSp>
+        <p:sp>
+          <p:nvSpPr>
+            <p:cNvPr id="55" name="角丸四角形 54">
+              <a:extLst>
+                <a:ext uri="{FF2B5EF4-FFF2-40B4-BE49-F238E27FC236}">
+                  <a16:creationId xmlns:a16="http://schemas.microsoft.com/office/drawing/2014/main" id="{F482FFE0-672E-F5E1-A1B1-9818A56A1F66}"/>
+                </a:ext>
+              </a:extLst>
+            </p:cNvPr>
+            <p:cNvSpPr/>
+            <p:nvPr/>
+          </p:nvSpPr>
+          <p:spPr>
+            <a:xfrm>
+              <a:off x="8360152" y="2729133"/>
+              <a:ext cx="2599651" cy="1273126"/>
+            </a:xfrm>
+            <a:prstGeom prst="roundRect">
+              <a:avLst/>
+            </a:prstGeom>
+            <a:noFill/>
+            <a:ln w="28575">
+              <a:solidFill>
+                <a:schemeClr val="tx1"/>
+              </a:solidFill>
+            </a:ln>
+          </p:spPr>
+          <p:style>
+            <a:lnRef idx="2">
+              <a:schemeClr val="accent1">
+                <a:shade val="15000"/>
+              </a:schemeClr>
+            </a:lnRef>
+            <a:fillRef idx="1">
+              <a:schemeClr val="accent1"/>
+            </a:fillRef>
+            <a:effectRef idx="0">
+              <a:schemeClr val="accent1"/>
+            </a:effectRef>
+            <a:fontRef idx="minor">
+              <a:schemeClr val="lt1"/>
+            </a:fontRef>
+          </p:style>
+          <p:txBody>
+            <a:bodyPr rtlCol="0" anchor="ctr"/>
+            <a:lstStyle/>
+            <a:p>
+              <a:pPr algn="ctr"/>
+              <a:r>
+                <a:rPr kumimoji="1" lang="ja-JP" altLang="en-US" sz="4400">
+                  <a:solidFill>
+                    <a:schemeClr val="tx1"/>
+                  </a:solidFill>
+                  <a:latin typeface="Hiragino Kaku Gothic StdN W8" panose="020B0800000000000000" pitchFamily="34" charset="-128"/>
+                  <a:ea typeface="Hiragino Kaku Gothic StdN W8" panose="020B0800000000000000" pitchFamily="34" charset="-128"/>
+                </a:rPr>
+                <a:t>頂上団体</a:t>
+              </a:r>
+              <a:endParaRPr kumimoji="1" lang="ja-JP" altLang="en-US" sz="3000"/>
+            </a:p>
+          </p:txBody>
+        </p:sp>
+        <p:sp>
+          <p:nvSpPr>
+            <p:cNvPr id="56" name="テキスト ボックス 55">
+              <a:extLst>
+                <a:ext uri="{FF2B5EF4-FFF2-40B4-BE49-F238E27FC236}">
+                  <a16:creationId xmlns:a16="http://schemas.microsoft.com/office/drawing/2014/main" id="{C520D47E-E71B-F675-B830-82886B0E774E}"/>
+                </a:ext>
+              </a:extLst>
+            </p:cNvPr>
+            <p:cNvSpPr txBox="1"/>
+            <p:nvPr/>
+          </p:nvSpPr>
+          <p:spPr>
+            <a:xfrm>
+              <a:off x="8869714" y="7813252"/>
+              <a:ext cx="1500802" cy="400110"/>
+            </a:xfrm>
+            <a:prstGeom prst="rect">
+              <a:avLst/>
+            </a:prstGeom>
+            <a:noFill/>
+          </p:spPr>
+          <p:txBody>
+            <a:bodyPr wrap="square" rtlCol="0">
+              <a:spAutoFit/>
+            </a:bodyPr>
+            <a:lstStyle/>
+            <a:p>
+              <a:pPr algn="ctr"/>
+              <a:r>
+                <a:rPr kumimoji="1" lang="ja-JP" altLang="en-US" sz="2000">
+                  <a:latin typeface="Hiragino Kaku Gothic StdN W8" panose="020B0800000000000000" pitchFamily="34" charset="-128"/>
+                  <a:ea typeface="Hiragino Kaku Gothic StdN W8" panose="020B0800000000000000" pitchFamily="34" charset="-128"/>
+                </a:rPr>
+                <a:t>使用者団体</a:t>
+              </a:r>
+            </a:p>
+          </p:txBody>
+        </p:sp>
+        <p:sp>
+          <p:nvSpPr>
+            <p:cNvPr id="57" name="テキスト ボックス 56">
+              <a:extLst>
+                <a:ext uri="{FF2B5EF4-FFF2-40B4-BE49-F238E27FC236}">
+                  <a16:creationId xmlns:a16="http://schemas.microsoft.com/office/drawing/2014/main" id="{556A6724-2D6D-892C-2BDE-A79226F947DF}"/>
+                </a:ext>
+              </a:extLst>
+            </p:cNvPr>
+            <p:cNvSpPr txBox="1"/>
+            <p:nvPr/>
+          </p:nvSpPr>
+          <p:spPr>
+            <a:xfrm>
+              <a:off x="10899742" y="7813252"/>
+              <a:ext cx="1500802" cy="400110"/>
+            </a:xfrm>
+            <a:prstGeom prst="rect">
+              <a:avLst/>
+            </a:prstGeom>
+            <a:noFill/>
+          </p:spPr>
+          <p:txBody>
+            <a:bodyPr wrap="square" rtlCol="0">
+              <a:spAutoFit/>
+            </a:bodyPr>
+            <a:lstStyle/>
+            <a:p>
+              <a:pPr algn="ctr"/>
+              <a:r>
+                <a:rPr kumimoji="1" lang="ja-JP" altLang="en-US" sz="2000">
+                  <a:latin typeface="Hiragino Kaku Gothic StdN W8" panose="020B0800000000000000" pitchFamily="34" charset="-128"/>
+                  <a:ea typeface="Hiragino Kaku Gothic StdN W8" panose="020B0800000000000000" pitchFamily="34" charset="-128"/>
+                </a:rPr>
+                <a:t>使用者団体</a:t>
+              </a:r>
+            </a:p>
+          </p:txBody>
+        </p:sp>
+        <p:cxnSp>
+          <p:nvCxnSpPr>
+            <p:cNvPr id="59" name="直線矢印コネクタ 58">
+              <a:extLst>
+                <a:ext uri="{FF2B5EF4-FFF2-40B4-BE49-F238E27FC236}">
+                  <a16:creationId xmlns:a16="http://schemas.microsoft.com/office/drawing/2014/main" id="{A5CD41FE-974D-0335-2D83-E7BD405E0090}"/>
+                </a:ext>
+              </a:extLst>
+            </p:cNvPr>
+            <p:cNvCxnSpPr>
+              <a:stCxn id="34" idx="2"/>
+              <a:endCxn id="4" idx="0"/>
+            </p:cNvCxnSpPr>
+            <p:nvPr/>
+          </p:nvCxnSpPr>
+          <p:spPr>
+            <a:xfrm flipH="1">
+              <a:off x="1150103" y="4002259"/>
+              <a:ext cx="2069890" cy="2122863"/>
+            </a:xfrm>
+            <a:prstGeom prst="straightConnector1">
+              <a:avLst/>
+            </a:prstGeom>
+            <a:ln w="50800" cmpd="dbl">
+              <a:solidFill>
+                <a:schemeClr val="tx1"/>
+              </a:solidFill>
+              <a:tailEnd type="triangle"/>
+            </a:ln>
+          </p:spPr>
+          <p:style>
+            <a:lnRef idx="1">
+              <a:schemeClr val="accent1"/>
+            </a:lnRef>
+            <a:fillRef idx="0">
+              <a:schemeClr val="accent1"/>
+            </a:fillRef>
+            <a:effectRef idx="0">
+              <a:schemeClr val="accent1"/>
+            </a:effectRef>
+            <a:fontRef idx="minor">
+              <a:schemeClr val="tx1"/>
+            </a:fontRef>
+          </p:style>
+        </p:cxnSp>
+        <p:cxnSp>
+          <p:nvCxnSpPr>
+            <p:cNvPr id="60" name="直線矢印コネクタ 59">
+              <a:extLst>
+                <a:ext uri="{FF2B5EF4-FFF2-40B4-BE49-F238E27FC236}">
+                  <a16:creationId xmlns:a16="http://schemas.microsoft.com/office/drawing/2014/main" id="{0B0307D1-DF78-69EB-6AAE-0C37057BD99F}"/>
+                </a:ext>
+              </a:extLst>
+            </p:cNvPr>
+            <p:cNvCxnSpPr>
+              <a:cxnSpLocks/>
+              <a:stCxn id="34" idx="2"/>
+              <a:endCxn id="23" idx="0"/>
+            </p:cNvCxnSpPr>
+            <p:nvPr/>
+          </p:nvCxnSpPr>
+          <p:spPr>
+            <a:xfrm flipH="1">
+              <a:off x="3180131" y="4002259"/>
+              <a:ext cx="39862" cy="2121421"/>
+            </a:xfrm>
+            <a:prstGeom prst="straightConnector1">
+              <a:avLst/>
+            </a:prstGeom>
+            <a:ln w="50800" cmpd="dbl">
+              <a:solidFill>
+                <a:schemeClr val="tx1"/>
+              </a:solidFill>
+              <a:tailEnd type="triangle"/>
+            </a:ln>
+          </p:spPr>
+          <p:style>
+            <a:lnRef idx="1">
+              <a:schemeClr val="accent1"/>
+            </a:lnRef>
+            <a:fillRef idx="0">
+              <a:schemeClr val="accent1"/>
+            </a:fillRef>
+            <a:effectRef idx="0">
+              <a:schemeClr val="accent1"/>
+            </a:effectRef>
+            <a:fontRef idx="minor">
+              <a:schemeClr val="tx1"/>
+            </a:fontRef>
+          </p:style>
+        </p:cxnSp>
+        <p:cxnSp>
+          <p:nvCxnSpPr>
+            <p:cNvPr id="61" name="直線矢印コネクタ 60">
+              <a:extLst>
+                <a:ext uri="{FF2B5EF4-FFF2-40B4-BE49-F238E27FC236}">
+                  <a16:creationId xmlns:a16="http://schemas.microsoft.com/office/drawing/2014/main" id="{5F781E67-518F-8313-0823-DB624DB61655}"/>
+                </a:ext>
+              </a:extLst>
+            </p:cNvPr>
+            <p:cNvCxnSpPr>
+              <a:cxnSpLocks/>
+              <a:stCxn id="34" idx="2"/>
+              <a:endCxn id="29" idx="0"/>
+            </p:cNvCxnSpPr>
+            <p:nvPr/>
+          </p:nvCxnSpPr>
+          <p:spPr>
+            <a:xfrm>
+              <a:off x="3219993" y="4002259"/>
+              <a:ext cx="1990166" cy="2121421"/>
+            </a:xfrm>
+            <a:prstGeom prst="straightConnector1">
+              <a:avLst/>
+            </a:prstGeom>
+            <a:ln w="50800" cmpd="dbl">
+              <a:solidFill>
+                <a:schemeClr val="tx1"/>
+              </a:solidFill>
+              <a:tailEnd type="triangle"/>
+            </a:ln>
+          </p:spPr>
+          <p:style>
+            <a:lnRef idx="1">
+              <a:schemeClr val="accent1"/>
+            </a:lnRef>
+            <a:fillRef idx="0">
+              <a:schemeClr val="accent1"/>
+            </a:fillRef>
+            <a:effectRef idx="0">
+              <a:schemeClr val="accent1"/>
+            </a:effectRef>
+            <a:fontRef idx="minor">
+              <a:schemeClr val="tx1"/>
+            </a:fontRef>
+          </p:style>
+        </p:cxnSp>
+        <p:cxnSp>
+          <p:nvCxnSpPr>
+            <p:cNvPr id="66" name="直線矢印コネクタ 65">
+              <a:extLst>
+                <a:ext uri="{FF2B5EF4-FFF2-40B4-BE49-F238E27FC236}">
+                  <a16:creationId xmlns:a16="http://schemas.microsoft.com/office/drawing/2014/main" id="{12726559-62A0-8F26-52CF-9A11A07A80FA}"/>
+                </a:ext>
+              </a:extLst>
+            </p:cNvPr>
+            <p:cNvCxnSpPr>
+              <a:cxnSpLocks/>
+              <a:stCxn id="55" idx="2"/>
+              <a:endCxn id="38" idx="0"/>
+            </p:cNvCxnSpPr>
+            <p:nvPr/>
+          </p:nvCxnSpPr>
+          <p:spPr>
+            <a:xfrm flipH="1">
+              <a:off x="7590088" y="4002259"/>
+              <a:ext cx="2069890" cy="2122863"/>
+            </a:xfrm>
+            <a:prstGeom prst="straightConnector1">
+              <a:avLst/>
+            </a:prstGeom>
+            <a:ln w="50800" cmpd="dbl">
+              <a:solidFill>
+                <a:schemeClr val="tx1"/>
+              </a:solidFill>
+              <a:tailEnd type="triangle"/>
+            </a:ln>
+          </p:spPr>
+          <p:style>
+            <a:lnRef idx="1">
+              <a:schemeClr val="accent1"/>
+            </a:lnRef>
+            <a:fillRef idx="0">
+              <a:schemeClr val="accent1"/>
+            </a:fillRef>
+            <a:effectRef idx="0">
+              <a:schemeClr val="accent1"/>
+            </a:effectRef>
+            <a:fontRef idx="minor">
+              <a:schemeClr val="tx1"/>
+            </a:fontRef>
+          </p:style>
+        </p:cxnSp>
+        <p:cxnSp>
+          <p:nvCxnSpPr>
+            <p:cNvPr id="67" name="直線矢印コネクタ 66">
+              <a:extLst>
+                <a:ext uri="{FF2B5EF4-FFF2-40B4-BE49-F238E27FC236}">
+                  <a16:creationId xmlns:a16="http://schemas.microsoft.com/office/drawing/2014/main" id="{AE7BFCC1-1847-E40E-A9F3-62DF899AD1B3}"/>
+                </a:ext>
+              </a:extLst>
+            </p:cNvPr>
+            <p:cNvCxnSpPr>
+              <a:cxnSpLocks/>
+              <a:stCxn id="55" idx="2"/>
+              <a:endCxn id="44" idx="0"/>
+            </p:cNvCxnSpPr>
+            <p:nvPr/>
+          </p:nvCxnSpPr>
+          <p:spPr>
+            <a:xfrm flipH="1">
+              <a:off x="9620116" y="4002259"/>
+              <a:ext cx="39862" cy="2121421"/>
+            </a:xfrm>
+            <a:prstGeom prst="straightConnector1">
+              <a:avLst/>
+            </a:prstGeom>
+            <a:ln w="50800" cmpd="dbl">
+              <a:solidFill>
+                <a:schemeClr val="tx1"/>
+              </a:solidFill>
+              <a:tailEnd type="triangle"/>
+            </a:ln>
+          </p:spPr>
+          <p:style>
+            <a:lnRef idx="1">
+              <a:schemeClr val="accent1"/>
+            </a:lnRef>
+            <a:fillRef idx="0">
+              <a:schemeClr val="accent1"/>
+            </a:fillRef>
+            <a:effectRef idx="0">
+              <a:schemeClr val="accent1"/>
+            </a:effectRef>
+            <a:fontRef idx="minor">
+              <a:schemeClr val="tx1"/>
+            </a:fontRef>
+          </p:style>
+        </p:cxnSp>
+        <p:cxnSp>
+          <p:nvCxnSpPr>
+            <p:cNvPr id="68" name="直線矢印コネクタ 67">
+              <a:extLst>
+                <a:ext uri="{FF2B5EF4-FFF2-40B4-BE49-F238E27FC236}">
+                  <a16:creationId xmlns:a16="http://schemas.microsoft.com/office/drawing/2014/main" id="{E794A5E9-2B89-9A02-EA83-65C3A9AD4B18}"/>
+                </a:ext>
+              </a:extLst>
+            </p:cNvPr>
+            <p:cNvCxnSpPr>
+              <a:cxnSpLocks/>
+              <a:stCxn id="55" idx="2"/>
+            </p:cNvCxnSpPr>
+            <p:nvPr/>
+          </p:nvCxnSpPr>
+          <p:spPr>
+            <a:xfrm>
+              <a:off x="9659978" y="4002259"/>
+              <a:ext cx="1991519" cy="2121420"/>
+            </a:xfrm>
+            <a:prstGeom prst="straightConnector1">
+              <a:avLst/>
+            </a:prstGeom>
+            <a:ln w="50800" cmpd="dbl">
+              <a:solidFill>
+                <a:schemeClr val="tx1"/>
+              </a:solidFill>
+              <a:tailEnd type="triangle"/>
+            </a:ln>
+          </p:spPr>
+          <p:style>
+            <a:lnRef idx="1">
+              <a:schemeClr val="accent1"/>
+            </a:lnRef>
+            <a:fillRef idx="0">
+              <a:schemeClr val="accent1"/>
+            </a:fillRef>
+            <a:effectRef idx="0">
+              <a:schemeClr val="accent1"/>
+            </a:effectRef>
+            <a:fontRef idx="minor">
+              <a:schemeClr val="tx1"/>
+            </a:fontRef>
+          </p:style>
+        </p:cxnSp>
+        <p:cxnSp>
+          <p:nvCxnSpPr>
+            <p:cNvPr id="74" name="直線矢印コネクタ 73">
+              <a:extLst>
+                <a:ext uri="{FF2B5EF4-FFF2-40B4-BE49-F238E27FC236}">
+                  <a16:creationId xmlns:a16="http://schemas.microsoft.com/office/drawing/2014/main" id="{E41A9B02-3713-5D91-3C41-ACC19C28B2FF}"/>
+                </a:ext>
+              </a:extLst>
+            </p:cNvPr>
+            <p:cNvCxnSpPr>
+              <a:cxnSpLocks/>
+              <a:stCxn id="55" idx="1"/>
+              <a:endCxn id="34" idx="3"/>
+            </p:cNvCxnSpPr>
+            <p:nvPr/>
+          </p:nvCxnSpPr>
+          <p:spPr>
+            <a:xfrm flipH="1">
+              <a:off x="4519818" y="3365696"/>
+              <a:ext cx="3840334" cy="0"/>
+            </a:xfrm>
+            <a:prstGeom prst="straightConnector1">
+              <a:avLst/>
+            </a:prstGeom>
+            <a:ln w="63500" cap="sq">
+              <a:solidFill>
+                <a:srgbClr val="FF0000"/>
+              </a:solidFill>
+              <a:headEnd type="stealth"/>
+              <a:tailEnd type="stealth"/>
+            </a:ln>
+          </p:spPr>
+          <p:style>
+            <a:lnRef idx="1">
+              <a:schemeClr val="accent1"/>
+            </a:lnRef>
+            <a:fillRef idx="0">
+              <a:schemeClr val="accent1"/>
+            </a:fillRef>
+            <a:effectRef idx="0">
+              <a:schemeClr val="accent1"/>
+            </a:effectRef>
+            <a:fontRef idx="minor">
+              <a:schemeClr val="tx1"/>
+            </a:fontRef>
+          </p:style>
+        </p:cxnSp>
+        <p:cxnSp>
+          <p:nvCxnSpPr>
+            <p:cNvPr id="77" name="直線矢印コネクタ 76">
+              <a:extLst>
+                <a:ext uri="{FF2B5EF4-FFF2-40B4-BE49-F238E27FC236}">
+                  <a16:creationId xmlns:a16="http://schemas.microsoft.com/office/drawing/2014/main" id="{33A107A3-FD3F-2AAA-6ADE-C074E99B5D72}"/>
+                </a:ext>
+              </a:extLst>
+            </p:cNvPr>
+            <p:cNvCxnSpPr>
+              <a:cxnSpLocks/>
+              <a:stCxn id="55" idx="1"/>
+              <a:endCxn id="2" idx="2"/>
+            </p:cNvCxnSpPr>
+            <p:nvPr/>
+          </p:nvCxnSpPr>
+          <p:spPr>
+            <a:xfrm flipH="1" flipV="1">
+              <a:off x="6400800" y="1078523"/>
+              <a:ext cx="1959352" cy="2287173"/>
+            </a:xfrm>
+            <a:prstGeom prst="straightConnector1">
+              <a:avLst/>
+            </a:prstGeom>
+            <a:ln w="63500" cap="sq">
+              <a:solidFill>
+                <a:srgbClr val="FF0000"/>
+              </a:solidFill>
+              <a:headEnd type="stealth"/>
+              <a:tailEnd type="stealth"/>
+            </a:ln>
+          </p:spPr>
+          <p:style>
+            <a:lnRef idx="1">
+              <a:schemeClr val="accent1"/>
+            </a:lnRef>
+            <a:fillRef idx="0">
+              <a:schemeClr val="accent1"/>
+            </a:fillRef>
+            <a:effectRef idx="0">
+              <a:schemeClr val="accent1"/>
+            </a:effectRef>
+            <a:fontRef idx="minor">
+              <a:schemeClr val="tx1"/>
+            </a:fontRef>
+          </p:style>
+        </p:cxnSp>
+        <p:cxnSp>
+          <p:nvCxnSpPr>
+            <p:cNvPr id="80" name="直線矢印コネクタ 79">
+              <a:extLst>
+                <a:ext uri="{FF2B5EF4-FFF2-40B4-BE49-F238E27FC236}">
+                  <a16:creationId xmlns:a16="http://schemas.microsoft.com/office/drawing/2014/main" id="{10C09DCB-9675-825F-7CDA-3231AB9CDAD9}"/>
+                </a:ext>
+              </a:extLst>
+            </p:cNvPr>
+            <p:cNvCxnSpPr>
+              <a:cxnSpLocks/>
+              <a:stCxn id="34" idx="3"/>
+              <a:endCxn id="2" idx="2"/>
+            </p:cNvCxnSpPr>
+            <p:nvPr/>
+          </p:nvCxnSpPr>
+          <p:spPr>
+            <a:xfrm flipV="1">
+              <a:off x="4519818" y="1078523"/>
+              <a:ext cx="1880982" cy="2287173"/>
+            </a:xfrm>
+            <a:prstGeom prst="straightConnector1">
+              <a:avLst/>
+            </a:prstGeom>
+            <a:ln w="63500" cap="sq">
+              <a:solidFill>
+                <a:srgbClr val="FF0000"/>
+              </a:solidFill>
+              <a:headEnd type="stealth"/>
+              <a:tailEnd type="stealth"/>
+            </a:ln>
+          </p:spPr>
+          <p:style>
+            <a:lnRef idx="1">
+              <a:schemeClr val="accent1"/>
+            </a:lnRef>
+            <a:fillRef idx="0">
+              <a:schemeClr val="accent1"/>
+            </a:fillRef>
+            <a:effectRef idx="0">
+              <a:schemeClr val="accent1"/>
+            </a:effectRef>
+            <a:fontRef idx="minor">
+              <a:schemeClr val="tx1"/>
+            </a:fontRef>
+          </p:style>
+        </p:cxnSp>
+        <p:sp>
+          <p:nvSpPr>
+            <p:cNvPr id="83" name="テキスト ボックス 82">
+              <a:extLst>
+                <a:ext uri="{FF2B5EF4-FFF2-40B4-BE49-F238E27FC236}">
+                  <a16:creationId xmlns:a16="http://schemas.microsoft.com/office/drawing/2014/main" id="{9F367425-808C-944F-3AA5-76BD21D005C5}"/>
+                </a:ext>
+              </a:extLst>
+            </p:cNvPr>
+            <p:cNvSpPr txBox="1"/>
+            <p:nvPr/>
+          </p:nvSpPr>
+          <p:spPr>
+            <a:xfrm>
+              <a:off x="5667095" y="2119201"/>
+              <a:ext cx="1415772" cy="830997"/>
+            </a:xfrm>
+            <a:prstGeom prst="rect">
+              <a:avLst/>
+            </a:prstGeom>
+            <a:noFill/>
+            <a:ln>
+              <a:noFill/>
+            </a:ln>
+          </p:spPr>
+          <p:txBody>
+            <a:bodyPr wrap="none" rtlCol="0">
+              <a:spAutoFit/>
+            </a:bodyPr>
+            <a:lstStyle/>
+            <a:p>
+              <a:pPr algn="ctr"/>
+              <a:r>
+                <a:rPr kumimoji="1" lang="ja-JP" altLang="en-US" sz="2400">
+                  <a:solidFill>
+                    <a:srgbClr val="FF0000"/>
+                  </a:solidFill>
+                  <a:latin typeface="Hiragino Sans W4" panose="020B0400000000000000" pitchFamily="34" charset="-128"/>
+                  <a:ea typeface="Hiragino Sans W4" panose="020B0400000000000000" pitchFamily="34" charset="-128"/>
+                </a:rPr>
+                <a:t>労使交渉</a:t>
+              </a:r>
+              <a:endParaRPr kumimoji="1" lang="en-US" altLang="ja-JP" sz="2400" dirty="0">
+                <a:solidFill>
+                  <a:srgbClr val="FF0000"/>
+                </a:solidFill>
+                <a:latin typeface="Hiragino Sans W4" panose="020B0400000000000000" pitchFamily="34" charset="-128"/>
+                <a:ea typeface="Hiragino Sans W4" panose="020B0400000000000000" pitchFamily="34" charset="-128"/>
+              </a:endParaRPr>
+            </a:p>
+            <a:p>
+              <a:pPr algn="ctr"/>
+              <a:r>
+                <a:rPr kumimoji="1" lang="ja-JP" altLang="en-US" sz="2400">
+                  <a:solidFill>
+                    <a:srgbClr val="FF0000"/>
+                  </a:solidFill>
+                  <a:latin typeface="Hiragino Sans W4" panose="020B0400000000000000" pitchFamily="34" charset="-128"/>
+                  <a:ea typeface="Hiragino Sans W4" panose="020B0400000000000000" pitchFamily="34" charset="-128"/>
+                </a:rPr>
+                <a:t>利益代表</a:t>
+              </a:r>
+            </a:p>
+          </p:txBody>
+        </p:sp>
+      </p:grpSp>
+    </p:spTree>
+    <p:extLst>
+      <p:ext uri="{BB962C8B-B14F-4D97-AF65-F5344CB8AC3E}">
+        <p14:creationId xmlns:p14="http://schemas.microsoft.com/office/powerpoint/2010/main" val="2760232183"/>
+      </p:ext>
+    </p:extLst>
+  </p:cSld>
+  <p:clrMapOvr>
+    <a:masterClrMapping/>
+  </p:clrMapOvr>
+</p:sld>
+</file>
+
 <file path=ppt/slides/slide2.xml><?xml version="1.0" encoding="utf-8"?>
 <p:sld xmlns:a="http://schemas.openxmlformats.org/drawingml/2006/main" xmlns:r="http://schemas.openxmlformats.org/officeDocument/2006/relationships" xmlns:p="http://schemas.openxmlformats.org/presentationml/2006/main">
   <p:cSld>
@@ -13808,6 +18002,315 @@
     <p:extLst>
       <p:ext uri="{BB962C8B-B14F-4D97-AF65-F5344CB8AC3E}">
         <p14:creationId xmlns:p14="http://schemas.microsoft.com/office/powerpoint/2010/main" val="2619129905"/>
+      </p:ext>
+    </p:extLst>
+  </p:cSld>
+  <p:clrMapOvr>
+    <a:masterClrMapping/>
+  </p:clrMapOvr>
+</p:sld>
+</file>
+
+<file path=ppt/slides/slide20.xml><?xml version="1.0" encoding="utf-8"?>
+<p:sld xmlns:a="http://schemas.openxmlformats.org/drawingml/2006/main" xmlns:r="http://schemas.openxmlformats.org/officeDocument/2006/relationships" xmlns:p="http://schemas.openxmlformats.org/presentationml/2006/main">
+  <p:cSld>
+    <p:spTree>
+      <p:nvGrpSpPr>
+        <p:cNvPr id="1" name=""/>
+        <p:cNvGrpSpPr/>
+        <p:nvPr/>
+      </p:nvGrpSpPr>
+      <p:grpSpPr>
+        <a:xfrm>
+          <a:off x="0" y="0"/>
+          <a:ext cx="0" cy="0"/>
+          <a:chOff x="0" y="0"/>
+          <a:chExt cx="0" cy="0"/>
+        </a:xfrm>
+      </p:grpSpPr>
+      <p:grpSp>
+        <p:nvGrpSpPr>
+          <p:cNvPr id="10" name="グループ化 9">
+            <a:extLst>
+              <a:ext uri="{FF2B5EF4-FFF2-40B4-BE49-F238E27FC236}">
+                <a16:creationId xmlns:a16="http://schemas.microsoft.com/office/drawing/2014/main" id="{963FB9D4-2A1C-37F0-EE62-E70545AB99F7}"/>
+              </a:ext>
+            </a:extLst>
+          </p:cNvPr>
+          <p:cNvGrpSpPr/>
+          <p:nvPr/>
+        </p:nvGrpSpPr>
+        <p:grpSpPr>
+          <a:xfrm>
+            <a:off x="516784" y="872373"/>
+            <a:ext cx="11778380" cy="7409274"/>
+            <a:chOff x="516784" y="872373"/>
+            <a:chExt cx="11778380" cy="7409274"/>
+          </a:xfrm>
+        </p:grpSpPr>
+        <p:cxnSp>
+          <p:nvCxnSpPr>
+            <p:cNvPr id="2" name="直線矢印コネクタ 1">
+              <a:extLst>
+                <a:ext uri="{FF2B5EF4-FFF2-40B4-BE49-F238E27FC236}">
+                  <a16:creationId xmlns:a16="http://schemas.microsoft.com/office/drawing/2014/main" id="{8F1BEF57-F709-F27E-9A8C-CB55F58A0A24}"/>
+                </a:ext>
+              </a:extLst>
+            </p:cNvPr>
+            <p:cNvCxnSpPr>
+              <a:cxnSpLocks/>
+            </p:cNvCxnSpPr>
+            <p:nvPr/>
+          </p:nvCxnSpPr>
+          <p:spPr>
+            <a:xfrm>
+              <a:off x="1193892" y="7696872"/>
+              <a:ext cx="11101271" cy="0"/>
+            </a:xfrm>
+            <a:prstGeom prst="straightConnector1">
+              <a:avLst/>
+            </a:prstGeom>
+            <a:ln w="57150">
+              <a:solidFill>
+                <a:schemeClr val="tx1"/>
+              </a:solidFill>
+              <a:headEnd type="none"/>
+              <a:tailEnd type="triangle"/>
+            </a:ln>
+          </p:spPr>
+          <p:style>
+            <a:lnRef idx="1">
+              <a:schemeClr val="accent1"/>
+            </a:lnRef>
+            <a:fillRef idx="0">
+              <a:schemeClr val="accent1"/>
+            </a:fillRef>
+            <a:effectRef idx="0">
+              <a:schemeClr val="accent1"/>
+            </a:effectRef>
+            <a:fontRef idx="minor">
+              <a:schemeClr val="tx1"/>
+            </a:fontRef>
+          </p:style>
+        </p:cxnSp>
+        <p:cxnSp>
+          <p:nvCxnSpPr>
+            <p:cNvPr id="3" name="直線矢印コネクタ 2">
+              <a:extLst>
+                <a:ext uri="{FF2B5EF4-FFF2-40B4-BE49-F238E27FC236}">
+                  <a16:creationId xmlns:a16="http://schemas.microsoft.com/office/drawing/2014/main" id="{22CACA83-403E-B402-098A-26821FD1D13F}"/>
+                </a:ext>
+              </a:extLst>
+            </p:cNvPr>
+            <p:cNvCxnSpPr>
+              <a:cxnSpLocks/>
+            </p:cNvCxnSpPr>
+            <p:nvPr/>
+          </p:nvCxnSpPr>
+          <p:spPr>
+            <a:xfrm flipV="1">
+              <a:off x="1193892" y="973015"/>
+              <a:ext cx="0" cy="6723857"/>
+            </a:xfrm>
+            <a:prstGeom prst="straightConnector1">
+              <a:avLst/>
+            </a:prstGeom>
+            <a:ln w="57150">
+              <a:solidFill>
+                <a:schemeClr val="tx1"/>
+              </a:solidFill>
+              <a:headEnd type="none"/>
+              <a:tailEnd type="triangle"/>
+            </a:ln>
+          </p:spPr>
+          <p:style>
+            <a:lnRef idx="1">
+              <a:schemeClr val="accent1"/>
+            </a:lnRef>
+            <a:fillRef idx="0">
+              <a:schemeClr val="accent1"/>
+            </a:fillRef>
+            <a:effectRef idx="0">
+              <a:schemeClr val="accent1"/>
+            </a:effectRef>
+            <a:fontRef idx="minor">
+              <a:schemeClr val="tx1"/>
+            </a:fontRef>
+          </p:style>
+        </p:cxnSp>
+        <p:sp>
+          <p:nvSpPr>
+            <p:cNvPr id="7" name="フリーフォーム 6">
+              <a:extLst>
+                <a:ext uri="{FF2B5EF4-FFF2-40B4-BE49-F238E27FC236}">
+                  <a16:creationId xmlns:a16="http://schemas.microsoft.com/office/drawing/2014/main" id="{E2C2C75F-5871-7E08-EF54-861834D1AF29}"/>
+                </a:ext>
+              </a:extLst>
+            </p:cNvPr>
+            <p:cNvSpPr/>
+            <p:nvPr/>
+          </p:nvSpPr>
+          <p:spPr>
+            <a:xfrm>
+              <a:off x="1757531" y="1486238"/>
+              <a:ext cx="9973994" cy="5697412"/>
+            </a:xfrm>
+            <a:custGeom>
+              <a:avLst/>
+              <a:gdLst>
+                <a:gd name="csX0" fmla="*/ 0 w 9973994"/>
+                <a:gd name="csY0" fmla="*/ 5036235 h 5050303"/>
+                <a:gd name="csX1" fmla="*/ 4965896 w 9973994"/>
+                <a:gd name="csY1" fmla="*/ 1 h 5050303"/>
+                <a:gd name="csX2" fmla="*/ 9973994 w 9973994"/>
+                <a:gd name="csY2" fmla="*/ 5050303 h 5050303"/>
+              </a:gdLst>
+              <a:ahLst/>
+              <a:cxnLst>
+                <a:cxn ang="0">
+                  <a:pos x="csX0" y="csY0"/>
+                </a:cxn>
+                <a:cxn ang="0">
+                  <a:pos x="csX1" y="csY1"/>
+                </a:cxn>
+                <a:cxn ang="0">
+                  <a:pos x="csX2" y="csY2"/>
+                </a:cxn>
+              </a:cxnLst>
+              <a:rect l="l" t="t" r="r" b="b"/>
+              <a:pathLst>
+                <a:path w="9973994" h="5050303">
+                  <a:moveTo>
+                    <a:pt x="0" y="5036235"/>
+                  </a:moveTo>
+                  <a:cubicBezTo>
+                    <a:pt x="1651782" y="2516945"/>
+                    <a:pt x="3303564" y="-2344"/>
+                    <a:pt x="4965896" y="1"/>
+                  </a:cubicBezTo>
+                  <a:cubicBezTo>
+                    <a:pt x="6628228" y="2346"/>
+                    <a:pt x="8301111" y="2526324"/>
+                    <a:pt x="9973994" y="5050303"/>
+                  </a:cubicBezTo>
+                </a:path>
+              </a:pathLst>
+            </a:custGeom>
+            <a:noFill/>
+            <a:ln w="28575">
+              <a:solidFill>
+                <a:schemeClr val="tx1"/>
+              </a:solidFill>
+            </a:ln>
+          </p:spPr>
+          <p:style>
+            <a:lnRef idx="2">
+              <a:schemeClr val="accent1">
+                <a:shade val="15000"/>
+              </a:schemeClr>
+            </a:lnRef>
+            <a:fillRef idx="1">
+              <a:schemeClr val="accent1"/>
+            </a:fillRef>
+            <a:effectRef idx="0">
+              <a:schemeClr val="accent1"/>
+            </a:effectRef>
+            <a:fontRef idx="minor">
+              <a:schemeClr val="lt1"/>
+            </a:fontRef>
+          </p:style>
+          <p:txBody>
+            <a:bodyPr rtlCol="0" anchor="ctr"/>
+            <a:lstStyle/>
+            <a:p>
+              <a:pPr algn="ctr"/>
+              <a:endParaRPr kumimoji="1" lang="ja-JP" altLang="en-US"/>
+            </a:p>
+          </p:txBody>
+        </p:sp>
+        <p:sp>
+          <p:nvSpPr>
+            <p:cNvPr id="8" name="テキスト ボックス 7">
+              <a:extLst>
+                <a:ext uri="{FF2B5EF4-FFF2-40B4-BE49-F238E27FC236}">
+                  <a16:creationId xmlns:a16="http://schemas.microsoft.com/office/drawing/2014/main" id="{4A9A9CC8-98DA-14AE-7B9B-E1018BD16B46}"/>
+                </a:ext>
+              </a:extLst>
+            </p:cNvPr>
+            <p:cNvSpPr txBox="1"/>
+            <p:nvPr/>
+          </p:nvSpPr>
+          <p:spPr>
+            <a:xfrm>
+              <a:off x="8236894" y="7696872"/>
+              <a:ext cx="4058270" cy="584775"/>
+            </a:xfrm>
+            <a:prstGeom prst="rect">
+              <a:avLst/>
+            </a:prstGeom>
+            <a:noFill/>
+          </p:spPr>
+          <p:txBody>
+            <a:bodyPr wrap="square" rtlCol="0" anchor="ctr">
+              <a:spAutoFit/>
+            </a:bodyPr>
+            <a:lstStyle/>
+            <a:p>
+              <a:pPr algn="ctr"/>
+              <a:r>
+                <a:rPr kumimoji="1" lang="ja-JP" altLang="en-US" sz="3200">
+                  <a:latin typeface="Hiragino Sans W4" panose="020B0400000000000000" pitchFamily="34" charset="-128"/>
+                  <a:ea typeface="Hiragino Sans W4" panose="020B0400000000000000" pitchFamily="34" charset="-128"/>
+                </a:rPr>
+                <a:t>コーポラティズム度</a:t>
+              </a:r>
+            </a:p>
+          </p:txBody>
+        </p:sp>
+        <p:sp>
+          <p:nvSpPr>
+            <p:cNvPr id="9" name="テキスト ボックス 8">
+              <a:extLst>
+                <a:ext uri="{FF2B5EF4-FFF2-40B4-BE49-F238E27FC236}">
+                  <a16:creationId xmlns:a16="http://schemas.microsoft.com/office/drawing/2014/main" id="{F89D8454-4524-1FE3-FA57-29E5B7A8A228}"/>
+                </a:ext>
+              </a:extLst>
+            </p:cNvPr>
+            <p:cNvSpPr txBox="1"/>
+            <p:nvPr/>
+          </p:nvSpPr>
+          <p:spPr>
+            <a:xfrm>
+              <a:off x="516784" y="872373"/>
+              <a:ext cx="677108" cy="4365922"/>
+            </a:xfrm>
+            <a:prstGeom prst="rect">
+              <a:avLst/>
+            </a:prstGeom>
+            <a:noFill/>
+          </p:spPr>
+          <p:txBody>
+            <a:bodyPr vert="eaVert" wrap="square" rtlCol="0" anchor="ctr">
+              <a:spAutoFit/>
+            </a:bodyPr>
+            <a:lstStyle/>
+            <a:p>
+              <a:pPr algn="ctr"/>
+              <a:r>
+                <a:rPr kumimoji="1" lang="ja-JP" altLang="en-US" sz="3200">
+                  <a:latin typeface="Hiragino Sans W4" panose="020B0400000000000000" pitchFamily="34" charset="-128"/>
+                  <a:ea typeface="Hiragino Sans W4" panose="020B0400000000000000" pitchFamily="34" charset="-128"/>
+                </a:rPr>
+                <a:t>インフレ率・失業率</a:t>
+              </a:r>
+            </a:p>
+          </p:txBody>
+        </p:sp>
+      </p:grpSp>
+    </p:spTree>
+    <p:extLst>
+      <p:ext uri="{BB962C8B-B14F-4D97-AF65-F5344CB8AC3E}">
+        <p14:creationId xmlns:p14="http://schemas.microsoft.com/office/powerpoint/2010/main" val="2645956043"/>
       </p:ext>
     </p:extLst>
   </p:cSld>

</xml_diff>